<commit_message>
Deploy site from 165b1b10e30da10dbacc3b90ad804f8ea8c72bed 165b1b10e30da10dbacc3b90ad804f8ea8c72bed
</commit_message>
<xml_diff>
--- a/courses/research-in-finance/lectures/lecture-01-basics/slides.pptx
+++ b/courses/research-in-finance/lectures/lecture-01-basics/slides.pptx
@@ -5,7 +5,7 @@
     <p:sldMasterId id="2147483648" r:id="rId1"/>
   </p:sldMasterIdLst>
   <p:notesMasterIdLst>
-    <p:notesMasterId r:id="rId44"/>
+    <p:notesMasterId r:id="rId45"/>
   </p:notesMasterIdLst>
   <p:sldIdLst>
     <p:sldId id="256" r:id="rId2"/>
@@ -50,6 +50,7 @@
     <p:sldId id="295" r:id="rId41"/>
     <p:sldId id="296" r:id="rId42"/>
     <p:sldId id="297" r:id="rId43"/>
+    <p:sldId id="298" r:id="rId44"/>
   </p:sldIdLst>
   <p:sldSz cx="9144000" cy="5143500" type="screen16x9"/>
   <p:notesSz cx="6858000" cy="9144000"/>
@@ -14841,15 +14842,7 @@
             <a:pPr lvl="0"/>
             <a:r>
               <a:rPr/>
-              <a:t>James, G., Witten, D., Hastie, T., &amp; Tibshirani, R. (2021). </a:t>
-            </a:r>
-            <a:r>
-              <a:rPr i="1"/>
-              <a:t>An Introduction to Statistical Learning with applications in R</a:t>
-            </a:r>
-            <a:r>
-              <a:rPr/>
-              <a:t> (2nd ed.). Springer. Free PDF: </a:t>
+              <a:t>James et al. (2021) — free PDF and exercises at </a:t>
             </a:r>
             <a:r>
               <a:rPr>
@@ -14857,20 +14850,16 @@
               </a:rPr>
               <a:t>https://www.statlearning.com/</a:t>
             </a:r>
+            <a:r>
+              <a:rPr/>
+              <a:t>.</a:t>
+            </a:r>
           </a:p>
           <a:p>
             <a:pPr lvl="0"/>
             <a:r>
               <a:rPr/>
-              <a:t>Scheuch, C., Voigt, S., &amp; Weiss, P. (2023). </a:t>
-            </a:r>
-            <a:r>
-              <a:rPr i="1"/>
-              <a:t>Tidy Finance with R</a:t>
-            </a:r>
-            <a:r>
-              <a:rPr/>
-              <a:t>. Chapman &amp; Hall/CRC. Free: </a:t>
+              <a:t>Scheuch, Voigt, and Weiss (2023) — finance-specific tidyverse cookbook, free at </a:t>
             </a:r>
             <a:r>
               <a:rPr>
@@ -14878,20 +14867,16 @@
               </a:rPr>
               <a:t>https://www.tidy-finance.org/r/</a:t>
             </a:r>
+            <a:r>
+              <a:rPr/>
+              <a:t>.</a:t>
+            </a:r>
           </a:p>
           <a:p>
             <a:pPr lvl="0"/>
             <a:r>
               <a:rPr/>
-              <a:t>Wickham, H., &amp; Çetinkaya-Rundel, M. (2023). </a:t>
-            </a:r>
-            <a:r>
-              <a:rPr i="1"/>
-              <a:t>R for Data Science</a:t>
-            </a:r>
-            <a:r>
-              <a:rPr/>
-              <a:t> (2nd ed.). O’Reilly. Free: </a:t>
+              <a:t>Wickham and Çetinkaya-Rundel (2023) — second edition, free at </a:t>
             </a:r>
             <a:r>
               <a:rPr>
@@ -14899,26 +14884,16 @@
               </a:rPr>
               <a:t>https://r4ds.hadley.nz/</a:t>
             </a:r>
+            <a:r>
+              <a:rPr/>
+              <a:t>.</a:t>
+            </a:r>
           </a:p>
           <a:p>
             <a:pPr lvl="0"/>
             <a:r>
               <a:rPr/>
-              <a:t>Kaggle Discussions (2021). </a:t>
-            </a:r>
-            <a:r>
-              <a:rPr i="1"/>
-              <a:t>List of free R books</a:t>
-            </a:r>
-            <a:r>
-              <a:rPr/>
-              <a:t>. </a:t>
-            </a:r>
-            <a:r>
-              <a:rPr>
-                <a:hlinkClick r:id="rId5"/>
-              </a:rPr>
-              <a:t>https://www.kaggle.com/discussions/general/274029</a:t>
+              <a:t>Kaggle Discussions (2021) — community-curated list of additional free R books.</a:t>
             </a:r>
           </a:p>
         </p:txBody>
@@ -15253,6 +15228,169 @@
             </a:r>
             <a:r>
               <a:rPr sz="2000"/>
+              <a:t>.</a:t>
+            </a:r>
+          </a:p>
+        </p:txBody>
+      </p:sp>
+    </p:spTree>
+  </p:cSld>
+</p:sld>
+</file>
+
+<file path=ppt/slides/slide43.xml><?xml version="1.0" encoding="utf-8"?>
+<p:sld xmlns:a="http://schemas.openxmlformats.org/drawingml/2006/main" xmlns:r="http://schemas.openxmlformats.org/officeDocument/2006/relationships" xmlns:p="http://schemas.openxmlformats.org/presentationml/2006/main">
+  <p:cSld>
+    <p:spTree>
+      <p:nvGrpSpPr>
+        <p:cNvPr id="1" name=""/>
+        <p:cNvGrpSpPr/>
+        <p:nvPr/>
+      </p:nvGrpSpPr>
+      <p:grpSpPr>
+        <a:xfrm>
+          <a:off x="0" y="0"/>
+          <a:ext cx="0" cy="0"/>
+          <a:chOff x="0" y="0"/>
+          <a:chExt cx="0" cy="0"/>
+        </a:xfrm>
+      </p:grpSpPr>
+      <p:sp>
+        <p:nvSpPr>
+          <p:cNvPr id="2" name="Title 1"/>
+          <p:cNvSpPr>
+            <a:spLocks noGrp="1"/>
+          </p:cNvSpPr>
+          <p:nvPr>
+            <p:ph type="title"/>
+          </p:nvPr>
+        </p:nvSpPr>
+        <p:spPr/>
+        <p:txBody>
+          <a:bodyPr/>
+          <a:lstStyle/>
+          <a:p>
+            <a:pPr lvl="0" indent="0" marL="0">
+              <a:buNone/>
+            </a:pPr>
+            <a:r>
+              <a:rPr/>
+              <a:t>References</a:t>
+            </a:r>
+          </a:p>
+        </p:txBody>
+      </p:sp>
+      <p:sp>
+        <p:nvSpPr>
+          <p:cNvPr id="3" name="Content Placeholder 2"/>
+          <p:cNvSpPr>
+            <a:spLocks noGrp="1"/>
+          </p:cNvSpPr>
+          <p:nvPr>
+            <p:ph idx="1"/>
+          </p:nvPr>
+        </p:nvSpPr>
+        <p:spPr/>
+        <p:txBody>
+          <a:bodyPr/>
+          <a:lstStyle/>
+          <a:p>
+            <a:pPr lvl="0" indent="0" marL="0">
+              <a:buNone/>
+            </a:pPr>
+            <a:r>
+              <a:rPr/>
+              <a:t>James, Gareth, Daniela Witten, Trevor Hastie, and Robert Tibshirani. 2021. </a:t>
+            </a:r>
+            <a:r>
+              <a:rPr i="1"/>
+              <a:t>An Introduction to Statistical Learning with Applications in R</a:t>
+            </a:r>
+            <a:r>
+              <a:rPr/>
+              <a:t>. 2nd ed. New York, NY: Springer. </a:t>
+            </a:r>
+            <a:r>
+              <a:rPr>
+                <a:hlinkClick r:id="rId2"/>
+              </a:rPr>
+              <a:t>https://www.statlearning.com/</a:t>
+            </a:r>
+            <a:r>
+              <a:rPr/>
+              <a:t>.</a:t>
+            </a:r>
+          </a:p>
+          <a:p>
+            <a:pPr lvl="0" indent="0" marL="0">
+              <a:buNone/>
+            </a:pPr>
+            <a:r>
+              <a:rPr/>
+              <a:t>Kaggle Discussions. 2021. “List of Free R Books.” </a:t>
+            </a:r>
+            <a:r>
+              <a:rPr>
+                <a:hlinkClick r:id="rId3"/>
+              </a:rPr>
+              <a:t>https://www.kaggle.com/discussions/general/274029</a:t>
+            </a:r>
+            <a:r>
+              <a:rPr/>
+              <a:t>.</a:t>
+            </a:r>
+          </a:p>
+          <a:p>
+            <a:pPr lvl="0" indent="0" marL="0">
+              <a:buNone/>
+            </a:pPr>
+            <a:r>
+              <a:rPr/>
+              <a:t>Scheuch, Christoph, Stefan Voigt, and Patrick Weiss. 2023. </a:t>
+            </a:r>
+            <a:r>
+              <a:rPr i="1"/>
+              <a:t>Tidy Finance with R</a:t>
+            </a:r>
+            <a:r>
+              <a:rPr/>
+              <a:t>. Chapman &amp; Hall/CRC. </a:t>
+            </a:r>
+            <a:r>
+              <a:rPr>
+                <a:hlinkClick r:id="rId4"/>
+              </a:rPr>
+              <a:t>https://www.tidy-finance.org/r/</a:t>
+            </a:r>
+            <a:r>
+              <a:rPr/>
+              <a:t>.</a:t>
+            </a:r>
+          </a:p>
+          <a:p>
+            <a:pPr lvl="0" indent="0" marL="0">
+              <a:buNone/>
+            </a:pPr>
+            <a:r>
+              <a:rPr/>
+              <a:t>Wickham, Hadley, and Mine Çetinkaya-Rundel. 2023. </a:t>
+            </a:r>
+            <a:r>
+              <a:rPr i="1"/>
+              <a:t>R for Data Science</a:t>
+            </a:r>
+            <a:r>
+              <a:rPr/>
+              <a:t>. 2nd ed. O’Reilly. </a:t>
+            </a:r>
+            <a:r>
+              <a:rPr>
+                <a:hlinkClick r:id="rId5"/>
+              </a:rPr>
+              <a:t>https://r4ds.hadley.nz/</a:t>
+            </a:r>
+            <a:r>
+              <a:rPr/>
               <a:t>.</a:t>
             </a:r>
           </a:p>

</xml_diff>

<commit_message>
Deploy site from 60fe69ecacc013b719a09034144e07ebf2ba0213 60fe69ecacc013b719a09034144e07ebf2ba0213
</commit_message>
<xml_diff>
--- a/courses/research-in-finance/lectures/lecture-01-basics/slides.pptx
+++ b/courses/research-in-finance/lectures/lecture-01-basics/slides.pptx
@@ -7,52 +7,7 @@
   <p:notesMasterIdLst>
     <p:notesMasterId r:id="rId45"/>
   </p:notesMasterIdLst>
-  <p:sldIdLst>
-    <p:sldId id="256" r:id="rId2"/>
-    <p:sldId id="257" r:id="rId3"/>
-    <p:sldId id="258" r:id="rId4"/>
-    <p:sldId id="259" r:id="rId5"/>
-    <p:sldId id="260" r:id="rId6"/>
-    <p:sldId id="261" r:id="rId7"/>
-    <p:sldId id="262" r:id="rId8"/>
-    <p:sldId id="263" r:id="rId9"/>
-    <p:sldId id="264" r:id="rId10"/>
-    <p:sldId id="265" r:id="rId11"/>
-    <p:sldId id="266" r:id="rId12"/>
-    <p:sldId id="267" r:id="rId13"/>
-    <p:sldId id="268" r:id="rId14"/>
-    <p:sldId id="269" r:id="rId15"/>
-    <p:sldId id="270" r:id="rId16"/>
-    <p:sldId id="271" r:id="rId17"/>
-    <p:sldId id="272" r:id="rId18"/>
-    <p:sldId id="273" r:id="rId19"/>
-    <p:sldId id="274" r:id="rId20"/>
-    <p:sldId id="275" r:id="rId21"/>
-    <p:sldId id="276" r:id="rId22"/>
-    <p:sldId id="277" r:id="rId23"/>
-    <p:sldId id="278" r:id="rId24"/>
-    <p:sldId id="279" r:id="rId25"/>
-    <p:sldId id="280" r:id="rId26"/>
-    <p:sldId id="281" r:id="rId27"/>
-    <p:sldId id="282" r:id="rId28"/>
-    <p:sldId id="283" r:id="rId29"/>
-    <p:sldId id="284" r:id="rId30"/>
-    <p:sldId id="285" r:id="rId31"/>
-    <p:sldId id="286" r:id="rId32"/>
-    <p:sldId id="287" r:id="rId33"/>
-    <p:sldId id="288" r:id="rId34"/>
-    <p:sldId id="289" r:id="rId35"/>
-    <p:sldId id="290" r:id="rId36"/>
-    <p:sldId id="291" r:id="rId37"/>
-    <p:sldId id="292" r:id="rId38"/>
-    <p:sldId id="293" r:id="rId39"/>
-    <p:sldId id="294" r:id="rId40"/>
-    <p:sldId id="295" r:id="rId41"/>
-    <p:sldId id="296" r:id="rId42"/>
-    <p:sldId id="297" r:id="rId43"/>
-    <p:sldId id="298" r:id="rId44"/>
-  </p:sldIdLst>
-  <p:sldSz cx="9144000" cy="5143500" type="screen16x9"/>
+  <p:sldSz cx="12191695" cy="6858000" type="screen4x3"/>
   <p:notesSz cx="6858000" cy="9144000"/>
   <p:defaultTextStyle>
     <a:defPPr>
@@ -149,22 +104,6 @@
       </a:defRPr>
     </a:lvl9pPr>
   </p:defaultTextStyle>
-  <p:extLst>
-    <p:ext uri="{EFAFB233-063F-42B5-8137-9DF3F51BA10A}">
-      <p15:sldGuideLst xmlns:p15="http://schemas.microsoft.com/office/powerpoint/2012/main">
-        <p15:guide id="1" orient="horz" pos="1620" userDrawn="1">
-          <p15:clr>
-            <a:srgbClr val="A4A3A4"/>
-          </p15:clr>
-        </p15:guide>
-        <p15:guide id="2" pos="2880" userDrawn="1">
-          <p15:clr>
-            <a:srgbClr val="A4A3A4"/>
-          </p15:clr>
-        </p15:guide>
-      </p15:sldGuideLst>
-    </p:ext>
-  </p:extLst>
 </p:presentation>
 </file>
 
@@ -710,8 +649,8 @@
         </p:nvSpPr>
         <p:spPr>
           <a:xfrm>
-            <a:off x="685800" y="1597819"/>
-            <a:ext cx="7772400" cy="1102519"/>
+            <a:off x="685800" y="2130425"/>
+            <a:ext cx="7772400" cy="1470025"/>
           </a:xfrm>
         </p:spPr>
         <p:txBody>
@@ -719,9 +658,14 @@
           <a:lstStyle/>
           <a:p>
             <a:r>
-              <a:rPr lang="en-US"/>
+              <a:rPr lang="en-US" smtClean="0">
+                <a:solidFill>
+                  <a:srgbClr val="111111"/>
+                </a:solidFill>
+              </a:rPr>
               <a:t>Click to edit Master title style</a:t>
             </a:r>
+            <a:endParaRPr lang="en-US"/>
           </a:p>
         </p:txBody>
       </p:sp>
@@ -737,8 +681,8 @@
         </p:nvSpPr>
         <p:spPr>
           <a:xfrm>
-            <a:off x="1371600" y="2914650"/>
-            <a:ext cx="6400800" cy="1314450"/>
+            <a:off x="1371600" y="3886200"/>
+            <a:ext cx="6400800" cy="1752600"/>
           </a:xfrm>
         </p:spPr>
         <p:txBody>
@@ -748,98 +692,85 @@
               <a:buNone/>
               <a:defRPr>
                 <a:solidFill>
-                  <a:schemeClr val="tx1">
-                    <a:tint val="75000"/>
-                  </a:schemeClr>
+                  <a:srgbClr val="111111"/>
                 </a:solidFill>
               </a:defRPr>
             </a:lvl1pPr>
-            <a:lvl2pPr marL="342900" indent="0" algn="ctr">
+            <a:lvl2pPr marL="457200" indent="0" algn="ctr">
               <a:buNone/>
               <a:defRPr>
                 <a:solidFill>
-                  <a:schemeClr val="tx1">
-                    <a:tint val="75000"/>
-                  </a:schemeClr>
+                  <a:srgbClr val="111111"/>
                 </a:solidFill>
               </a:defRPr>
             </a:lvl2pPr>
-            <a:lvl3pPr marL="685800" indent="0" algn="ctr">
+            <a:lvl3pPr marL="914400" indent="0" algn="ctr">
               <a:buNone/>
               <a:defRPr>
                 <a:solidFill>
-                  <a:schemeClr val="tx1">
-                    <a:tint val="75000"/>
-                  </a:schemeClr>
+                  <a:srgbClr val="111111"/>
                 </a:solidFill>
               </a:defRPr>
             </a:lvl3pPr>
-            <a:lvl4pPr marL="1028700" indent="0" algn="ctr">
+            <a:lvl4pPr marL="1371600" indent="0" algn="ctr">
               <a:buNone/>
               <a:defRPr>
                 <a:solidFill>
-                  <a:schemeClr val="tx1">
-                    <a:tint val="75000"/>
-                  </a:schemeClr>
+                  <a:srgbClr val="111111"/>
                 </a:solidFill>
               </a:defRPr>
             </a:lvl4pPr>
-            <a:lvl5pPr marL="1371600" indent="0" algn="ctr">
+            <a:lvl5pPr marL="1828800" indent="0" algn="ctr">
               <a:buNone/>
               <a:defRPr>
                 <a:solidFill>
-                  <a:schemeClr val="tx1">
-                    <a:tint val="75000"/>
-                  </a:schemeClr>
+                  <a:srgbClr val="111111"/>
                 </a:solidFill>
               </a:defRPr>
             </a:lvl5pPr>
-            <a:lvl6pPr marL="1714500" indent="0" algn="ctr">
+            <a:lvl6pPr marL="2286000" indent="0" algn="ctr">
               <a:buNone/>
               <a:defRPr>
                 <a:solidFill>
-                  <a:schemeClr val="tx1">
-                    <a:tint val="75000"/>
-                  </a:schemeClr>
+                  <a:srgbClr val="111111"/>
                 </a:solidFill>
               </a:defRPr>
             </a:lvl6pPr>
-            <a:lvl7pPr marL="2057400" indent="0" algn="ctr">
+            <a:lvl7pPr marL="2743200" indent="0" algn="ctr">
               <a:buNone/>
               <a:defRPr>
                 <a:solidFill>
-                  <a:schemeClr val="tx1">
-                    <a:tint val="75000"/>
-                  </a:schemeClr>
+                  <a:srgbClr val="111111"/>
                 </a:solidFill>
               </a:defRPr>
             </a:lvl7pPr>
-            <a:lvl8pPr marL="2400300" indent="0" algn="ctr">
+            <a:lvl8pPr marL="3200400" indent="0" algn="ctr">
               <a:buNone/>
               <a:defRPr>
                 <a:solidFill>
-                  <a:schemeClr val="tx1">
-                    <a:tint val="75000"/>
-                  </a:schemeClr>
+                  <a:srgbClr val="111111"/>
                 </a:solidFill>
               </a:defRPr>
             </a:lvl8pPr>
-            <a:lvl9pPr marL="2743200" indent="0" algn="ctr">
+            <a:lvl9pPr marL="3657600" indent="0" algn="ctr">
               <a:buNone/>
               <a:defRPr>
                 <a:solidFill>
-                  <a:schemeClr val="tx1">
-                    <a:tint val="75000"/>
-                  </a:schemeClr>
+                  <a:srgbClr val="111111"/>
                 </a:solidFill>
               </a:defRPr>
             </a:lvl9pPr>
           </a:lstStyle>
           <a:p>
             <a:r>
-              <a:rPr lang="en-US"/>
+              <a:rPr lang="en-US" smtClean="0">
+                <a:solidFill>
+                  <a:srgbClr val="111111"/>
+                </a:solidFill>
+              </a:rPr>
               <a:t>Click to edit Master subtitle style</a:t>
             </a:r>
+            <a:endParaRPr lang="en-US"/>
           </a:p>
         </p:txBody>
       </p:sp>
@@ -858,9 +789,13 @@
           <a:bodyPr/>
           <a:lstStyle/>
           <a:p>
-            <a:fld id="{241EB5C9-1307-BA42-ABA2-0BC069CD8E7F}" type="datetimeFigureOut">
-              <a:rPr lang="en-US" smtClean="0"/>
-              <a:t>1/2/22</a:t>
+            <a:fld id="{5BCAD085-E8A6-8845-BD4E-CB4CCA059FC4}" type="datetimeFigureOut">
+              <a:rPr lang="en-US" smtClean="0">
+                <a:solidFill>
+                  <a:srgbClr val="111111"/>
+                </a:solidFill>
+              </a:rPr>
+              <a:t>1/27/13</a:t>
             </a:fld>
             <a:endParaRPr lang="en-US"/>
           </a:p>
@@ -900,8 +835,12 @@
           <a:bodyPr/>
           <a:lstStyle/>
           <a:p>
-            <a:fld id="{C5EF2332-01BF-834F-8236-50238282D533}" type="slidenum">
-              <a:rPr lang="en-US" smtClean="0"/>
+            <a:fld id="{C1FF6DA9-008F-8B48-92A6-B652298478BF}" type="slidenum">
+              <a:rPr lang="en-US" smtClean="0">
+                <a:solidFill>
+                  <a:srgbClr val="111111"/>
+                </a:solidFill>
+              </a:rPr>
               <a:t>‹#›</a:t>
             </a:fld>
             <a:endParaRPr lang="en-US"/>
@@ -911,7 +850,7 @@
     </p:spTree>
     <p:extLst>
       <p:ext uri="{BB962C8B-B14F-4D97-AF65-F5344CB8AC3E}">
-        <p14:creationId xmlns:p14="http://schemas.microsoft.com/office/powerpoint/2010/main" val="1444357513"/>
+        <p14:creationId xmlns:p14="http://schemas.microsoft.com/office/powerpoint/2010/main" val="3168075583"/>
       </p:ext>
     </p:extLst>
   </p:cSld>
@@ -954,9 +893,14 @@
           <a:lstStyle/>
           <a:p>
             <a:r>
-              <a:rPr lang="en-US"/>
+              <a:rPr lang="en-US" smtClean="0">
+                <a:solidFill>
+                  <a:srgbClr val="111111"/>
+                </a:solidFill>
+              </a:rPr>
               <a:t>Click to edit Master title style</a:t>
             </a:r>
+            <a:endParaRPr lang="en-US"/>
           </a:p>
         </p:txBody>
       </p:sp>
@@ -977,37 +921,58 @@
           <a:p>
             <a:pPr lvl="0"/>
             <a:r>
-              <a:rPr lang="en-US"/>
+              <a:rPr lang="en-US" smtClean="0">
+                <a:solidFill>
+                  <a:srgbClr val="111111"/>
+                </a:solidFill>
+              </a:rPr>
               <a:t>Click to edit Master text styles</a:t>
             </a:r>
           </a:p>
           <a:p>
             <a:pPr lvl="1"/>
             <a:r>
-              <a:rPr lang="en-US"/>
+              <a:rPr lang="en-US" smtClean="0">
+                <a:solidFill>
+                  <a:srgbClr val="111111"/>
+                </a:solidFill>
+              </a:rPr>
               <a:t>Second level</a:t>
             </a:r>
           </a:p>
           <a:p>
             <a:pPr lvl="2"/>
             <a:r>
-              <a:rPr lang="en-US"/>
+              <a:rPr lang="en-US" smtClean="0">
+                <a:solidFill>
+                  <a:srgbClr val="111111"/>
+                </a:solidFill>
+              </a:rPr>
               <a:t>Third level</a:t>
             </a:r>
           </a:p>
           <a:p>
             <a:pPr lvl="3"/>
             <a:r>
-              <a:rPr lang="en-US"/>
+              <a:rPr lang="en-US" smtClean="0">
+                <a:solidFill>
+                  <a:srgbClr val="111111"/>
+                </a:solidFill>
+              </a:rPr>
               <a:t>Fourth level</a:t>
             </a:r>
           </a:p>
           <a:p>
             <a:pPr lvl="4"/>
             <a:r>
-              <a:rPr lang="en-US"/>
+              <a:rPr lang="en-US" smtClean="0">
+                <a:solidFill>
+                  <a:srgbClr val="111111"/>
+                </a:solidFill>
+              </a:rPr>
               <a:t>Fifth level</a:t>
             </a:r>
+            <a:endParaRPr lang="en-US"/>
           </a:p>
         </p:txBody>
       </p:sp>
@@ -1026,9 +991,13 @@
           <a:bodyPr/>
           <a:lstStyle/>
           <a:p>
-            <a:fld id="{241EB5C9-1307-BA42-ABA2-0BC069CD8E7F}" type="datetimeFigureOut">
-              <a:rPr lang="en-US" smtClean="0"/>
-              <a:t>1/2/22</a:t>
+            <a:fld id="{5BCAD085-E8A6-8845-BD4E-CB4CCA059FC4}" type="datetimeFigureOut">
+              <a:rPr lang="en-US" smtClean="0">
+                <a:solidFill>
+                  <a:srgbClr val="111111"/>
+                </a:solidFill>
+              </a:rPr>
+              <a:t>1/27/13</a:t>
             </a:fld>
             <a:endParaRPr lang="en-US"/>
           </a:p>
@@ -1068,8 +1037,12 @@
           <a:bodyPr/>
           <a:lstStyle/>
           <a:p>
-            <a:fld id="{C5EF2332-01BF-834F-8236-50238282D533}" type="slidenum">
-              <a:rPr lang="en-US" smtClean="0"/>
+            <a:fld id="{C1FF6DA9-008F-8B48-92A6-B652298478BF}" type="slidenum">
+              <a:rPr lang="en-US" smtClean="0">
+                <a:solidFill>
+                  <a:srgbClr val="111111"/>
+                </a:solidFill>
+              </a:rPr>
               <a:t>‹#›</a:t>
             </a:fld>
             <a:endParaRPr lang="en-US"/>
@@ -1079,7 +1052,7 @@
     </p:spTree>
     <p:extLst>
       <p:ext uri="{BB962C8B-B14F-4D97-AF65-F5344CB8AC3E}">
-        <p14:creationId xmlns:p14="http://schemas.microsoft.com/office/powerpoint/2010/main" val="313914798"/>
+        <p14:creationId xmlns:p14="http://schemas.microsoft.com/office/powerpoint/2010/main" val="2910927964"/>
       </p:ext>
     </p:extLst>
   </p:cSld>
@@ -1118,8 +1091,8 @@
         </p:nvSpPr>
         <p:spPr>
           <a:xfrm>
-            <a:off x="6629400" y="205979"/>
-            <a:ext cx="2057400" cy="4388644"/>
+            <a:off x="6629400" y="274638"/>
+            <a:ext cx="2057400" cy="5851525"/>
           </a:xfrm>
         </p:spPr>
         <p:txBody>
@@ -1127,9 +1100,14 @@
           <a:lstStyle/>
           <a:p>
             <a:r>
-              <a:rPr lang="en-US"/>
+              <a:rPr lang="en-US" smtClean="0">
+                <a:solidFill>
+                  <a:srgbClr val="111111"/>
+                </a:solidFill>
+              </a:rPr>
               <a:t>Click to edit Master title style</a:t>
             </a:r>
+            <a:endParaRPr lang="en-US"/>
           </a:p>
         </p:txBody>
       </p:sp>
@@ -1145,8 +1123,8 @@
         </p:nvSpPr>
         <p:spPr>
           <a:xfrm>
-            <a:off x="457200" y="205979"/>
-            <a:ext cx="6019800" cy="4388644"/>
+            <a:off x="457200" y="274638"/>
+            <a:ext cx="6019800" cy="5851525"/>
           </a:xfrm>
         </p:spPr>
         <p:txBody>
@@ -1155,37 +1133,58 @@
           <a:p>
             <a:pPr lvl="0"/>
             <a:r>
-              <a:rPr lang="en-US"/>
+              <a:rPr lang="en-US" smtClean="0">
+                <a:solidFill>
+                  <a:srgbClr val="111111"/>
+                </a:solidFill>
+              </a:rPr>
               <a:t>Click to edit Master text styles</a:t>
             </a:r>
           </a:p>
           <a:p>
             <a:pPr lvl="1"/>
             <a:r>
-              <a:rPr lang="en-US"/>
+              <a:rPr lang="en-US" smtClean="0">
+                <a:solidFill>
+                  <a:srgbClr val="111111"/>
+                </a:solidFill>
+              </a:rPr>
               <a:t>Second level</a:t>
             </a:r>
           </a:p>
           <a:p>
             <a:pPr lvl="2"/>
             <a:r>
-              <a:rPr lang="en-US"/>
+              <a:rPr lang="en-US" smtClean="0">
+                <a:solidFill>
+                  <a:srgbClr val="111111"/>
+                </a:solidFill>
+              </a:rPr>
               <a:t>Third level</a:t>
             </a:r>
           </a:p>
           <a:p>
             <a:pPr lvl="3"/>
             <a:r>
-              <a:rPr lang="en-US"/>
+              <a:rPr lang="en-US" smtClean="0">
+                <a:solidFill>
+                  <a:srgbClr val="111111"/>
+                </a:solidFill>
+              </a:rPr>
               <a:t>Fourth level</a:t>
             </a:r>
           </a:p>
           <a:p>
             <a:pPr lvl="4"/>
             <a:r>
-              <a:rPr lang="en-US"/>
+              <a:rPr lang="en-US" smtClean="0">
+                <a:solidFill>
+                  <a:srgbClr val="111111"/>
+                </a:solidFill>
+              </a:rPr>
               <a:t>Fifth level</a:t>
             </a:r>
+            <a:endParaRPr lang="en-US"/>
           </a:p>
         </p:txBody>
       </p:sp>
@@ -1204,9 +1203,13 @@
           <a:bodyPr/>
           <a:lstStyle/>
           <a:p>
-            <a:fld id="{241EB5C9-1307-BA42-ABA2-0BC069CD8E7F}" type="datetimeFigureOut">
-              <a:rPr lang="en-US" smtClean="0"/>
-              <a:t>1/2/22</a:t>
+            <a:fld id="{5BCAD085-E8A6-8845-BD4E-CB4CCA059FC4}" type="datetimeFigureOut">
+              <a:rPr lang="en-US" smtClean="0">
+                <a:solidFill>
+                  <a:srgbClr val="111111"/>
+                </a:solidFill>
+              </a:rPr>
+              <a:t>1/27/13</a:t>
             </a:fld>
             <a:endParaRPr lang="en-US"/>
           </a:p>
@@ -1246,8 +1249,12 @@
           <a:bodyPr/>
           <a:lstStyle/>
           <a:p>
-            <a:fld id="{C5EF2332-01BF-834F-8236-50238282D533}" type="slidenum">
-              <a:rPr lang="en-US" smtClean="0"/>
+            <a:fld id="{C1FF6DA9-008F-8B48-92A6-B652298478BF}" type="slidenum">
+              <a:rPr lang="en-US" smtClean="0">
+                <a:solidFill>
+                  <a:srgbClr val="111111"/>
+                </a:solidFill>
+              </a:rPr>
               <a:t>‹#›</a:t>
             </a:fld>
             <a:endParaRPr lang="en-US"/>
@@ -1257,7 +1264,7 @@
     </p:spTree>
     <p:extLst>
       <p:ext uri="{BB962C8B-B14F-4D97-AF65-F5344CB8AC3E}">
-        <p14:creationId xmlns:p14="http://schemas.microsoft.com/office/powerpoint/2010/main" val="2581529045"/>
+        <p14:creationId xmlns:p14="http://schemas.microsoft.com/office/powerpoint/2010/main" val="3612223792"/>
       </p:ext>
     </p:extLst>
   </p:cSld>
@@ -1300,9 +1307,14 @@
           <a:lstStyle/>
           <a:p>
             <a:r>
-              <a:rPr lang="en-US"/>
+              <a:rPr lang="en-US" smtClean="0">
+                <a:solidFill>
+                  <a:srgbClr val="111111"/>
+                </a:solidFill>
+              </a:rPr>
               <a:t>Click to edit Master title style</a:t>
             </a:r>
+            <a:endParaRPr lang="en-US"/>
           </a:p>
         </p:txBody>
       </p:sp>
@@ -1323,37 +1335,58 @@
           <a:p>
             <a:pPr lvl="0"/>
             <a:r>
-              <a:rPr lang="en-US"/>
+              <a:rPr lang="en-US" smtClean="0">
+                <a:solidFill>
+                  <a:srgbClr val="111111"/>
+                </a:solidFill>
+              </a:rPr>
               <a:t>Click to edit Master text styles</a:t>
             </a:r>
           </a:p>
           <a:p>
             <a:pPr lvl="1"/>
             <a:r>
-              <a:rPr lang="en-US"/>
+              <a:rPr lang="en-US" smtClean="0">
+                <a:solidFill>
+                  <a:srgbClr val="111111"/>
+                </a:solidFill>
+              </a:rPr>
               <a:t>Second level</a:t>
             </a:r>
           </a:p>
           <a:p>
             <a:pPr lvl="2"/>
             <a:r>
-              <a:rPr lang="en-US"/>
+              <a:rPr lang="en-US" smtClean="0">
+                <a:solidFill>
+                  <a:srgbClr val="111111"/>
+                </a:solidFill>
+              </a:rPr>
               <a:t>Third level</a:t>
             </a:r>
           </a:p>
           <a:p>
             <a:pPr lvl="3"/>
             <a:r>
-              <a:rPr lang="en-US"/>
+              <a:rPr lang="en-US" smtClean="0">
+                <a:solidFill>
+                  <a:srgbClr val="111111"/>
+                </a:solidFill>
+              </a:rPr>
               <a:t>Fourth level</a:t>
             </a:r>
           </a:p>
           <a:p>
             <a:pPr lvl="4"/>
             <a:r>
-              <a:rPr lang="en-US"/>
+              <a:rPr lang="en-US" smtClean="0">
+                <a:solidFill>
+                  <a:srgbClr val="111111"/>
+                </a:solidFill>
+              </a:rPr>
               <a:t>Fifth level</a:t>
             </a:r>
+            <a:endParaRPr lang="en-US"/>
           </a:p>
         </p:txBody>
       </p:sp>
@@ -1372,9 +1405,13 @@
           <a:bodyPr/>
           <a:lstStyle/>
           <a:p>
-            <a:fld id="{241EB5C9-1307-BA42-ABA2-0BC069CD8E7F}" type="datetimeFigureOut">
-              <a:rPr lang="en-US" smtClean="0"/>
-              <a:t>1/2/22</a:t>
+            <a:fld id="{5BCAD085-E8A6-8845-BD4E-CB4CCA059FC4}" type="datetimeFigureOut">
+              <a:rPr lang="en-US" smtClean="0">
+                <a:solidFill>
+                  <a:srgbClr val="111111"/>
+                </a:solidFill>
+              </a:rPr>
+              <a:t>1/27/13</a:t>
             </a:fld>
             <a:endParaRPr lang="en-US"/>
           </a:p>
@@ -1414,8 +1451,12 @@
           <a:bodyPr/>
           <a:lstStyle/>
           <a:p>
-            <a:fld id="{C5EF2332-01BF-834F-8236-50238282D533}" type="slidenum">
-              <a:rPr lang="en-US" smtClean="0"/>
+            <a:fld id="{C1FF6DA9-008F-8B48-92A6-B652298478BF}" type="slidenum">
+              <a:rPr lang="en-US" smtClean="0">
+                <a:solidFill>
+                  <a:srgbClr val="111111"/>
+                </a:solidFill>
+              </a:rPr>
               <a:t>‹#›</a:t>
             </a:fld>
             <a:endParaRPr lang="en-US"/>
@@ -1425,7 +1466,7 @@
     </p:spTree>
     <p:extLst>
       <p:ext uri="{BB962C8B-B14F-4D97-AF65-F5344CB8AC3E}">
-        <p14:creationId xmlns:p14="http://schemas.microsoft.com/office/powerpoint/2010/main" val="338346009"/>
+        <p14:creationId xmlns:p14="http://schemas.microsoft.com/office/powerpoint/2010/main" val="2614314258"/>
       </p:ext>
     </p:extLst>
   </p:cSld>
@@ -1464,22 +1505,31 @@
         </p:nvSpPr>
         <p:spPr>
           <a:xfrm>
-            <a:off x="722313" y="3305176"/>
-            <a:ext cx="7772400" cy="1021556"/>
+            <a:off x="722313" y="4406900"/>
+            <a:ext cx="7772400" cy="1362075"/>
           </a:xfrm>
         </p:spPr>
         <p:txBody>
           <a:bodyPr anchor="t"/>
           <a:lstStyle>
             <a:lvl1pPr algn="l">
-              <a:defRPr sz="3000" b="1" cap="all"/>
+              <a:defRPr sz="4000" b="1" cap="all">
+                <a:solidFill>
+                  <a:srgbClr val="111111"/>
+                </a:solidFill>
+              </a:defRPr>
             </a:lvl1pPr>
           </a:lstStyle>
           <a:p>
             <a:r>
-              <a:rPr lang="en-US"/>
+              <a:rPr lang="en-US" smtClean="0">
+                <a:solidFill>
+                  <a:srgbClr val="111111"/>
+                </a:solidFill>
+              </a:rPr>
               <a:t>Click to edit Master title style</a:t>
             </a:r>
+            <a:endParaRPr lang="en-US"/>
           </a:p>
         </p:txBody>
       </p:sp>
@@ -1495,8 +1545,8 @@
         </p:nvSpPr>
         <p:spPr>
           <a:xfrm>
-            <a:off x="722313" y="2180035"/>
-            <a:ext cx="7772400" cy="1125140"/>
+            <a:off x="722313" y="2906713"/>
+            <a:ext cx="7772400" cy="1500187"/>
           </a:xfrm>
         </p:spPr>
         <p:txBody>
@@ -1504,91 +1554,73 @@
           <a:lstStyle>
             <a:lvl1pPr marL="0" indent="0">
               <a:buNone/>
-              <a:defRPr sz="1500">
-                <a:solidFill>
-                  <a:schemeClr val="tx1">
-                    <a:tint val="75000"/>
-                  </a:schemeClr>
+              <a:defRPr sz="2000">
+                <a:solidFill>
+                  <a:srgbClr val="111111"/>
                 </a:solidFill>
               </a:defRPr>
             </a:lvl1pPr>
-            <a:lvl2pPr marL="342900" indent="0">
+            <a:lvl2pPr marL="457200" indent="0">
               <a:buNone/>
-              <a:defRPr sz="1350">
-                <a:solidFill>
-                  <a:schemeClr val="tx1">
-                    <a:tint val="75000"/>
-                  </a:schemeClr>
+              <a:defRPr sz="1800">
+                <a:solidFill>
+                  <a:srgbClr val="111111"/>
                 </a:solidFill>
               </a:defRPr>
             </a:lvl2pPr>
-            <a:lvl3pPr marL="685800" indent="0">
+            <a:lvl3pPr marL="914400" indent="0">
               <a:buNone/>
-              <a:defRPr sz="1200">
-                <a:solidFill>
-                  <a:schemeClr val="tx1">
-                    <a:tint val="75000"/>
-                  </a:schemeClr>
+              <a:defRPr sz="1600">
+                <a:solidFill>
+                  <a:srgbClr val="111111"/>
                 </a:solidFill>
               </a:defRPr>
             </a:lvl3pPr>
-            <a:lvl4pPr marL="1028700" indent="0">
+            <a:lvl4pPr marL="1371600" indent="0">
               <a:buNone/>
-              <a:defRPr sz="1050">
-                <a:solidFill>
-                  <a:schemeClr val="tx1">
-                    <a:tint val="75000"/>
-                  </a:schemeClr>
+              <a:defRPr sz="1400">
+                <a:solidFill>
+                  <a:srgbClr val="111111"/>
                 </a:solidFill>
               </a:defRPr>
             </a:lvl4pPr>
-            <a:lvl5pPr marL="1371600" indent="0">
+            <a:lvl5pPr marL="1828800" indent="0">
               <a:buNone/>
-              <a:defRPr sz="1050">
-                <a:solidFill>
-                  <a:schemeClr val="tx1">
-                    <a:tint val="75000"/>
-                  </a:schemeClr>
+              <a:defRPr sz="1400">
+                <a:solidFill>
+                  <a:srgbClr val="111111"/>
                 </a:solidFill>
               </a:defRPr>
             </a:lvl5pPr>
-            <a:lvl6pPr marL="1714500" indent="0">
+            <a:lvl6pPr marL="2286000" indent="0">
               <a:buNone/>
-              <a:defRPr sz="1050">
-                <a:solidFill>
-                  <a:schemeClr val="tx1">
-                    <a:tint val="75000"/>
-                  </a:schemeClr>
+              <a:defRPr sz="1400">
+                <a:solidFill>
+                  <a:srgbClr val="111111"/>
                 </a:solidFill>
               </a:defRPr>
             </a:lvl6pPr>
-            <a:lvl7pPr marL="2057400" indent="0">
+            <a:lvl7pPr marL="2743200" indent="0">
               <a:buNone/>
-              <a:defRPr sz="1050">
-                <a:solidFill>
-                  <a:schemeClr val="tx1">
-                    <a:tint val="75000"/>
-                  </a:schemeClr>
+              <a:defRPr sz="1400">
+                <a:solidFill>
+                  <a:srgbClr val="111111"/>
                 </a:solidFill>
               </a:defRPr>
             </a:lvl7pPr>
-            <a:lvl8pPr marL="2400300" indent="0">
+            <a:lvl8pPr marL="3200400" indent="0">
               <a:buNone/>
-              <a:defRPr sz="1050">
-                <a:solidFill>
-                  <a:schemeClr val="tx1">
-                    <a:tint val="75000"/>
-                  </a:schemeClr>
+              <a:defRPr sz="1400">
+                <a:solidFill>
+                  <a:srgbClr val="111111"/>
                 </a:solidFill>
               </a:defRPr>
             </a:lvl8pPr>
-            <a:lvl9pPr marL="2743200" indent="0">
+            <a:lvl9pPr marL="3657600" indent="0">
               <a:buNone/>
-              <a:defRPr sz="1050">
-                <a:solidFill>
-                  <a:schemeClr val="tx1">
-                    <a:tint val="75000"/>
-                  </a:schemeClr>
+              <a:defRPr sz="1400">
+                <a:solidFill>
+                  <a:srgbClr val="111111"/>
                 </a:solidFill>
               </a:defRPr>
             </a:lvl9pPr>
@@ -1596,7 +1628,11 @@
           <a:p>
             <a:pPr lvl="0"/>
             <a:r>
-              <a:rPr lang="en-US"/>
+              <a:rPr lang="en-US" smtClean="0">
+                <a:solidFill>
+                  <a:srgbClr val="111111"/>
+                </a:solidFill>
+              </a:rPr>
               <a:t>Click to edit Master text styles</a:t>
             </a:r>
           </a:p>
@@ -1617,9 +1653,13 @@
           <a:bodyPr/>
           <a:lstStyle/>
           <a:p>
-            <a:fld id="{241EB5C9-1307-BA42-ABA2-0BC069CD8E7F}" type="datetimeFigureOut">
-              <a:rPr lang="en-US" smtClean="0"/>
-              <a:t>1/2/22</a:t>
+            <a:fld id="{5BCAD085-E8A6-8845-BD4E-CB4CCA059FC4}" type="datetimeFigureOut">
+              <a:rPr lang="en-US" smtClean="0">
+                <a:solidFill>
+                  <a:srgbClr val="111111"/>
+                </a:solidFill>
+              </a:rPr>
+              <a:t>1/27/13</a:t>
             </a:fld>
             <a:endParaRPr lang="en-US"/>
           </a:p>
@@ -1659,8 +1699,12 @@
           <a:bodyPr/>
           <a:lstStyle/>
           <a:p>
-            <a:fld id="{C5EF2332-01BF-834F-8236-50238282D533}" type="slidenum">
-              <a:rPr lang="en-US" smtClean="0"/>
+            <a:fld id="{C1FF6DA9-008F-8B48-92A6-B652298478BF}" type="slidenum">
+              <a:rPr lang="en-US" smtClean="0">
+                <a:solidFill>
+                  <a:srgbClr val="111111"/>
+                </a:solidFill>
+              </a:rPr>
               <a:t>‹#›</a:t>
             </a:fld>
             <a:endParaRPr lang="en-US"/>
@@ -1670,7 +1714,7 @@
     </p:spTree>
     <p:extLst>
       <p:ext uri="{BB962C8B-B14F-4D97-AF65-F5344CB8AC3E}">
-        <p14:creationId xmlns:p14="http://schemas.microsoft.com/office/powerpoint/2010/main" val="1073069076"/>
+        <p14:creationId xmlns:p14="http://schemas.microsoft.com/office/powerpoint/2010/main" val="960648375"/>
       </p:ext>
     </p:extLst>
   </p:cSld>
@@ -1713,9 +1757,14 @@
           <a:lstStyle/>
           <a:p>
             <a:r>
-              <a:rPr lang="en-US"/>
+              <a:rPr lang="en-US" smtClean="0">
+                <a:solidFill>
+                  <a:srgbClr val="111111"/>
+                </a:solidFill>
+              </a:rPr>
               <a:t>Click to edit Master title style</a:t>
             </a:r>
+            <a:endParaRPr lang="en-US"/>
           </a:p>
         </p:txBody>
       </p:sp>
@@ -1731,75 +1780,132 @@
         </p:nvSpPr>
         <p:spPr>
           <a:xfrm>
-            <a:off x="457200" y="1200151"/>
-            <a:ext cx="4038600" cy="3394472"/>
+            <a:off x="457200" y="1600200"/>
+            <a:ext cx="4038600" cy="4525963"/>
           </a:xfrm>
         </p:spPr>
         <p:txBody>
           <a:bodyPr/>
           <a:lstStyle>
             <a:lvl1pPr>
-              <a:defRPr sz="2100"/>
+              <a:defRPr sz="2800">
+                <a:solidFill>
+                  <a:srgbClr val="111111"/>
+                </a:solidFill>
+              </a:defRPr>
             </a:lvl1pPr>
             <a:lvl2pPr>
-              <a:defRPr sz="1800"/>
+              <a:defRPr sz="2400">
+                <a:solidFill>
+                  <a:srgbClr val="111111"/>
+                </a:solidFill>
+              </a:defRPr>
             </a:lvl2pPr>
             <a:lvl3pPr>
-              <a:defRPr sz="1500"/>
+              <a:defRPr sz="2000">
+                <a:solidFill>
+                  <a:srgbClr val="111111"/>
+                </a:solidFill>
+              </a:defRPr>
             </a:lvl3pPr>
             <a:lvl4pPr>
-              <a:defRPr sz="1350"/>
+              <a:defRPr sz="1800">
+                <a:solidFill>
+                  <a:srgbClr val="111111"/>
+                </a:solidFill>
+              </a:defRPr>
             </a:lvl4pPr>
             <a:lvl5pPr>
-              <a:defRPr sz="1350"/>
+              <a:defRPr sz="1800">
+                <a:solidFill>
+                  <a:srgbClr val="111111"/>
+                </a:solidFill>
+              </a:defRPr>
             </a:lvl5pPr>
             <a:lvl6pPr>
-              <a:defRPr sz="1350"/>
+              <a:defRPr sz="1800">
+                <a:solidFill>
+                  <a:srgbClr val="111111"/>
+                </a:solidFill>
+              </a:defRPr>
             </a:lvl6pPr>
             <a:lvl7pPr>
-              <a:defRPr sz="1350"/>
+              <a:defRPr sz="1800">
+                <a:solidFill>
+                  <a:srgbClr val="111111"/>
+                </a:solidFill>
+              </a:defRPr>
             </a:lvl7pPr>
             <a:lvl8pPr>
-              <a:defRPr sz="1350"/>
+              <a:defRPr sz="1800">
+                <a:solidFill>
+                  <a:srgbClr val="111111"/>
+                </a:solidFill>
+              </a:defRPr>
             </a:lvl8pPr>
             <a:lvl9pPr>
-              <a:defRPr sz="1350"/>
+              <a:defRPr sz="1800">
+                <a:solidFill>
+                  <a:srgbClr val="111111"/>
+                </a:solidFill>
+              </a:defRPr>
             </a:lvl9pPr>
           </a:lstStyle>
           <a:p>
             <a:pPr lvl="0"/>
             <a:r>
-              <a:rPr lang="en-US"/>
+              <a:rPr lang="en-US" smtClean="0">
+                <a:solidFill>
+                  <a:srgbClr val="111111"/>
+                </a:solidFill>
+              </a:rPr>
               <a:t>Click to edit Master text styles</a:t>
             </a:r>
           </a:p>
           <a:p>
             <a:pPr lvl="1"/>
             <a:r>
-              <a:rPr lang="en-US"/>
+              <a:rPr lang="en-US" smtClean="0">
+                <a:solidFill>
+                  <a:srgbClr val="111111"/>
+                </a:solidFill>
+              </a:rPr>
               <a:t>Second level</a:t>
             </a:r>
           </a:p>
           <a:p>
             <a:pPr lvl="2"/>
             <a:r>
-              <a:rPr lang="en-US"/>
+              <a:rPr lang="en-US" smtClean="0">
+                <a:solidFill>
+                  <a:srgbClr val="111111"/>
+                </a:solidFill>
+              </a:rPr>
               <a:t>Third level</a:t>
             </a:r>
           </a:p>
           <a:p>
             <a:pPr lvl="3"/>
             <a:r>
-              <a:rPr lang="en-US"/>
+              <a:rPr lang="en-US" smtClean="0">
+                <a:solidFill>
+                  <a:srgbClr val="111111"/>
+                </a:solidFill>
+              </a:rPr>
               <a:t>Fourth level</a:t>
             </a:r>
           </a:p>
           <a:p>
             <a:pPr lvl="4"/>
             <a:r>
-              <a:rPr lang="en-US"/>
+              <a:rPr lang="en-US" smtClean="0">
+                <a:solidFill>
+                  <a:srgbClr val="111111"/>
+                </a:solidFill>
+              </a:rPr>
               <a:t>Fifth level</a:t>
             </a:r>
+            <a:endParaRPr lang="en-US"/>
           </a:p>
         </p:txBody>
       </p:sp>
@@ -1815,75 +1921,132 @@
         </p:nvSpPr>
         <p:spPr>
           <a:xfrm>
-            <a:off x="4648200" y="1200151"/>
-            <a:ext cx="4038600" cy="3394472"/>
+            <a:off x="4648200" y="1600200"/>
+            <a:ext cx="4038600" cy="4525963"/>
           </a:xfrm>
         </p:spPr>
         <p:txBody>
           <a:bodyPr/>
           <a:lstStyle>
             <a:lvl1pPr>
-              <a:defRPr sz="2100"/>
+              <a:defRPr sz="2800">
+                <a:solidFill>
+                  <a:srgbClr val="111111"/>
+                </a:solidFill>
+              </a:defRPr>
             </a:lvl1pPr>
             <a:lvl2pPr>
-              <a:defRPr sz="1800"/>
+              <a:defRPr sz="2400">
+                <a:solidFill>
+                  <a:srgbClr val="111111"/>
+                </a:solidFill>
+              </a:defRPr>
             </a:lvl2pPr>
             <a:lvl3pPr>
-              <a:defRPr sz="1500"/>
+              <a:defRPr sz="2000">
+                <a:solidFill>
+                  <a:srgbClr val="111111"/>
+                </a:solidFill>
+              </a:defRPr>
             </a:lvl3pPr>
             <a:lvl4pPr>
-              <a:defRPr sz="1350"/>
+              <a:defRPr sz="1800">
+                <a:solidFill>
+                  <a:srgbClr val="111111"/>
+                </a:solidFill>
+              </a:defRPr>
             </a:lvl4pPr>
             <a:lvl5pPr>
-              <a:defRPr sz="1350"/>
+              <a:defRPr sz="1800">
+                <a:solidFill>
+                  <a:srgbClr val="111111"/>
+                </a:solidFill>
+              </a:defRPr>
             </a:lvl5pPr>
             <a:lvl6pPr>
-              <a:defRPr sz="1350"/>
+              <a:defRPr sz="1800">
+                <a:solidFill>
+                  <a:srgbClr val="111111"/>
+                </a:solidFill>
+              </a:defRPr>
             </a:lvl6pPr>
             <a:lvl7pPr>
-              <a:defRPr sz="1350"/>
+              <a:defRPr sz="1800">
+                <a:solidFill>
+                  <a:srgbClr val="111111"/>
+                </a:solidFill>
+              </a:defRPr>
             </a:lvl7pPr>
             <a:lvl8pPr>
-              <a:defRPr sz="1350"/>
+              <a:defRPr sz="1800">
+                <a:solidFill>
+                  <a:srgbClr val="111111"/>
+                </a:solidFill>
+              </a:defRPr>
             </a:lvl8pPr>
             <a:lvl9pPr>
-              <a:defRPr sz="1350"/>
+              <a:defRPr sz="1800">
+                <a:solidFill>
+                  <a:srgbClr val="111111"/>
+                </a:solidFill>
+              </a:defRPr>
             </a:lvl9pPr>
           </a:lstStyle>
           <a:p>
             <a:pPr lvl="0"/>
             <a:r>
-              <a:rPr lang="en-US"/>
+              <a:rPr lang="en-US" smtClean="0">
+                <a:solidFill>
+                  <a:srgbClr val="111111"/>
+                </a:solidFill>
+              </a:rPr>
               <a:t>Click to edit Master text styles</a:t>
             </a:r>
           </a:p>
           <a:p>
             <a:pPr lvl="1"/>
             <a:r>
-              <a:rPr lang="en-US"/>
+              <a:rPr lang="en-US" smtClean="0">
+                <a:solidFill>
+                  <a:srgbClr val="111111"/>
+                </a:solidFill>
+              </a:rPr>
               <a:t>Second level</a:t>
             </a:r>
           </a:p>
           <a:p>
             <a:pPr lvl="2"/>
             <a:r>
-              <a:rPr lang="en-US"/>
+              <a:rPr lang="en-US" smtClean="0">
+                <a:solidFill>
+                  <a:srgbClr val="111111"/>
+                </a:solidFill>
+              </a:rPr>
               <a:t>Third level</a:t>
             </a:r>
           </a:p>
           <a:p>
             <a:pPr lvl="3"/>
             <a:r>
-              <a:rPr lang="en-US"/>
+              <a:rPr lang="en-US" smtClean="0">
+                <a:solidFill>
+                  <a:srgbClr val="111111"/>
+                </a:solidFill>
+              </a:rPr>
               <a:t>Fourth level</a:t>
             </a:r>
           </a:p>
           <a:p>
             <a:pPr lvl="4"/>
             <a:r>
-              <a:rPr lang="en-US"/>
+              <a:rPr lang="en-US" smtClean="0">
+                <a:solidFill>
+                  <a:srgbClr val="111111"/>
+                </a:solidFill>
+              </a:rPr>
               <a:t>Fifth level</a:t>
             </a:r>
+            <a:endParaRPr lang="en-US"/>
           </a:p>
         </p:txBody>
       </p:sp>
@@ -1902,9 +2065,13 @@
           <a:bodyPr/>
           <a:lstStyle/>
           <a:p>
-            <a:fld id="{241EB5C9-1307-BA42-ABA2-0BC069CD8E7F}" type="datetimeFigureOut">
-              <a:rPr lang="en-US" smtClean="0"/>
-              <a:t>1/2/22</a:t>
+            <a:fld id="{5BCAD085-E8A6-8845-BD4E-CB4CCA059FC4}" type="datetimeFigureOut">
+              <a:rPr lang="en-US" smtClean="0">
+                <a:solidFill>
+                  <a:srgbClr val="111111"/>
+                </a:solidFill>
+              </a:rPr>
+              <a:t>1/27/13</a:t>
             </a:fld>
             <a:endParaRPr lang="en-US"/>
           </a:p>
@@ -1944,8 +2111,12 @@
           <a:bodyPr/>
           <a:lstStyle/>
           <a:p>
-            <a:fld id="{C5EF2332-01BF-834F-8236-50238282D533}" type="slidenum">
-              <a:rPr lang="en-US" smtClean="0"/>
+            <a:fld id="{C1FF6DA9-008F-8B48-92A6-B652298478BF}" type="slidenum">
+              <a:rPr lang="en-US" smtClean="0">
+                <a:solidFill>
+                  <a:srgbClr val="111111"/>
+                </a:solidFill>
+              </a:rPr>
               <a:t>‹#›</a:t>
             </a:fld>
             <a:endParaRPr lang="en-US"/>
@@ -1955,7 +2126,7 @@
     </p:spTree>
     <p:extLst>
       <p:ext uri="{BB962C8B-B14F-4D97-AF65-F5344CB8AC3E}">
-        <p14:creationId xmlns:p14="http://schemas.microsoft.com/office/powerpoint/2010/main" val="2619886245"/>
+        <p14:creationId xmlns:p14="http://schemas.microsoft.com/office/powerpoint/2010/main" val="2782244947"/>
       </p:ext>
     </p:extLst>
   </p:cSld>
@@ -1997,14 +2168,23 @@
           <a:bodyPr/>
           <a:lstStyle>
             <a:lvl1pPr>
-              <a:defRPr/>
+              <a:defRPr>
+                <a:solidFill>
+                  <a:srgbClr val="111111"/>
+                </a:solidFill>
+              </a:defRPr>
             </a:lvl1pPr>
           </a:lstStyle>
           <a:p>
             <a:r>
-              <a:rPr lang="en-US"/>
+              <a:rPr lang="en-US" smtClean="0">
+                <a:solidFill>
+                  <a:srgbClr val="111111"/>
+                </a:solidFill>
+              </a:rPr>
               <a:t>Click to edit Master title style</a:t>
             </a:r>
+            <a:endParaRPr lang="en-US"/>
           </a:p>
         </p:txBody>
       </p:sp>
@@ -2020,8 +2200,8 @@
         </p:nvSpPr>
         <p:spPr>
           <a:xfrm>
-            <a:off x="457200" y="1151335"/>
-            <a:ext cx="4040188" cy="479822"/>
+            <a:off x="457200" y="1535113"/>
+            <a:ext cx="4040188" cy="639762"/>
           </a:xfrm>
         </p:spPr>
         <p:txBody>
@@ -2029,45 +2209,85 @@
           <a:lstStyle>
             <a:lvl1pPr marL="0" indent="0">
               <a:buNone/>
-              <a:defRPr sz="1800" b="1"/>
+              <a:defRPr sz="2400" b="1">
+                <a:solidFill>
+                  <a:srgbClr val="111111"/>
+                </a:solidFill>
+              </a:defRPr>
             </a:lvl1pPr>
-            <a:lvl2pPr marL="342900" indent="0">
+            <a:lvl2pPr marL="457200" indent="0">
               <a:buNone/>
-              <a:defRPr sz="1500" b="1"/>
+              <a:defRPr sz="2000" b="1">
+                <a:solidFill>
+                  <a:srgbClr val="111111"/>
+                </a:solidFill>
+              </a:defRPr>
             </a:lvl2pPr>
-            <a:lvl3pPr marL="685800" indent="0">
+            <a:lvl3pPr marL="914400" indent="0">
               <a:buNone/>
-              <a:defRPr sz="1350" b="1"/>
+              <a:defRPr sz="1800" b="1">
+                <a:solidFill>
+                  <a:srgbClr val="111111"/>
+                </a:solidFill>
+              </a:defRPr>
             </a:lvl3pPr>
-            <a:lvl4pPr marL="1028700" indent="0">
+            <a:lvl4pPr marL="1371600" indent="0">
               <a:buNone/>
-              <a:defRPr sz="1200" b="1"/>
+              <a:defRPr sz="1600" b="1">
+                <a:solidFill>
+                  <a:srgbClr val="111111"/>
+                </a:solidFill>
+              </a:defRPr>
             </a:lvl4pPr>
-            <a:lvl5pPr marL="1371600" indent="0">
+            <a:lvl5pPr marL="1828800" indent="0">
               <a:buNone/>
-              <a:defRPr sz="1200" b="1"/>
+              <a:defRPr sz="1600" b="1">
+                <a:solidFill>
+                  <a:srgbClr val="111111"/>
+                </a:solidFill>
+              </a:defRPr>
             </a:lvl5pPr>
-            <a:lvl6pPr marL="1714500" indent="0">
+            <a:lvl6pPr marL="2286000" indent="0">
               <a:buNone/>
-              <a:defRPr sz="1200" b="1"/>
+              <a:defRPr sz="1600" b="1">
+                <a:solidFill>
+                  <a:srgbClr val="111111"/>
+                </a:solidFill>
+              </a:defRPr>
             </a:lvl6pPr>
-            <a:lvl7pPr marL="2057400" indent="0">
+            <a:lvl7pPr marL="2743200" indent="0">
               <a:buNone/>
-              <a:defRPr sz="1200" b="1"/>
+              <a:defRPr sz="1600" b="1">
+                <a:solidFill>
+                  <a:srgbClr val="111111"/>
+                </a:solidFill>
+              </a:defRPr>
             </a:lvl7pPr>
-            <a:lvl8pPr marL="2400300" indent="0">
+            <a:lvl8pPr marL="3200400" indent="0">
               <a:buNone/>
-              <a:defRPr sz="1200" b="1"/>
+              <a:defRPr sz="1600" b="1">
+                <a:solidFill>
+                  <a:srgbClr val="111111"/>
+                </a:solidFill>
+              </a:defRPr>
             </a:lvl8pPr>
-            <a:lvl9pPr marL="2743200" indent="0">
+            <a:lvl9pPr marL="3657600" indent="0">
               <a:buNone/>
-              <a:defRPr sz="1200" b="1"/>
+              <a:defRPr sz="1600" b="1">
+                <a:solidFill>
+                  <a:srgbClr val="111111"/>
+                </a:solidFill>
+              </a:defRPr>
             </a:lvl9pPr>
           </a:lstStyle>
           <a:p>
             <a:pPr lvl="0"/>
             <a:r>
-              <a:rPr lang="en-US"/>
+              <a:rPr lang="en-US" smtClean="0">
+                <a:solidFill>
+                  <a:srgbClr val="111111"/>
+                </a:solidFill>
+              </a:rPr>
               <a:t>Click to edit Master text styles</a:t>
             </a:r>
           </a:p>
@@ -2085,75 +2305,132 @@
         </p:nvSpPr>
         <p:spPr>
           <a:xfrm>
-            <a:off x="457200" y="1631156"/>
-            <a:ext cx="4040188" cy="2963466"/>
+            <a:off x="457200" y="2174875"/>
+            <a:ext cx="4040188" cy="3951288"/>
           </a:xfrm>
         </p:spPr>
         <p:txBody>
           <a:bodyPr/>
           <a:lstStyle>
             <a:lvl1pPr>
-              <a:defRPr sz="1800"/>
+              <a:defRPr sz="2400">
+                <a:solidFill>
+                  <a:srgbClr val="111111"/>
+                </a:solidFill>
+              </a:defRPr>
             </a:lvl1pPr>
             <a:lvl2pPr>
-              <a:defRPr sz="1500"/>
+              <a:defRPr sz="2000">
+                <a:solidFill>
+                  <a:srgbClr val="111111"/>
+                </a:solidFill>
+              </a:defRPr>
             </a:lvl2pPr>
             <a:lvl3pPr>
-              <a:defRPr sz="1350"/>
+              <a:defRPr sz="1800">
+                <a:solidFill>
+                  <a:srgbClr val="111111"/>
+                </a:solidFill>
+              </a:defRPr>
             </a:lvl3pPr>
             <a:lvl4pPr>
-              <a:defRPr sz="1200"/>
+              <a:defRPr sz="1600">
+                <a:solidFill>
+                  <a:srgbClr val="111111"/>
+                </a:solidFill>
+              </a:defRPr>
             </a:lvl4pPr>
             <a:lvl5pPr>
-              <a:defRPr sz="1200"/>
+              <a:defRPr sz="1600">
+                <a:solidFill>
+                  <a:srgbClr val="111111"/>
+                </a:solidFill>
+              </a:defRPr>
             </a:lvl5pPr>
             <a:lvl6pPr>
-              <a:defRPr sz="1200"/>
+              <a:defRPr sz="1600">
+                <a:solidFill>
+                  <a:srgbClr val="111111"/>
+                </a:solidFill>
+              </a:defRPr>
             </a:lvl6pPr>
             <a:lvl7pPr>
-              <a:defRPr sz="1200"/>
+              <a:defRPr sz="1600">
+                <a:solidFill>
+                  <a:srgbClr val="111111"/>
+                </a:solidFill>
+              </a:defRPr>
             </a:lvl7pPr>
             <a:lvl8pPr>
-              <a:defRPr sz="1200"/>
+              <a:defRPr sz="1600">
+                <a:solidFill>
+                  <a:srgbClr val="111111"/>
+                </a:solidFill>
+              </a:defRPr>
             </a:lvl8pPr>
             <a:lvl9pPr>
-              <a:defRPr sz="1200"/>
+              <a:defRPr sz="1600">
+                <a:solidFill>
+                  <a:srgbClr val="111111"/>
+                </a:solidFill>
+              </a:defRPr>
             </a:lvl9pPr>
           </a:lstStyle>
           <a:p>
             <a:pPr lvl="0"/>
             <a:r>
-              <a:rPr lang="en-US"/>
+              <a:rPr lang="en-US" smtClean="0">
+                <a:solidFill>
+                  <a:srgbClr val="111111"/>
+                </a:solidFill>
+              </a:rPr>
               <a:t>Click to edit Master text styles</a:t>
             </a:r>
           </a:p>
           <a:p>
             <a:pPr lvl="1"/>
             <a:r>
-              <a:rPr lang="en-US"/>
+              <a:rPr lang="en-US" smtClean="0">
+                <a:solidFill>
+                  <a:srgbClr val="111111"/>
+                </a:solidFill>
+              </a:rPr>
               <a:t>Second level</a:t>
             </a:r>
           </a:p>
           <a:p>
             <a:pPr lvl="2"/>
             <a:r>
-              <a:rPr lang="en-US"/>
+              <a:rPr lang="en-US" smtClean="0">
+                <a:solidFill>
+                  <a:srgbClr val="111111"/>
+                </a:solidFill>
+              </a:rPr>
               <a:t>Third level</a:t>
             </a:r>
           </a:p>
           <a:p>
             <a:pPr lvl="3"/>
             <a:r>
-              <a:rPr lang="en-US"/>
+              <a:rPr lang="en-US" smtClean="0">
+                <a:solidFill>
+                  <a:srgbClr val="111111"/>
+                </a:solidFill>
+              </a:rPr>
               <a:t>Fourth level</a:t>
             </a:r>
           </a:p>
           <a:p>
             <a:pPr lvl="4"/>
             <a:r>
-              <a:rPr lang="en-US"/>
+              <a:rPr lang="en-US" smtClean="0">
+                <a:solidFill>
+                  <a:srgbClr val="111111"/>
+                </a:solidFill>
+              </a:rPr>
               <a:t>Fifth level</a:t>
             </a:r>
+            <a:endParaRPr lang="en-US"/>
           </a:p>
         </p:txBody>
       </p:sp>
@@ -2169,8 +2446,8 @@
         </p:nvSpPr>
         <p:spPr>
           <a:xfrm>
-            <a:off x="4645026" y="1151335"/>
-            <a:ext cx="4041775" cy="479822"/>
+            <a:off x="4645025" y="1535113"/>
+            <a:ext cx="4041775" cy="639762"/>
           </a:xfrm>
         </p:spPr>
         <p:txBody>
@@ -2178,45 +2455,85 @@
           <a:lstStyle>
             <a:lvl1pPr marL="0" indent="0">
               <a:buNone/>
-              <a:defRPr sz="1800" b="1"/>
+              <a:defRPr sz="2400" b="1">
+                <a:solidFill>
+                  <a:srgbClr val="111111"/>
+                </a:solidFill>
+              </a:defRPr>
             </a:lvl1pPr>
-            <a:lvl2pPr marL="342900" indent="0">
+            <a:lvl2pPr marL="457200" indent="0">
               <a:buNone/>
-              <a:defRPr sz="1500" b="1"/>
+              <a:defRPr sz="2000" b="1">
+                <a:solidFill>
+                  <a:srgbClr val="111111"/>
+                </a:solidFill>
+              </a:defRPr>
             </a:lvl2pPr>
-            <a:lvl3pPr marL="685800" indent="0">
+            <a:lvl3pPr marL="914400" indent="0">
               <a:buNone/>
-              <a:defRPr sz="1350" b="1"/>
+              <a:defRPr sz="1800" b="1">
+                <a:solidFill>
+                  <a:srgbClr val="111111"/>
+                </a:solidFill>
+              </a:defRPr>
             </a:lvl3pPr>
-            <a:lvl4pPr marL="1028700" indent="0">
+            <a:lvl4pPr marL="1371600" indent="0">
               <a:buNone/>
-              <a:defRPr sz="1200" b="1"/>
+              <a:defRPr sz="1600" b="1">
+                <a:solidFill>
+                  <a:srgbClr val="111111"/>
+                </a:solidFill>
+              </a:defRPr>
             </a:lvl4pPr>
-            <a:lvl5pPr marL="1371600" indent="0">
+            <a:lvl5pPr marL="1828800" indent="0">
               <a:buNone/>
-              <a:defRPr sz="1200" b="1"/>
+              <a:defRPr sz="1600" b="1">
+                <a:solidFill>
+                  <a:srgbClr val="111111"/>
+                </a:solidFill>
+              </a:defRPr>
             </a:lvl5pPr>
-            <a:lvl6pPr marL="1714500" indent="0">
+            <a:lvl6pPr marL="2286000" indent="0">
               <a:buNone/>
-              <a:defRPr sz="1200" b="1"/>
+              <a:defRPr sz="1600" b="1">
+                <a:solidFill>
+                  <a:srgbClr val="111111"/>
+                </a:solidFill>
+              </a:defRPr>
             </a:lvl6pPr>
-            <a:lvl7pPr marL="2057400" indent="0">
+            <a:lvl7pPr marL="2743200" indent="0">
               <a:buNone/>
-              <a:defRPr sz="1200" b="1"/>
+              <a:defRPr sz="1600" b="1">
+                <a:solidFill>
+                  <a:srgbClr val="111111"/>
+                </a:solidFill>
+              </a:defRPr>
             </a:lvl7pPr>
-            <a:lvl8pPr marL="2400300" indent="0">
+            <a:lvl8pPr marL="3200400" indent="0">
               <a:buNone/>
-              <a:defRPr sz="1200" b="1"/>
+              <a:defRPr sz="1600" b="1">
+                <a:solidFill>
+                  <a:srgbClr val="111111"/>
+                </a:solidFill>
+              </a:defRPr>
             </a:lvl8pPr>
-            <a:lvl9pPr marL="2743200" indent="0">
+            <a:lvl9pPr marL="3657600" indent="0">
               <a:buNone/>
-              <a:defRPr sz="1200" b="1"/>
+              <a:defRPr sz="1600" b="1">
+                <a:solidFill>
+                  <a:srgbClr val="111111"/>
+                </a:solidFill>
+              </a:defRPr>
             </a:lvl9pPr>
           </a:lstStyle>
           <a:p>
             <a:pPr lvl="0"/>
             <a:r>
-              <a:rPr lang="en-US"/>
+              <a:rPr lang="en-US" smtClean="0">
+                <a:solidFill>
+                  <a:srgbClr val="111111"/>
+                </a:solidFill>
+              </a:rPr>
               <a:t>Click to edit Master text styles</a:t>
             </a:r>
           </a:p>
@@ -2234,75 +2551,132 @@
         </p:nvSpPr>
         <p:spPr>
           <a:xfrm>
-            <a:off x="4645026" y="1631156"/>
-            <a:ext cx="4041775" cy="2963466"/>
+            <a:off x="4645025" y="2174875"/>
+            <a:ext cx="4041775" cy="3951288"/>
           </a:xfrm>
         </p:spPr>
         <p:txBody>
           <a:bodyPr/>
           <a:lstStyle>
             <a:lvl1pPr>
-              <a:defRPr sz="1800"/>
+              <a:defRPr sz="2400">
+                <a:solidFill>
+                  <a:srgbClr val="111111"/>
+                </a:solidFill>
+              </a:defRPr>
             </a:lvl1pPr>
             <a:lvl2pPr>
-              <a:defRPr sz="1500"/>
+              <a:defRPr sz="2000">
+                <a:solidFill>
+                  <a:srgbClr val="111111"/>
+                </a:solidFill>
+              </a:defRPr>
             </a:lvl2pPr>
             <a:lvl3pPr>
-              <a:defRPr sz="1350"/>
+              <a:defRPr sz="1800">
+                <a:solidFill>
+                  <a:srgbClr val="111111"/>
+                </a:solidFill>
+              </a:defRPr>
             </a:lvl3pPr>
             <a:lvl4pPr>
-              <a:defRPr sz="1200"/>
+              <a:defRPr sz="1600">
+                <a:solidFill>
+                  <a:srgbClr val="111111"/>
+                </a:solidFill>
+              </a:defRPr>
             </a:lvl4pPr>
             <a:lvl5pPr>
-              <a:defRPr sz="1200"/>
+              <a:defRPr sz="1600">
+                <a:solidFill>
+                  <a:srgbClr val="111111"/>
+                </a:solidFill>
+              </a:defRPr>
             </a:lvl5pPr>
             <a:lvl6pPr>
-              <a:defRPr sz="1200"/>
+              <a:defRPr sz="1600">
+                <a:solidFill>
+                  <a:srgbClr val="111111"/>
+                </a:solidFill>
+              </a:defRPr>
             </a:lvl6pPr>
             <a:lvl7pPr>
-              <a:defRPr sz="1200"/>
+              <a:defRPr sz="1600">
+                <a:solidFill>
+                  <a:srgbClr val="111111"/>
+                </a:solidFill>
+              </a:defRPr>
             </a:lvl7pPr>
             <a:lvl8pPr>
-              <a:defRPr sz="1200"/>
+              <a:defRPr sz="1600">
+                <a:solidFill>
+                  <a:srgbClr val="111111"/>
+                </a:solidFill>
+              </a:defRPr>
             </a:lvl8pPr>
             <a:lvl9pPr>
-              <a:defRPr sz="1200"/>
+              <a:defRPr sz="1600">
+                <a:solidFill>
+                  <a:srgbClr val="111111"/>
+                </a:solidFill>
+              </a:defRPr>
             </a:lvl9pPr>
           </a:lstStyle>
           <a:p>
             <a:pPr lvl="0"/>
             <a:r>
-              <a:rPr lang="en-US"/>
+              <a:rPr lang="en-US" smtClean="0">
+                <a:solidFill>
+                  <a:srgbClr val="111111"/>
+                </a:solidFill>
+              </a:rPr>
               <a:t>Click to edit Master text styles</a:t>
             </a:r>
           </a:p>
           <a:p>
             <a:pPr lvl="1"/>
             <a:r>
-              <a:rPr lang="en-US"/>
+              <a:rPr lang="en-US" smtClean="0">
+                <a:solidFill>
+                  <a:srgbClr val="111111"/>
+                </a:solidFill>
+              </a:rPr>
               <a:t>Second level</a:t>
             </a:r>
           </a:p>
           <a:p>
             <a:pPr lvl="2"/>
             <a:r>
-              <a:rPr lang="en-US"/>
+              <a:rPr lang="en-US" smtClean="0">
+                <a:solidFill>
+                  <a:srgbClr val="111111"/>
+                </a:solidFill>
+              </a:rPr>
               <a:t>Third level</a:t>
             </a:r>
           </a:p>
           <a:p>
             <a:pPr lvl="3"/>
             <a:r>
-              <a:rPr lang="en-US"/>
+              <a:rPr lang="en-US" smtClean="0">
+                <a:solidFill>
+                  <a:srgbClr val="111111"/>
+                </a:solidFill>
+              </a:rPr>
               <a:t>Fourth level</a:t>
             </a:r>
           </a:p>
           <a:p>
             <a:pPr lvl="4"/>
             <a:r>
-              <a:rPr lang="en-US"/>
+              <a:rPr lang="en-US" smtClean="0">
+                <a:solidFill>
+                  <a:srgbClr val="111111"/>
+                </a:solidFill>
+              </a:rPr>
               <a:t>Fifth level</a:t>
             </a:r>
+            <a:endParaRPr lang="en-US"/>
           </a:p>
         </p:txBody>
       </p:sp>
@@ -2321,9 +2695,13 @@
           <a:bodyPr/>
           <a:lstStyle/>
           <a:p>
-            <a:fld id="{241EB5C9-1307-BA42-ABA2-0BC069CD8E7F}" type="datetimeFigureOut">
-              <a:rPr lang="en-US" smtClean="0"/>
-              <a:t>1/2/22</a:t>
+            <a:fld id="{5BCAD085-E8A6-8845-BD4E-CB4CCA059FC4}" type="datetimeFigureOut">
+              <a:rPr lang="en-US" smtClean="0">
+                <a:solidFill>
+                  <a:srgbClr val="111111"/>
+                </a:solidFill>
+              </a:rPr>
+              <a:t>1/27/13</a:t>
             </a:fld>
             <a:endParaRPr lang="en-US"/>
           </a:p>
@@ -2363,8 +2741,12 @@
           <a:bodyPr/>
           <a:lstStyle/>
           <a:p>
-            <a:fld id="{C5EF2332-01BF-834F-8236-50238282D533}" type="slidenum">
-              <a:rPr lang="en-US" smtClean="0"/>
+            <a:fld id="{C1FF6DA9-008F-8B48-92A6-B652298478BF}" type="slidenum">
+              <a:rPr lang="en-US" smtClean="0">
+                <a:solidFill>
+                  <a:srgbClr val="111111"/>
+                </a:solidFill>
+              </a:rPr>
               <a:t>‹#›</a:t>
             </a:fld>
             <a:endParaRPr lang="en-US"/>
@@ -2374,7 +2756,7 @@
     </p:spTree>
     <p:extLst>
       <p:ext uri="{BB962C8B-B14F-4D97-AF65-F5344CB8AC3E}">
-        <p14:creationId xmlns:p14="http://schemas.microsoft.com/office/powerpoint/2010/main" val="2535793967"/>
+        <p14:creationId xmlns:p14="http://schemas.microsoft.com/office/powerpoint/2010/main" val="990158736"/>
       </p:ext>
     </p:extLst>
   </p:cSld>
@@ -2417,9 +2799,14 @@
           <a:lstStyle/>
           <a:p>
             <a:r>
-              <a:rPr lang="en-US"/>
+              <a:rPr lang="en-US" smtClean="0">
+                <a:solidFill>
+                  <a:srgbClr val="111111"/>
+                </a:solidFill>
+              </a:rPr>
               <a:t>Click to edit Master title style</a:t>
             </a:r>
+            <a:endParaRPr lang="en-US"/>
           </a:p>
         </p:txBody>
       </p:sp>
@@ -2438,9 +2825,13 @@
           <a:bodyPr/>
           <a:lstStyle/>
           <a:p>
-            <a:fld id="{241EB5C9-1307-BA42-ABA2-0BC069CD8E7F}" type="datetimeFigureOut">
-              <a:rPr lang="en-US" smtClean="0"/>
-              <a:t>1/2/22</a:t>
+            <a:fld id="{5BCAD085-E8A6-8845-BD4E-CB4CCA059FC4}" type="datetimeFigureOut">
+              <a:rPr lang="en-US" smtClean="0">
+                <a:solidFill>
+                  <a:srgbClr val="111111"/>
+                </a:solidFill>
+              </a:rPr>
+              <a:t>1/27/13</a:t>
             </a:fld>
             <a:endParaRPr lang="en-US"/>
           </a:p>
@@ -2480,8 +2871,12 @@
           <a:bodyPr/>
           <a:lstStyle/>
           <a:p>
-            <a:fld id="{C5EF2332-01BF-834F-8236-50238282D533}" type="slidenum">
-              <a:rPr lang="en-US" smtClean="0"/>
+            <a:fld id="{C1FF6DA9-008F-8B48-92A6-B652298478BF}" type="slidenum">
+              <a:rPr lang="en-US" smtClean="0">
+                <a:solidFill>
+                  <a:srgbClr val="111111"/>
+                </a:solidFill>
+              </a:rPr>
               <a:t>‹#›</a:t>
             </a:fld>
             <a:endParaRPr lang="en-US"/>
@@ -2491,7 +2886,7 @@
     </p:spTree>
     <p:extLst>
       <p:ext uri="{BB962C8B-B14F-4D97-AF65-F5344CB8AC3E}">
-        <p14:creationId xmlns:p14="http://schemas.microsoft.com/office/powerpoint/2010/main" val="3472721253"/>
+        <p14:creationId xmlns:p14="http://schemas.microsoft.com/office/powerpoint/2010/main" val="727027711"/>
       </p:ext>
     </p:extLst>
   </p:cSld>
@@ -2533,9 +2928,13 @@
           <a:bodyPr/>
           <a:lstStyle/>
           <a:p>
-            <a:fld id="{241EB5C9-1307-BA42-ABA2-0BC069CD8E7F}" type="datetimeFigureOut">
-              <a:rPr lang="en-US" smtClean="0"/>
-              <a:t>1/2/22</a:t>
+            <a:fld id="{5BCAD085-E8A6-8845-BD4E-CB4CCA059FC4}" type="datetimeFigureOut">
+              <a:rPr lang="en-US" smtClean="0">
+                <a:solidFill>
+                  <a:srgbClr val="111111"/>
+                </a:solidFill>
+              </a:rPr>
+              <a:t>1/27/13</a:t>
             </a:fld>
             <a:endParaRPr lang="en-US"/>
           </a:p>
@@ -2575,8 +2974,12 @@
           <a:bodyPr/>
           <a:lstStyle/>
           <a:p>
-            <a:fld id="{C5EF2332-01BF-834F-8236-50238282D533}" type="slidenum">
-              <a:rPr lang="en-US" smtClean="0"/>
+            <a:fld id="{C1FF6DA9-008F-8B48-92A6-B652298478BF}" type="slidenum">
+              <a:rPr lang="en-US" smtClean="0">
+                <a:solidFill>
+                  <a:srgbClr val="111111"/>
+                </a:solidFill>
+              </a:rPr>
               <a:t>‹#›</a:t>
             </a:fld>
             <a:endParaRPr lang="en-US"/>
@@ -2586,7 +2989,7 @@
     </p:spTree>
     <p:extLst>
       <p:ext uri="{BB962C8B-B14F-4D97-AF65-F5344CB8AC3E}">
-        <p14:creationId xmlns:p14="http://schemas.microsoft.com/office/powerpoint/2010/main" val="2130901097"/>
+        <p14:creationId xmlns:p14="http://schemas.microsoft.com/office/powerpoint/2010/main" val="1212999818"/>
       </p:ext>
     </p:extLst>
   </p:cSld>
@@ -2625,22 +3028,31 @@
         </p:nvSpPr>
         <p:spPr>
           <a:xfrm>
-            <a:off x="457201" y="204787"/>
-            <a:ext cx="3008313" cy="871538"/>
+            <a:off x="457200" y="273050"/>
+            <a:ext cx="3008313" cy="1162050"/>
           </a:xfrm>
         </p:spPr>
         <p:txBody>
           <a:bodyPr anchor="b"/>
           <a:lstStyle>
             <a:lvl1pPr algn="l">
-              <a:defRPr sz="1500" b="1"/>
+              <a:defRPr sz="2000" b="1">
+                <a:solidFill>
+                  <a:srgbClr val="111111"/>
+                </a:solidFill>
+              </a:defRPr>
             </a:lvl1pPr>
           </a:lstStyle>
           <a:p>
             <a:r>
-              <a:rPr lang="en-US"/>
+              <a:rPr lang="en-US" smtClean="0">
+                <a:solidFill>
+                  <a:srgbClr val="111111"/>
+                </a:solidFill>
+              </a:rPr>
               <a:t>Click to edit Master title style</a:t>
             </a:r>
+            <a:endParaRPr lang="en-US"/>
           </a:p>
         </p:txBody>
       </p:sp>
@@ -2656,75 +3068,132 @@
         </p:nvSpPr>
         <p:spPr>
           <a:xfrm>
-            <a:off x="3575050" y="204788"/>
-            <a:ext cx="5111750" cy="4389835"/>
+            <a:off x="3575050" y="273050"/>
+            <a:ext cx="5111750" cy="5853113"/>
           </a:xfrm>
         </p:spPr>
         <p:txBody>
           <a:bodyPr/>
           <a:lstStyle>
             <a:lvl1pPr>
-              <a:defRPr sz="2400"/>
+              <a:defRPr sz="3200">
+                <a:solidFill>
+                  <a:srgbClr val="111111"/>
+                </a:solidFill>
+              </a:defRPr>
             </a:lvl1pPr>
             <a:lvl2pPr>
-              <a:defRPr sz="2100"/>
+              <a:defRPr sz="2800">
+                <a:solidFill>
+                  <a:srgbClr val="111111"/>
+                </a:solidFill>
+              </a:defRPr>
             </a:lvl2pPr>
             <a:lvl3pPr>
-              <a:defRPr sz="1800"/>
+              <a:defRPr sz="2400">
+                <a:solidFill>
+                  <a:srgbClr val="111111"/>
+                </a:solidFill>
+              </a:defRPr>
             </a:lvl3pPr>
             <a:lvl4pPr>
-              <a:defRPr sz="1500"/>
+              <a:defRPr sz="2000">
+                <a:solidFill>
+                  <a:srgbClr val="111111"/>
+                </a:solidFill>
+              </a:defRPr>
             </a:lvl4pPr>
             <a:lvl5pPr>
-              <a:defRPr sz="1500"/>
+              <a:defRPr sz="2000">
+                <a:solidFill>
+                  <a:srgbClr val="111111"/>
+                </a:solidFill>
+              </a:defRPr>
             </a:lvl5pPr>
             <a:lvl6pPr>
-              <a:defRPr sz="1500"/>
+              <a:defRPr sz="2000">
+                <a:solidFill>
+                  <a:srgbClr val="111111"/>
+                </a:solidFill>
+              </a:defRPr>
             </a:lvl6pPr>
             <a:lvl7pPr>
-              <a:defRPr sz="1500"/>
+              <a:defRPr sz="2000">
+                <a:solidFill>
+                  <a:srgbClr val="111111"/>
+                </a:solidFill>
+              </a:defRPr>
             </a:lvl7pPr>
             <a:lvl8pPr>
-              <a:defRPr sz="1500"/>
+              <a:defRPr sz="2000">
+                <a:solidFill>
+                  <a:srgbClr val="111111"/>
+                </a:solidFill>
+              </a:defRPr>
             </a:lvl8pPr>
             <a:lvl9pPr>
-              <a:defRPr sz="1500"/>
+              <a:defRPr sz="2000">
+                <a:solidFill>
+                  <a:srgbClr val="111111"/>
+                </a:solidFill>
+              </a:defRPr>
             </a:lvl9pPr>
           </a:lstStyle>
           <a:p>
             <a:pPr lvl="0"/>
             <a:r>
-              <a:rPr lang="en-US"/>
+              <a:rPr lang="en-US" smtClean="0">
+                <a:solidFill>
+                  <a:srgbClr val="111111"/>
+                </a:solidFill>
+              </a:rPr>
               <a:t>Click to edit Master text styles</a:t>
             </a:r>
           </a:p>
           <a:p>
             <a:pPr lvl="1"/>
             <a:r>
-              <a:rPr lang="en-US"/>
+              <a:rPr lang="en-US" smtClean="0">
+                <a:solidFill>
+                  <a:srgbClr val="111111"/>
+                </a:solidFill>
+              </a:rPr>
               <a:t>Second level</a:t>
             </a:r>
           </a:p>
           <a:p>
             <a:pPr lvl="2"/>
             <a:r>
-              <a:rPr lang="en-US"/>
+              <a:rPr lang="en-US" smtClean="0">
+                <a:solidFill>
+                  <a:srgbClr val="111111"/>
+                </a:solidFill>
+              </a:rPr>
               <a:t>Third level</a:t>
             </a:r>
           </a:p>
           <a:p>
             <a:pPr lvl="3"/>
             <a:r>
-              <a:rPr lang="en-US"/>
+              <a:rPr lang="en-US" smtClean="0">
+                <a:solidFill>
+                  <a:srgbClr val="111111"/>
+                </a:solidFill>
+              </a:rPr>
               <a:t>Fourth level</a:t>
             </a:r>
           </a:p>
           <a:p>
             <a:pPr lvl="4"/>
             <a:r>
-              <a:rPr lang="en-US"/>
+              <a:rPr lang="en-US" smtClean="0">
+                <a:solidFill>
+                  <a:srgbClr val="111111"/>
+                </a:solidFill>
+              </a:rPr>
               <a:t>Fifth level</a:t>
             </a:r>
+            <a:endParaRPr lang="en-US"/>
           </a:p>
         </p:txBody>
       </p:sp>
@@ -2740,8 +3209,8 @@
         </p:nvSpPr>
         <p:spPr>
           <a:xfrm>
-            <a:off x="457201" y="1076326"/>
-            <a:ext cx="3008313" cy="3518297"/>
+            <a:off x="457200" y="1435100"/>
+            <a:ext cx="3008313" cy="4691063"/>
           </a:xfrm>
         </p:spPr>
         <p:txBody>
@@ -2749,45 +3218,85 @@
           <a:lstStyle>
             <a:lvl1pPr marL="0" indent="0">
               <a:buNone/>
-              <a:defRPr sz="1050"/>
+              <a:defRPr sz="1400">
+                <a:solidFill>
+                  <a:srgbClr val="111111"/>
+                </a:solidFill>
+              </a:defRPr>
             </a:lvl1pPr>
-            <a:lvl2pPr marL="342900" indent="0">
+            <a:lvl2pPr marL="457200" indent="0">
               <a:buNone/>
-              <a:defRPr sz="900"/>
+              <a:defRPr sz="1200">
+                <a:solidFill>
+                  <a:srgbClr val="111111"/>
+                </a:solidFill>
+              </a:defRPr>
             </a:lvl2pPr>
-            <a:lvl3pPr marL="685800" indent="0">
+            <a:lvl3pPr marL="914400" indent="0">
               <a:buNone/>
-              <a:defRPr sz="750"/>
+              <a:defRPr sz="1000">
+                <a:solidFill>
+                  <a:srgbClr val="111111"/>
+                </a:solidFill>
+              </a:defRPr>
             </a:lvl3pPr>
-            <a:lvl4pPr marL="1028700" indent="0">
+            <a:lvl4pPr marL="1371600" indent="0">
               <a:buNone/>
-              <a:defRPr sz="675"/>
+              <a:defRPr sz="900">
+                <a:solidFill>
+                  <a:srgbClr val="111111"/>
+                </a:solidFill>
+              </a:defRPr>
             </a:lvl4pPr>
-            <a:lvl5pPr marL="1371600" indent="0">
+            <a:lvl5pPr marL="1828800" indent="0">
               <a:buNone/>
-              <a:defRPr sz="675"/>
+              <a:defRPr sz="900">
+                <a:solidFill>
+                  <a:srgbClr val="111111"/>
+                </a:solidFill>
+              </a:defRPr>
             </a:lvl5pPr>
-            <a:lvl6pPr marL="1714500" indent="0">
+            <a:lvl6pPr marL="2286000" indent="0">
               <a:buNone/>
-              <a:defRPr sz="675"/>
+              <a:defRPr sz="900">
+                <a:solidFill>
+                  <a:srgbClr val="111111"/>
+                </a:solidFill>
+              </a:defRPr>
             </a:lvl6pPr>
-            <a:lvl7pPr marL="2057400" indent="0">
+            <a:lvl7pPr marL="2743200" indent="0">
               <a:buNone/>
-              <a:defRPr sz="675"/>
+              <a:defRPr sz="900">
+                <a:solidFill>
+                  <a:srgbClr val="111111"/>
+                </a:solidFill>
+              </a:defRPr>
             </a:lvl7pPr>
-            <a:lvl8pPr marL="2400300" indent="0">
+            <a:lvl8pPr marL="3200400" indent="0">
               <a:buNone/>
-              <a:defRPr sz="675"/>
+              <a:defRPr sz="900">
+                <a:solidFill>
+                  <a:srgbClr val="111111"/>
+                </a:solidFill>
+              </a:defRPr>
             </a:lvl8pPr>
-            <a:lvl9pPr marL="2743200" indent="0">
+            <a:lvl9pPr marL="3657600" indent="0">
               <a:buNone/>
-              <a:defRPr sz="675"/>
+              <a:defRPr sz="900">
+                <a:solidFill>
+                  <a:srgbClr val="111111"/>
+                </a:solidFill>
+              </a:defRPr>
             </a:lvl9pPr>
           </a:lstStyle>
           <a:p>
             <a:pPr lvl="0"/>
             <a:r>
-              <a:rPr lang="en-US"/>
+              <a:rPr lang="en-US" smtClean="0">
+                <a:solidFill>
+                  <a:srgbClr val="111111"/>
+                </a:solidFill>
+              </a:rPr>
               <a:t>Click to edit Master text styles</a:t>
             </a:r>
           </a:p>
@@ -2808,9 +3317,13 @@
           <a:bodyPr/>
           <a:lstStyle/>
           <a:p>
-            <a:fld id="{241EB5C9-1307-BA42-ABA2-0BC069CD8E7F}" type="datetimeFigureOut">
-              <a:rPr lang="en-US" smtClean="0"/>
-              <a:t>1/2/22</a:t>
+            <a:fld id="{5BCAD085-E8A6-8845-BD4E-CB4CCA059FC4}" type="datetimeFigureOut">
+              <a:rPr lang="en-US" smtClean="0">
+                <a:solidFill>
+                  <a:srgbClr val="111111"/>
+                </a:solidFill>
+              </a:rPr>
+              <a:t>1/27/13</a:t>
             </a:fld>
             <a:endParaRPr lang="en-US"/>
           </a:p>
@@ -2850,8 +3363,12 @@
           <a:bodyPr/>
           <a:lstStyle/>
           <a:p>
-            <a:fld id="{C5EF2332-01BF-834F-8236-50238282D533}" type="slidenum">
-              <a:rPr lang="en-US" smtClean="0"/>
+            <a:fld id="{C1FF6DA9-008F-8B48-92A6-B652298478BF}" type="slidenum">
+              <a:rPr lang="en-US" smtClean="0">
+                <a:solidFill>
+                  <a:srgbClr val="111111"/>
+                </a:solidFill>
+              </a:rPr>
               <a:t>‹#›</a:t>
             </a:fld>
             <a:endParaRPr lang="en-US"/>
@@ -2861,7 +3378,7 @@
     </p:spTree>
     <p:extLst>
       <p:ext uri="{BB962C8B-B14F-4D97-AF65-F5344CB8AC3E}">
-        <p14:creationId xmlns:p14="http://schemas.microsoft.com/office/powerpoint/2010/main" val="3540895647"/>
+        <p14:creationId xmlns:p14="http://schemas.microsoft.com/office/powerpoint/2010/main" val="1840726560"/>
       </p:ext>
     </p:extLst>
   </p:cSld>
@@ -2900,22 +3417,31 @@
         </p:nvSpPr>
         <p:spPr>
           <a:xfrm>
-            <a:off x="1792288" y="3600450"/>
-            <a:ext cx="5486400" cy="425054"/>
+            <a:off x="1792288" y="4800600"/>
+            <a:ext cx="5486400" cy="566738"/>
           </a:xfrm>
         </p:spPr>
         <p:txBody>
           <a:bodyPr anchor="b"/>
           <a:lstStyle>
             <a:lvl1pPr algn="l">
-              <a:defRPr sz="1500" b="1"/>
+              <a:defRPr sz="2000" b="1">
+                <a:solidFill>
+                  <a:srgbClr val="111111"/>
+                </a:solidFill>
+              </a:defRPr>
             </a:lvl1pPr>
           </a:lstStyle>
           <a:p>
             <a:r>
-              <a:rPr lang="en-US"/>
+              <a:rPr lang="en-US" smtClean="0">
+                <a:solidFill>
+                  <a:srgbClr val="111111"/>
+                </a:solidFill>
+              </a:rPr>
               <a:t>Click to edit Master title style</a:t>
             </a:r>
+            <a:endParaRPr lang="en-US"/>
           </a:p>
         </p:txBody>
       </p:sp>
@@ -2931,8 +3457,8 @@
         </p:nvSpPr>
         <p:spPr>
           <a:xfrm>
-            <a:off x="1792288" y="459581"/>
-            <a:ext cx="5486400" cy="3086100"/>
+            <a:off x="1792288" y="612775"/>
+            <a:ext cx="5486400" cy="4114800"/>
           </a:xfrm>
         </p:spPr>
         <p:txBody>
@@ -2940,39 +3466,75 @@
           <a:lstStyle>
             <a:lvl1pPr marL="0" indent="0">
               <a:buNone/>
-              <a:defRPr sz="2400"/>
+              <a:defRPr sz="3200">
+                <a:solidFill>
+                  <a:srgbClr val="111111"/>
+                </a:solidFill>
+              </a:defRPr>
             </a:lvl1pPr>
-            <a:lvl2pPr marL="342900" indent="0">
+            <a:lvl2pPr marL="457200" indent="0">
               <a:buNone/>
-              <a:defRPr sz="2100"/>
+              <a:defRPr sz="2800">
+                <a:solidFill>
+                  <a:srgbClr val="111111"/>
+                </a:solidFill>
+              </a:defRPr>
             </a:lvl2pPr>
-            <a:lvl3pPr marL="685800" indent="0">
+            <a:lvl3pPr marL="914400" indent="0">
               <a:buNone/>
-              <a:defRPr sz="1800"/>
+              <a:defRPr sz="2400">
+                <a:solidFill>
+                  <a:srgbClr val="111111"/>
+                </a:solidFill>
+              </a:defRPr>
             </a:lvl3pPr>
-            <a:lvl4pPr marL="1028700" indent="0">
+            <a:lvl4pPr marL="1371600" indent="0">
               <a:buNone/>
-              <a:defRPr sz="1500"/>
+              <a:defRPr sz="2000">
+                <a:solidFill>
+                  <a:srgbClr val="111111"/>
+                </a:solidFill>
+              </a:defRPr>
             </a:lvl4pPr>
-            <a:lvl5pPr marL="1371600" indent="0">
+            <a:lvl5pPr marL="1828800" indent="0">
               <a:buNone/>
-              <a:defRPr sz="1500"/>
+              <a:defRPr sz="2000">
+                <a:solidFill>
+                  <a:srgbClr val="111111"/>
+                </a:solidFill>
+              </a:defRPr>
             </a:lvl5pPr>
-            <a:lvl6pPr marL="1714500" indent="0">
+            <a:lvl6pPr marL="2286000" indent="0">
               <a:buNone/>
-              <a:defRPr sz="1500"/>
+              <a:defRPr sz="2000">
+                <a:solidFill>
+                  <a:srgbClr val="111111"/>
+                </a:solidFill>
+              </a:defRPr>
             </a:lvl6pPr>
-            <a:lvl7pPr marL="2057400" indent="0">
+            <a:lvl7pPr marL="2743200" indent="0">
               <a:buNone/>
-              <a:defRPr sz="1500"/>
+              <a:defRPr sz="2000">
+                <a:solidFill>
+                  <a:srgbClr val="111111"/>
+                </a:solidFill>
+              </a:defRPr>
             </a:lvl7pPr>
-            <a:lvl8pPr marL="2400300" indent="0">
+            <a:lvl8pPr marL="3200400" indent="0">
               <a:buNone/>
-              <a:defRPr sz="1500"/>
+              <a:defRPr sz="2000">
+                <a:solidFill>
+                  <a:srgbClr val="111111"/>
+                </a:solidFill>
+              </a:defRPr>
             </a:lvl8pPr>
-            <a:lvl9pPr marL="2743200" indent="0">
+            <a:lvl9pPr marL="3657600" indent="0">
               <a:buNone/>
-              <a:defRPr sz="1500"/>
+              <a:defRPr sz="2000">
+                <a:solidFill>
+                  <a:srgbClr val="111111"/>
+                </a:solidFill>
+              </a:defRPr>
             </a:lvl9pPr>
           </a:lstStyle>
           <a:p>
@@ -2992,8 +3554,8 @@
         </p:nvSpPr>
         <p:spPr>
           <a:xfrm>
-            <a:off x="1792288" y="4025503"/>
-            <a:ext cx="5486400" cy="603647"/>
+            <a:off x="1792288" y="5367338"/>
+            <a:ext cx="5486400" cy="804862"/>
           </a:xfrm>
         </p:spPr>
         <p:txBody>
@@ -3001,45 +3563,85 @@
           <a:lstStyle>
             <a:lvl1pPr marL="0" indent="0">
               <a:buNone/>
-              <a:defRPr sz="1050"/>
+              <a:defRPr sz="1400">
+                <a:solidFill>
+                  <a:srgbClr val="111111"/>
+                </a:solidFill>
+              </a:defRPr>
             </a:lvl1pPr>
-            <a:lvl2pPr marL="342900" indent="0">
+            <a:lvl2pPr marL="457200" indent="0">
               <a:buNone/>
-              <a:defRPr sz="900"/>
+              <a:defRPr sz="1200">
+                <a:solidFill>
+                  <a:srgbClr val="111111"/>
+                </a:solidFill>
+              </a:defRPr>
             </a:lvl2pPr>
-            <a:lvl3pPr marL="685800" indent="0">
+            <a:lvl3pPr marL="914400" indent="0">
               <a:buNone/>
-              <a:defRPr sz="750"/>
+              <a:defRPr sz="1000">
+                <a:solidFill>
+                  <a:srgbClr val="111111"/>
+                </a:solidFill>
+              </a:defRPr>
             </a:lvl3pPr>
-            <a:lvl4pPr marL="1028700" indent="0">
+            <a:lvl4pPr marL="1371600" indent="0">
               <a:buNone/>
-              <a:defRPr sz="675"/>
+              <a:defRPr sz="900">
+                <a:solidFill>
+                  <a:srgbClr val="111111"/>
+                </a:solidFill>
+              </a:defRPr>
             </a:lvl4pPr>
-            <a:lvl5pPr marL="1371600" indent="0">
+            <a:lvl5pPr marL="1828800" indent="0">
               <a:buNone/>
-              <a:defRPr sz="675"/>
+              <a:defRPr sz="900">
+                <a:solidFill>
+                  <a:srgbClr val="111111"/>
+                </a:solidFill>
+              </a:defRPr>
             </a:lvl5pPr>
-            <a:lvl6pPr marL="1714500" indent="0">
+            <a:lvl6pPr marL="2286000" indent="0">
               <a:buNone/>
-              <a:defRPr sz="675"/>
+              <a:defRPr sz="900">
+                <a:solidFill>
+                  <a:srgbClr val="111111"/>
+                </a:solidFill>
+              </a:defRPr>
             </a:lvl6pPr>
-            <a:lvl7pPr marL="2057400" indent="0">
+            <a:lvl7pPr marL="2743200" indent="0">
               <a:buNone/>
-              <a:defRPr sz="675"/>
+              <a:defRPr sz="900">
+                <a:solidFill>
+                  <a:srgbClr val="111111"/>
+                </a:solidFill>
+              </a:defRPr>
             </a:lvl7pPr>
-            <a:lvl8pPr marL="2400300" indent="0">
+            <a:lvl8pPr marL="3200400" indent="0">
               <a:buNone/>
-              <a:defRPr sz="675"/>
+              <a:defRPr sz="900">
+                <a:solidFill>
+                  <a:srgbClr val="111111"/>
+                </a:solidFill>
+              </a:defRPr>
             </a:lvl8pPr>
-            <a:lvl9pPr marL="2743200" indent="0">
+            <a:lvl9pPr marL="3657600" indent="0">
               <a:buNone/>
-              <a:defRPr sz="675"/>
+              <a:defRPr sz="900">
+                <a:solidFill>
+                  <a:srgbClr val="111111"/>
+                </a:solidFill>
+              </a:defRPr>
             </a:lvl9pPr>
           </a:lstStyle>
           <a:p>
             <a:pPr lvl="0"/>
             <a:r>
-              <a:rPr lang="en-US"/>
+              <a:rPr lang="en-US" smtClean="0">
+                <a:solidFill>
+                  <a:srgbClr val="111111"/>
+                </a:solidFill>
+              </a:rPr>
               <a:t>Click to edit Master text styles</a:t>
             </a:r>
           </a:p>
@@ -3060,9 +3662,13 @@
           <a:bodyPr/>
           <a:lstStyle/>
           <a:p>
-            <a:fld id="{241EB5C9-1307-BA42-ABA2-0BC069CD8E7F}" type="datetimeFigureOut">
-              <a:rPr lang="en-US" smtClean="0"/>
-              <a:t>1/2/22</a:t>
+            <a:fld id="{5BCAD085-E8A6-8845-BD4E-CB4CCA059FC4}" type="datetimeFigureOut">
+              <a:rPr lang="en-US" smtClean="0">
+                <a:solidFill>
+                  <a:srgbClr val="111111"/>
+                </a:solidFill>
+              </a:rPr>
+              <a:t>1/27/13</a:t>
             </a:fld>
             <a:endParaRPr lang="en-US"/>
           </a:p>
@@ -3102,8 +3708,12 @@
           <a:bodyPr/>
           <a:lstStyle/>
           <a:p>
-            <a:fld id="{C5EF2332-01BF-834F-8236-50238282D533}" type="slidenum">
-              <a:rPr lang="en-US" smtClean="0"/>
+            <a:fld id="{C1FF6DA9-008F-8B48-92A6-B652298478BF}" type="slidenum">
+              <a:rPr lang="en-US" smtClean="0">
+                <a:solidFill>
+                  <a:srgbClr val="111111"/>
+                </a:solidFill>
+              </a:rPr>
               <a:t>‹#›</a:t>
             </a:fld>
             <a:endParaRPr lang="en-US"/>
@@ -3113,7 +3723,7 @@
     </p:spTree>
     <p:extLst>
       <p:ext uri="{BB962C8B-B14F-4D97-AF65-F5344CB8AC3E}">
-        <p14:creationId xmlns:p14="http://schemas.microsoft.com/office/powerpoint/2010/main" val="3566899855"/>
+        <p14:creationId xmlns:p14="http://schemas.microsoft.com/office/powerpoint/2010/main" val="3889236939"/>
       </p:ext>
     </p:extLst>
   </p:cSld>
@@ -3127,9 +3737,12 @@
 <p:sldMaster xmlns:a="http://schemas.openxmlformats.org/drawingml/2006/main" xmlns:p="http://schemas.openxmlformats.org/presentationml/2006/main" xmlns:r="http://schemas.openxmlformats.org/officeDocument/2006/relationships">
   <p:cSld>
     <p:bg>
-      <p:bgRef idx="1001">
-        <a:schemeClr val="bg1"/>
-      </p:bgRef>
+      <p:bgPr>
+        <a:solidFill>
+          <a:srgbClr val="FFFFFF"/>
+        </a:solidFill>
+        <a:effectLst/>
+      </p:bgPr>
     </p:bg>
     <p:spTree>
       <p:nvGrpSpPr>
@@ -3157,8 +3770,8 @@
         </p:nvSpPr>
         <p:spPr>
           <a:xfrm>
-            <a:off x="457200" y="205979"/>
-            <a:ext cx="8229600" cy="857250"/>
+            <a:off x="457200" y="274638"/>
+            <a:ext cx="8229600" cy="1143000"/>
           </a:xfrm>
           <a:prstGeom prst="rect">
             <a:avLst/>
@@ -3171,9 +3784,14 @@
           <a:lstStyle/>
           <a:p>
             <a:r>
-              <a:rPr lang="en-US"/>
+              <a:rPr lang="en-US" smtClean="0">
+                <a:solidFill>
+                  <a:srgbClr val="111111"/>
+                </a:solidFill>
+              </a:rPr>
               <a:t>Click to edit Master title style</a:t>
             </a:r>
+            <a:endParaRPr lang="en-US"/>
           </a:p>
         </p:txBody>
       </p:sp>
@@ -3189,8 +3807,8 @@
         </p:nvSpPr>
         <p:spPr>
           <a:xfrm>
-            <a:off x="457200" y="1200151"/>
-            <a:ext cx="8229600" cy="3394472"/>
+            <a:off x="457200" y="1600200"/>
+            <a:ext cx="8229600" cy="4525963"/>
           </a:xfrm>
           <a:prstGeom prst="rect">
             <a:avLst/>
@@ -3204,37 +3822,58 @@
           <a:p>
             <a:pPr lvl="0"/>
             <a:r>
-              <a:rPr lang="en-US"/>
+              <a:rPr lang="en-US" smtClean="0">
+                <a:solidFill>
+                  <a:srgbClr val="111111"/>
+                </a:solidFill>
+              </a:rPr>
               <a:t>Click to edit Master text styles</a:t>
             </a:r>
           </a:p>
           <a:p>
             <a:pPr lvl="1"/>
             <a:r>
-              <a:rPr lang="en-US"/>
+              <a:rPr lang="en-US" smtClean="0">
+                <a:solidFill>
+                  <a:srgbClr val="111111"/>
+                </a:solidFill>
+              </a:rPr>
               <a:t>Second level</a:t>
             </a:r>
           </a:p>
           <a:p>
             <a:pPr lvl="2"/>
             <a:r>
-              <a:rPr lang="en-US"/>
+              <a:rPr lang="en-US" smtClean="0">
+                <a:solidFill>
+                  <a:srgbClr val="111111"/>
+                </a:solidFill>
+              </a:rPr>
               <a:t>Third level</a:t>
             </a:r>
           </a:p>
           <a:p>
             <a:pPr lvl="3"/>
             <a:r>
-              <a:rPr lang="en-US"/>
+              <a:rPr lang="en-US" smtClean="0">
+                <a:solidFill>
+                  <a:srgbClr val="111111"/>
+                </a:solidFill>
+              </a:rPr>
               <a:t>Fourth level</a:t>
             </a:r>
           </a:p>
           <a:p>
             <a:pPr lvl="4"/>
             <a:r>
-              <a:rPr lang="en-US"/>
+              <a:rPr lang="en-US" smtClean="0">
+                <a:solidFill>
+                  <a:srgbClr val="111111"/>
+                </a:solidFill>
+              </a:rPr>
               <a:t>Fifth level</a:t>
             </a:r>
+            <a:endParaRPr lang="en-US"/>
           </a:p>
         </p:txBody>
       </p:sp>
@@ -3250,8 +3889,8 @@
         </p:nvSpPr>
         <p:spPr>
           <a:xfrm>
-            <a:off x="457200" y="4767263"/>
-            <a:ext cx="2133600" cy="273844"/>
+            <a:off x="457200" y="6356350"/>
+            <a:ext cx="2133600" cy="365125"/>
           </a:xfrm>
           <a:prstGeom prst="rect">
             <a:avLst/>
@@ -3261,19 +3900,21 @@
           <a:bodyPr anchor="ctr" bIns="45720" lIns="91440" rIns="91440" rtlCol="0" tIns="45720" vert="horz"/>
           <a:lstStyle>
             <a:lvl1pPr algn="l">
-              <a:defRPr sz="900">
-                <a:solidFill>
-                  <a:schemeClr val="tx1">
-                    <a:tint val="75000"/>
-                  </a:schemeClr>
+              <a:defRPr sz="1200">
+                <a:solidFill>
+                  <a:srgbClr val="111111"/>
                 </a:solidFill>
               </a:defRPr>
             </a:lvl1pPr>
           </a:lstStyle>
           <a:p>
-            <a:fld id="{241EB5C9-1307-BA42-ABA2-0BC069CD8E7F}" type="datetimeFigureOut">
-              <a:rPr lang="en-US" smtClean="0"/>
-              <a:t>1/2/22</a:t>
+            <a:fld id="{5BCAD085-E8A6-8845-BD4E-CB4CCA059FC4}" type="datetimeFigureOut">
+              <a:rPr lang="en-US" smtClean="0">
+                <a:solidFill>
+                  <a:srgbClr val="111111"/>
+                </a:solidFill>
+              </a:rPr>
+              <a:t>1/27/13</a:t>
             </a:fld>
             <a:endParaRPr lang="en-US"/>
           </a:p>
@@ -3291,8 +3932,8 @@
         </p:nvSpPr>
         <p:spPr>
           <a:xfrm>
-            <a:off x="3124200" y="4767263"/>
-            <a:ext cx="2895600" cy="273844"/>
+            <a:off x="3124200" y="6356350"/>
+            <a:ext cx="2895600" cy="365125"/>
           </a:xfrm>
           <a:prstGeom prst="rect">
             <a:avLst/>
@@ -3302,11 +3943,9 @@
           <a:bodyPr anchor="ctr" bIns="45720" lIns="91440" rIns="91440" rtlCol="0" tIns="45720" vert="horz"/>
           <a:lstStyle>
             <a:lvl1pPr algn="ctr">
-              <a:defRPr sz="900">
-                <a:solidFill>
-                  <a:schemeClr val="tx1">
-                    <a:tint val="75000"/>
-                  </a:schemeClr>
+              <a:defRPr sz="1200">
+                <a:solidFill>
+                  <a:srgbClr val="111111"/>
                 </a:solidFill>
               </a:defRPr>
             </a:lvl1pPr>
@@ -3328,8 +3967,8 @@
         </p:nvSpPr>
         <p:spPr>
           <a:xfrm>
-            <a:off x="6553200" y="4767263"/>
-            <a:ext cx="2133600" cy="273844"/>
+            <a:off x="6553200" y="6356350"/>
+            <a:ext cx="2133600" cy="365125"/>
           </a:xfrm>
           <a:prstGeom prst="rect">
             <a:avLst/>
@@ -3339,18 +3978,20 @@
           <a:bodyPr anchor="ctr" bIns="45720" lIns="91440" rIns="91440" rtlCol="0" tIns="45720" vert="horz"/>
           <a:lstStyle>
             <a:lvl1pPr algn="r">
-              <a:defRPr sz="900">
-                <a:solidFill>
-                  <a:schemeClr val="tx1">
-                    <a:tint val="75000"/>
-                  </a:schemeClr>
+              <a:defRPr sz="1200">
+                <a:solidFill>
+                  <a:srgbClr val="111111"/>
                 </a:solidFill>
               </a:defRPr>
             </a:lvl1pPr>
           </a:lstStyle>
           <a:p>
-            <a:fld id="{C5EF2332-01BF-834F-8236-50238282D533}" type="slidenum">
-              <a:rPr lang="en-US" smtClean="0"/>
+            <a:fld id="{C1FF6DA9-008F-8B48-92A6-B652298478BF}" type="slidenum">
+              <a:rPr lang="en-US" smtClean="0">
+                <a:solidFill>
+                  <a:srgbClr val="111111"/>
+                </a:solidFill>
+              </a:rPr>
               <a:t>‹#›</a:t>
             </a:fld>
             <a:endParaRPr lang="en-US"/>
@@ -3360,7 +4001,7 @@
     </p:spTree>
     <p:extLst>
       <p:ext uri="{BB962C8B-B14F-4D97-AF65-F5344CB8AC3E}">
-        <p14:creationId xmlns:p14="http://schemas.microsoft.com/office/powerpoint/2010/main" val="3676200875"/>
+        <p14:creationId xmlns:p14="http://schemas.microsoft.com/office/powerpoint/2010/main" val="2209977519"/>
       </p:ext>
     </p:extLst>
   </p:cSld>
@@ -3380,250 +4021,254 @@
   </p:sldLayoutIdLst>
   <p:txStyles>
     <p:titleStyle>
-      <a:lvl1pPr algn="ctr" defTabSz="342900" eaLnBrk="1" hangingPunct="1" latinLnBrk="0" rtl="0">
+      <a:lvl1pPr algn="ctr" defTabSz="457200" eaLnBrk="1" hangingPunct="1" latinLnBrk="0" rtl="0">
         <a:spcBef>
           <a:spcPct val="0"/>
         </a:spcBef>
         <a:buNone/>
-        <a:defRPr kern="1200" sz="3300">
-          <a:solidFill>
-            <a:schemeClr val="tx1"/>
-          </a:solidFill>
-          <a:latin typeface="+mj-lt"/>
+        <a:defRPr kern="1200" sz="4400">
+          <a:latin typeface="Cambria"/>
           <a:ea typeface="+mj-ea"/>
           <a:cs typeface="+mj-cs"/>
+          <a:solidFill>
+            <a:srgbClr val="111111"/>
+          </a:solidFill>
         </a:defRPr>
       </a:lvl1pPr>
     </p:titleStyle>
     <p:bodyStyle>
-      <a:lvl1pPr algn="l" defTabSz="342900" eaLnBrk="1" hangingPunct="1" indent="-342900" latinLnBrk="0" marL="342900" rtl="0">
+      <a:lvl1pPr algn="l" defTabSz="457200" eaLnBrk="1" hangingPunct="1" indent="-342900" latinLnBrk="0" marL="342900" rtl="0">
+        <a:spcBef>
+          <a:spcPct val="20000"/>
+        </a:spcBef>
+        <a:buFont typeface="Arial"/>
+        <a:buChar char="•"/>
+        <a:defRPr kern="1200" sz="3200">
+          <a:latin typeface="Cambria"/>
+          <a:ea typeface="+mn-ea"/>
+          <a:cs typeface="+mn-cs"/>
+          <a:solidFill>
+            <a:srgbClr val="111111"/>
+          </a:solidFill>
+        </a:defRPr>
+      </a:lvl1pPr>
+      <a:lvl2pPr algn="l" defTabSz="457200" eaLnBrk="1" hangingPunct="1" indent="-285750" latinLnBrk="0" marL="742950" rtl="0">
+        <a:spcBef>
+          <a:spcPct val="20000"/>
+        </a:spcBef>
+        <a:buFont typeface="Arial"/>
+        <a:buChar char="–"/>
+        <a:defRPr kern="1200" sz="2800">
+          <a:latin typeface="Cambria"/>
+          <a:ea typeface="+mn-ea"/>
+          <a:cs typeface="+mn-cs"/>
+          <a:solidFill>
+            <a:srgbClr val="111111"/>
+          </a:solidFill>
+        </a:defRPr>
+      </a:lvl2pPr>
+      <a:lvl3pPr algn="l" defTabSz="457200" eaLnBrk="1" hangingPunct="1" indent="-228600" latinLnBrk="0" marL="1143000" rtl="0">
         <a:spcBef>
           <a:spcPct val="20000"/>
         </a:spcBef>
         <a:buFont typeface="Arial"/>
         <a:buChar char="•"/>
         <a:defRPr kern="1200" sz="2400">
-          <a:solidFill>
-            <a:schemeClr val="tx1"/>
-          </a:solidFill>
-          <a:latin typeface="+mn-lt"/>
+          <a:latin typeface="Cambria"/>
           <a:ea typeface="+mn-ea"/>
           <a:cs typeface="+mn-cs"/>
+          <a:solidFill>
+            <a:srgbClr val="111111"/>
+          </a:solidFill>
         </a:defRPr>
-      </a:lvl1pPr>
-      <a:lvl2pPr algn="l" defTabSz="342900" eaLnBrk="1" hangingPunct="1" indent="-342900" latinLnBrk="0" marL="685800" rtl="0">
+      </a:lvl3pPr>
+      <a:lvl4pPr algn="l" defTabSz="457200" eaLnBrk="1" hangingPunct="1" indent="-228600" latinLnBrk="0" marL="1600200" rtl="0">
         <a:spcBef>
           <a:spcPct val="20000"/>
         </a:spcBef>
         <a:buFont typeface="Arial"/>
         <a:buChar char="–"/>
-        <a:defRPr kern="1200" sz="2100">
-          <a:solidFill>
-            <a:schemeClr val="tx1"/>
-          </a:solidFill>
-          <a:latin typeface="+mn-lt"/>
+        <a:defRPr kern="1200" sz="2000">
+          <a:latin typeface="Cambria"/>
           <a:ea typeface="+mn-ea"/>
           <a:cs typeface="+mn-cs"/>
+          <a:solidFill>
+            <a:srgbClr val="111111"/>
+          </a:solidFill>
         </a:defRPr>
-      </a:lvl2pPr>
-      <a:lvl3pPr algn="l" defTabSz="342900" eaLnBrk="1" hangingPunct="1" indent="-342900" latinLnBrk="0" marL="1028700" rtl="0">
+      </a:lvl4pPr>
+      <a:lvl5pPr algn="l" defTabSz="457200" eaLnBrk="1" hangingPunct="1" indent="-228600" latinLnBrk="0" marL="2057400" rtl="0">
+        <a:spcBef>
+          <a:spcPct val="20000"/>
+        </a:spcBef>
+        <a:buFont typeface="Arial"/>
+        <a:buChar char="»"/>
+        <a:defRPr kern="1200" sz="2000">
+          <a:latin typeface="Cambria"/>
+          <a:ea typeface="+mn-ea"/>
+          <a:cs typeface="+mn-cs"/>
+          <a:solidFill>
+            <a:srgbClr val="111111"/>
+          </a:solidFill>
+        </a:defRPr>
+      </a:lvl5pPr>
+      <a:lvl6pPr algn="l" defTabSz="457200" eaLnBrk="1" hangingPunct="1" indent="-228600" latinLnBrk="0" marL="2514600" rtl="0">
         <a:spcBef>
           <a:spcPct val="20000"/>
         </a:spcBef>
         <a:buFont typeface="Arial"/>
         <a:buChar char="•"/>
-        <a:defRPr kern="1200" sz="1800">
-          <a:solidFill>
-            <a:schemeClr val="tx1"/>
-          </a:solidFill>
-          <a:latin typeface="+mn-lt"/>
+        <a:defRPr kern="1200" sz="2000">
+          <a:latin typeface="Cambria"/>
           <a:ea typeface="+mn-ea"/>
           <a:cs typeface="+mn-cs"/>
+          <a:solidFill>
+            <a:srgbClr val="111111"/>
+          </a:solidFill>
         </a:defRPr>
-      </a:lvl3pPr>
-      <a:lvl4pPr algn="l" defTabSz="342900" eaLnBrk="1" hangingPunct="1" indent="-342900" latinLnBrk="0" marL="1371600" rtl="0">
-        <a:spcBef>
-          <a:spcPct val="20000"/>
-        </a:spcBef>
-        <a:buFont typeface="Arial"/>
-        <a:buChar char="–"/>
-        <a:defRPr kern="1200" sz="1500">
-          <a:solidFill>
-            <a:schemeClr val="tx1"/>
-          </a:solidFill>
-          <a:latin typeface="+mn-lt"/>
-          <a:ea typeface="+mn-ea"/>
-          <a:cs typeface="+mn-cs"/>
-        </a:defRPr>
-      </a:lvl4pPr>
-      <a:lvl5pPr algn="l" defTabSz="342900" eaLnBrk="1" hangingPunct="1" indent="-342900" latinLnBrk="0" marL="1714500" rtl="0">
-        <a:spcBef>
-          <a:spcPct val="20000"/>
-        </a:spcBef>
-        <a:buFont typeface="Arial"/>
-        <a:buChar char="»"/>
-        <a:defRPr kern="1200" sz="1500">
-          <a:solidFill>
-            <a:schemeClr val="tx1"/>
-          </a:solidFill>
-          <a:latin typeface="+mn-lt"/>
-          <a:ea typeface="+mn-ea"/>
-          <a:cs typeface="+mn-cs"/>
-        </a:defRPr>
-      </a:lvl5pPr>
-      <a:lvl6pPr algn="l" defTabSz="342900" eaLnBrk="1" hangingPunct="1" indent="-342900" latinLnBrk="0" marL="2057400" rtl="0">
+      </a:lvl6pPr>
+      <a:lvl7pPr algn="l" defTabSz="457200" eaLnBrk="1" hangingPunct="1" indent="-228600" latinLnBrk="0" marL="2971800" rtl="0">
         <a:spcBef>
           <a:spcPct val="20000"/>
         </a:spcBef>
         <a:buFont typeface="Arial"/>
         <a:buChar char="•"/>
-        <a:defRPr kern="1200" sz="1500">
-          <a:solidFill>
-            <a:schemeClr val="tx1"/>
-          </a:solidFill>
-          <a:latin typeface="+mn-lt"/>
+        <a:defRPr kern="1200" sz="2000">
+          <a:latin typeface="Cambria"/>
           <a:ea typeface="+mn-ea"/>
           <a:cs typeface="+mn-cs"/>
+          <a:solidFill>
+            <a:srgbClr val="111111"/>
+          </a:solidFill>
         </a:defRPr>
-      </a:lvl6pPr>
-      <a:lvl7pPr algn="l" defTabSz="342900" eaLnBrk="1" hangingPunct="1" indent="-342900" latinLnBrk="0" marL="2400300" rtl="0">
+      </a:lvl7pPr>
+      <a:lvl8pPr algn="l" defTabSz="457200" eaLnBrk="1" hangingPunct="1" indent="-228600" latinLnBrk="0" marL="3429000" rtl="0">
         <a:spcBef>
           <a:spcPct val="20000"/>
         </a:spcBef>
         <a:buFont typeface="Arial"/>
         <a:buChar char="•"/>
-        <a:defRPr kern="1200" sz="1500">
-          <a:solidFill>
-            <a:schemeClr val="tx1"/>
-          </a:solidFill>
-          <a:latin typeface="+mn-lt"/>
+        <a:defRPr kern="1200" sz="2000">
+          <a:latin typeface="Cambria"/>
           <a:ea typeface="+mn-ea"/>
           <a:cs typeface="+mn-cs"/>
+          <a:solidFill>
+            <a:srgbClr val="111111"/>
+          </a:solidFill>
         </a:defRPr>
-      </a:lvl7pPr>
-      <a:lvl8pPr algn="l" defTabSz="342900" eaLnBrk="1" hangingPunct="1" indent="-342900" latinLnBrk="0" marL="2743200" rtl="0">
+      </a:lvl8pPr>
+      <a:lvl9pPr algn="l" defTabSz="457200" eaLnBrk="1" hangingPunct="1" indent="-228600" latinLnBrk="0" marL="3886200" rtl="0">
         <a:spcBef>
           <a:spcPct val="20000"/>
         </a:spcBef>
         <a:buFont typeface="Arial"/>
         <a:buChar char="•"/>
-        <a:defRPr kern="1200" sz="1500">
-          <a:solidFill>
-            <a:schemeClr val="tx1"/>
-          </a:solidFill>
-          <a:latin typeface="+mn-lt"/>
+        <a:defRPr kern="1200" sz="2000">
+          <a:latin typeface="Cambria"/>
           <a:ea typeface="+mn-ea"/>
           <a:cs typeface="+mn-cs"/>
-        </a:defRPr>
-      </a:lvl8pPr>
-      <a:lvl9pPr algn="l" defTabSz="342900" eaLnBrk="1" hangingPunct="1" indent="-342900" latinLnBrk="0" marL="3086100" rtl="0">
-        <a:spcBef>
-          <a:spcPct val="20000"/>
-        </a:spcBef>
-        <a:buFont typeface="Arial"/>
-        <a:buChar char="•"/>
-        <a:defRPr kern="1200" sz="1500">
           <a:solidFill>
-            <a:schemeClr val="tx1"/>
+            <a:srgbClr val="111111"/>
           </a:solidFill>
-          <a:latin typeface="+mn-lt"/>
-          <a:ea typeface="+mn-ea"/>
-          <a:cs typeface="+mn-cs"/>
         </a:defRPr>
       </a:lvl9pPr>
     </p:bodyStyle>
     <p:otherStyle>
       <a:defPPr>
-        <a:defRPr lang="en-US"/>
+        <a:defRPr lang="en-US">
+          <a:solidFill>
+            <a:srgbClr val="111111"/>
+          </a:solidFill>
+        </a:defRPr>
       </a:defPPr>
-      <a:lvl1pPr algn="l" defTabSz="342900" eaLnBrk="1" hangingPunct="1" latinLnBrk="0" marL="0" rtl="0">
-        <a:defRPr kern="1200" sz="1350">
-          <a:solidFill>
-            <a:schemeClr val="tx1"/>
-          </a:solidFill>
-          <a:latin typeface="+mn-lt"/>
+      <a:lvl1pPr algn="l" defTabSz="457200" eaLnBrk="1" hangingPunct="1" latinLnBrk="0" marL="0" rtl="0">
+        <a:defRPr kern="1200" sz="1800">
+          <a:latin typeface="Cambria"/>
           <a:ea typeface="+mn-ea"/>
           <a:cs typeface="+mn-cs"/>
+          <a:solidFill>
+            <a:srgbClr val="111111"/>
+          </a:solidFill>
         </a:defRPr>
       </a:lvl1pPr>
-      <a:lvl2pPr algn="l" defTabSz="342900" eaLnBrk="1" hangingPunct="1" latinLnBrk="0" marL="342900" rtl="0">
-        <a:defRPr kern="1200" sz="1350">
-          <a:solidFill>
-            <a:schemeClr val="tx1"/>
-          </a:solidFill>
-          <a:latin typeface="+mn-lt"/>
+      <a:lvl2pPr algn="l" defTabSz="457200" eaLnBrk="1" hangingPunct="1" latinLnBrk="0" marL="457200" rtl="0">
+        <a:defRPr kern="1200" sz="1800">
+          <a:latin typeface="Cambria"/>
           <a:ea typeface="+mn-ea"/>
           <a:cs typeface="+mn-cs"/>
+          <a:solidFill>
+            <a:srgbClr val="111111"/>
+          </a:solidFill>
         </a:defRPr>
       </a:lvl2pPr>
-      <a:lvl3pPr algn="l" defTabSz="342900" eaLnBrk="1" hangingPunct="1" latinLnBrk="0" marL="685800" rtl="0">
-        <a:defRPr kern="1200" sz="1350">
-          <a:solidFill>
-            <a:schemeClr val="tx1"/>
-          </a:solidFill>
-          <a:latin typeface="+mn-lt"/>
+      <a:lvl3pPr algn="l" defTabSz="457200" eaLnBrk="1" hangingPunct="1" latinLnBrk="0" marL="914400" rtl="0">
+        <a:defRPr kern="1200" sz="1800">
+          <a:latin typeface="Cambria"/>
           <a:ea typeface="+mn-ea"/>
           <a:cs typeface="+mn-cs"/>
+          <a:solidFill>
+            <a:srgbClr val="111111"/>
+          </a:solidFill>
         </a:defRPr>
       </a:lvl3pPr>
-      <a:lvl4pPr algn="l" defTabSz="342900" eaLnBrk="1" hangingPunct="1" latinLnBrk="0" marL="1028700" rtl="0">
-        <a:defRPr kern="1200" sz="1350">
-          <a:solidFill>
-            <a:schemeClr val="tx1"/>
-          </a:solidFill>
-          <a:latin typeface="+mn-lt"/>
+      <a:lvl4pPr algn="l" defTabSz="457200" eaLnBrk="1" hangingPunct="1" latinLnBrk="0" marL="1371600" rtl="0">
+        <a:defRPr kern="1200" sz="1800">
+          <a:latin typeface="Cambria"/>
           <a:ea typeface="+mn-ea"/>
           <a:cs typeface="+mn-cs"/>
+          <a:solidFill>
+            <a:srgbClr val="111111"/>
+          </a:solidFill>
         </a:defRPr>
       </a:lvl4pPr>
-      <a:lvl5pPr algn="l" defTabSz="342900" eaLnBrk="1" hangingPunct="1" latinLnBrk="0" marL="1371600" rtl="0">
-        <a:defRPr kern="1200" sz="1350">
-          <a:solidFill>
-            <a:schemeClr val="tx1"/>
-          </a:solidFill>
-          <a:latin typeface="+mn-lt"/>
+      <a:lvl5pPr algn="l" defTabSz="457200" eaLnBrk="1" hangingPunct="1" latinLnBrk="0" marL="1828800" rtl="0">
+        <a:defRPr kern="1200" sz="1800">
+          <a:latin typeface="Cambria"/>
           <a:ea typeface="+mn-ea"/>
           <a:cs typeface="+mn-cs"/>
+          <a:solidFill>
+            <a:srgbClr val="111111"/>
+          </a:solidFill>
         </a:defRPr>
       </a:lvl5pPr>
-      <a:lvl6pPr algn="l" defTabSz="342900" eaLnBrk="1" hangingPunct="1" latinLnBrk="0" marL="1714500" rtl="0">
-        <a:defRPr kern="1200" sz="1350">
-          <a:solidFill>
-            <a:schemeClr val="tx1"/>
-          </a:solidFill>
-          <a:latin typeface="+mn-lt"/>
+      <a:lvl6pPr algn="l" defTabSz="457200" eaLnBrk="1" hangingPunct="1" latinLnBrk="0" marL="2286000" rtl="0">
+        <a:defRPr kern="1200" sz="1800">
+          <a:latin typeface="Cambria"/>
           <a:ea typeface="+mn-ea"/>
           <a:cs typeface="+mn-cs"/>
+          <a:solidFill>
+            <a:srgbClr val="111111"/>
+          </a:solidFill>
         </a:defRPr>
       </a:lvl6pPr>
-      <a:lvl7pPr algn="l" defTabSz="342900" eaLnBrk="1" hangingPunct="1" latinLnBrk="0" marL="2057400" rtl="0">
-        <a:defRPr kern="1200" sz="1350">
-          <a:solidFill>
-            <a:schemeClr val="tx1"/>
-          </a:solidFill>
-          <a:latin typeface="+mn-lt"/>
+      <a:lvl7pPr algn="l" defTabSz="457200" eaLnBrk="1" hangingPunct="1" latinLnBrk="0" marL="2743200" rtl="0">
+        <a:defRPr kern="1200" sz="1800">
+          <a:latin typeface="Cambria"/>
           <a:ea typeface="+mn-ea"/>
           <a:cs typeface="+mn-cs"/>
+          <a:solidFill>
+            <a:srgbClr val="111111"/>
+          </a:solidFill>
         </a:defRPr>
       </a:lvl7pPr>
-      <a:lvl8pPr algn="l" defTabSz="342900" eaLnBrk="1" hangingPunct="1" latinLnBrk="0" marL="2400300" rtl="0">
-        <a:defRPr kern="1200" sz="1350">
-          <a:solidFill>
-            <a:schemeClr val="tx1"/>
-          </a:solidFill>
-          <a:latin typeface="+mn-lt"/>
+      <a:lvl8pPr algn="l" defTabSz="457200" eaLnBrk="1" hangingPunct="1" latinLnBrk="0" marL="3200400" rtl="0">
+        <a:defRPr kern="1200" sz="1800">
+          <a:latin typeface="Cambria"/>
           <a:ea typeface="+mn-ea"/>
           <a:cs typeface="+mn-cs"/>
+          <a:solidFill>
+            <a:srgbClr val="111111"/>
+          </a:solidFill>
         </a:defRPr>
       </a:lvl8pPr>
-      <a:lvl9pPr algn="l" defTabSz="342900" eaLnBrk="1" hangingPunct="1" latinLnBrk="0" marL="2743200" rtl="0">
-        <a:defRPr kern="1200" sz="1350">
-          <a:solidFill>
-            <a:schemeClr val="tx1"/>
-          </a:solidFill>
-          <a:latin typeface="+mn-lt"/>
+      <a:lvl9pPr algn="l" defTabSz="457200" eaLnBrk="1" hangingPunct="1" latinLnBrk="0" marL="3657600" rtl="0">
+        <a:defRPr kern="1200" sz="1800">
+          <a:latin typeface="Cambria"/>
           <a:ea typeface="+mn-ea"/>
           <a:cs typeface="+mn-cs"/>
+          <a:solidFill>
+            <a:srgbClr val="111111"/>
+          </a:solidFill>
         </a:defRPr>
       </a:lvl9pPr>
     </p:otherStyle>
@@ -3660,8 +4305,8 @@
         </p:nvSpPr>
         <p:spPr>
           <a:xfrm>
-            <a:off x="685800" y="1597819"/>
-            <a:ext cx="7772400" cy="1102519"/>
+            <a:off x="685800" y="2130425"/>
+            <a:ext cx="7772400" cy="1470025"/>
           </a:xfrm>
         </p:spPr>
         <p:txBody>
@@ -3690,8 +4335,8 @@
         </p:nvSpPr>
         <p:spPr>
           <a:xfrm>
-            <a:off x="1371600" y="2914650"/>
-            <a:ext cx="6400800" cy="1314450"/>
+            <a:off x="1371600" y="3886200"/>
+            <a:ext cx="6400800" cy="1752600"/>
           </a:xfrm>
         </p:spPr>
         <p:txBody>
@@ -4120,7 +4765,7 @@
           <a:bodyPr/>
           <a:lstStyle/>
           <a:p>
-            <a:pPr lvl="0" indent="-342900" marL="342900">
+            <a:pPr lvl="0" indent="-457200" marL="457200">
               <a:buAutoNum type="arabicPeriod"/>
             </a:pPr>
             <a:r>
@@ -4147,7 +4792,7 @@
             </a:r>
           </a:p>
           <a:p>
-            <a:pPr lvl="0" indent="-342900" marL="342900">
+            <a:pPr lvl="0" indent="-457200" marL="457200">
               <a:buAutoNum type="arabicPeriod"/>
             </a:pPr>
             <a:r>
@@ -4164,7 +4809,7 @@
             </a:r>
           </a:p>
           <a:p>
-            <a:pPr lvl="0" indent="-342900" marL="342900">
+            <a:pPr lvl="0" indent="-457200" marL="457200">
               <a:buAutoNum type="arabicPeriod"/>
             </a:pPr>
             <a:r>
@@ -4191,7 +4836,7 @@
             </a:r>
           </a:p>
           <a:p>
-            <a:pPr lvl="0" indent="-342900" marL="342900">
+            <a:pPr lvl="0" indent="-457200" marL="457200">
               <a:buAutoNum type="arabicPeriod"/>
             </a:pPr>
             <a:r>
@@ -4218,7 +4863,7 @@
             </a:r>
           </a:p>
           <a:p>
-            <a:pPr lvl="0" indent="-342900" marL="342900">
+            <a:pPr lvl="0" indent="-457200" marL="457200">
               <a:buAutoNum type="arabicPeriod"/>
             </a:pPr>
             <a:r>
@@ -4577,7 +5222,7 @@
             </a:r>
           </a:p>
           <a:p>
-            <a:pPr lvl="0" indent="-342900" marL="342900">
+            <a:pPr lvl="0" indent="-457200" marL="457200">
               <a:buAutoNum type="arabicPeriod"/>
             </a:pPr>
             <a:r>
@@ -4590,7 +5235,7 @@
             </a:r>
           </a:p>
           <a:p>
-            <a:pPr lvl="0" indent="-342900" marL="342900">
+            <a:pPr lvl="0" indent="-457200" marL="457200">
               <a:buAutoNum type="arabicPeriod"/>
             </a:pPr>
             <a:r>
@@ -4603,7 +5248,7 @@
             </a:r>
           </a:p>
           <a:p>
-            <a:pPr lvl="0" indent="-342900" marL="342900">
+            <a:pPr lvl="0" indent="-457200" marL="457200">
               <a:buAutoNum type="arabicPeriod"/>
             </a:pPr>
             <a:r>
@@ -5143,7 +5788,7 @@
             </a:r>
           </a:p>
           <a:p>
-            <a:pPr lvl="0" indent="-342900" marL="342900">
+            <a:pPr lvl="0" indent="-457200" marL="457200">
               <a:buAutoNum type="arabicPeriod"/>
             </a:pPr>
             <a:r>
@@ -5156,7 +5801,7 @@
             </a:r>
           </a:p>
           <a:p>
-            <a:pPr lvl="0" indent="-342900" marL="342900">
+            <a:pPr lvl="0" indent="-457200" marL="457200">
               <a:buAutoNum type="arabicPeriod"/>
             </a:pPr>
             <a:r>
@@ -5173,7 +5818,7 @@
             </a:r>
           </a:p>
           <a:p>
-            <a:pPr lvl="0" indent="-342900" marL="342900">
+            <a:pPr lvl="0" indent="-457200" marL="457200">
               <a:buAutoNum type="arabicPeriod"/>
             </a:pPr>
             <a:r>
@@ -5186,7 +5831,7 @@
             </a:r>
           </a:p>
           <a:p>
-            <a:pPr lvl="0" indent="-342900" marL="342900">
+            <a:pPr lvl="0" indent="-457200" marL="457200">
               <a:buAutoNum type="arabicPeriod"/>
             </a:pPr>
             <a:r>
@@ -5454,7 +6099,7 @@
             </a:r>
           </a:p>
           <a:p>
-            <a:pPr lvl="0" indent="-342900" marL="342900">
+            <a:pPr lvl="0" indent="-457200" marL="457200">
               <a:buAutoNum type="arabicPeriod"/>
             </a:pPr>
             <a:r>
@@ -5467,7 +6112,7 @@
             </a:r>
           </a:p>
           <a:p>
-            <a:pPr lvl="0" indent="-342900" marL="342900">
+            <a:pPr lvl="0" indent="-457200" marL="457200">
               <a:buAutoNum type="arabicPeriod"/>
             </a:pPr>
             <a:r>
@@ -5480,7 +6125,7 @@
             </a:r>
           </a:p>
           <a:p>
-            <a:pPr lvl="0" indent="-342900" marL="342900">
+            <a:pPr lvl="0" indent="-457200" marL="457200">
               <a:buAutoNum type="arabicPeriod"/>
             </a:pPr>
             <a:r>
@@ -5493,7 +6138,7 @@
             </a:r>
           </a:p>
           <a:p>
-            <a:pPr lvl="0" indent="-342900" marL="342900">
+            <a:pPr lvl="0" indent="-457200" marL="457200">
               <a:buAutoNum type="arabicPeriod"/>
             </a:pPr>
             <a:r>
@@ -5942,8 +6587,8 @@
         </p:nvSpPr>
         <p:spPr>
           <a:xfrm>
-            <a:off x="722313" y="3305176"/>
-            <a:ext cx="7772400" cy="1021556"/>
+            <a:off x="722313" y="4406900"/>
+            <a:ext cx="7772400" cy="1362075"/>
           </a:xfrm>
         </p:spPr>
         <p:txBody>
@@ -6389,7 +7034,7 @@
           <a:bodyPr/>
           <a:lstStyle/>
           <a:p>
-            <a:pPr lvl="0" indent="-342900" marL="342900">
+            <a:pPr lvl="0" indent="-457200" marL="457200">
               <a:buAutoNum type="arabicPeriod"/>
             </a:pPr>
             <a:r>
@@ -6423,7 +7068,7 @@
             </a:r>
           </a:p>
           <a:p>
-            <a:pPr lvl="0" indent="-342900" marL="342900">
+            <a:pPr lvl="0" indent="-457200" marL="457200">
               <a:buAutoNum type="arabicPeriod"/>
             </a:pPr>
             <a:r>
@@ -6446,7 +7091,7 @@
             </a:r>
           </a:p>
           <a:p>
-            <a:pPr lvl="0" indent="-342900" marL="342900">
+            <a:pPr lvl="0" indent="-457200" marL="457200">
               <a:buAutoNum type="arabicPeriod"/>
             </a:pPr>
             <a:r>
@@ -6467,7 +7112,7 @@
             </a:r>
           </a:p>
           <a:p>
-            <a:pPr lvl="0" indent="-342900" marL="342900">
+            <a:pPr lvl="0" indent="-457200" marL="457200">
               <a:buAutoNum type="arabicPeriod"/>
             </a:pPr>
             <a:r>
@@ -7010,7 +7655,7 @@
           <a:bodyPr/>
           <a:lstStyle/>
           <a:p>
-            <a:pPr lvl="0" indent="-342900" marL="342900">
+            <a:pPr lvl="0" indent="-457200" marL="457200">
               <a:buAutoNum type="arabicPeriod"/>
             </a:pPr>
             <a:r>
@@ -7023,7 +7668,7 @@
             </a:r>
           </a:p>
           <a:p>
-            <a:pPr lvl="0" indent="-342900" marL="342900">
+            <a:pPr lvl="0" indent="-457200" marL="457200">
               <a:buAutoNum type="arabicPeriod"/>
             </a:pPr>
             <a:r>
@@ -7036,7 +7681,7 @@
             </a:r>
           </a:p>
           <a:p>
-            <a:pPr lvl="0" indent="-342900" marL="342900">
+            <a:pPr lvl="0" indent="-457200" marL="457200">
               <a:buAutoNum type="arabicPeriod"/>
             </a:pPr>
             <a:r>
@@ -7049,7 +7694,7 @@
             </a:r>
           </a:p>
           <a:p>
-            <a:pPr lvl="0" indent="-342900" marL="342900">
+            <a:pPr lvl="0" indent="-457200" marL="457200">
               <a:buAutoNum type="arabicPeriod"/>
             </a:pPr>
             <a:r>
@@ -7070,7 +7715,7 @@
             </a:r>
           </a:p>
           <a:p>
-            <a:pPr lvl="0" indent="-342900" marL="342900">
+            <a:pPr lvl="0" indent="-457200" marL="457200">
               <a:buAutoNum type="arabicPeriod"/>
             </a:pPr>
             <a:r>
@@ -10121,8 +10766,8 @@
         </p:nvSpPr>
         <p:spPr>
           <a:xfrm>
-            <a:off x="722313" y="3305176"/>
-            <a:ext cx="7772400" cy="1021556"/>
+            <a:off x="722313" y="4406900"/>
+            <a:ext cx="7772400" cy="1362075"/>
           </a:xfrm>
         </p:spPr>
         <p:txBody>
@@ -14187,7 +14832,7 @@
           <a:bodyPr/>
           <a:lstStyle/>
           <a:p>
-            <a:pPr lvl="0" indent="-342900" marL="342900">
+            <a:pPr lvl="0" indent="-457200" marL="457200">
               <a:buAutoNum type="arabicPeriod"/>
             </a:pPr>
             <a:r>
@@ -14216,7 +14861,7 @@
             </a:r>
           </a:p>
           <a:p>
-            <a:pPr lvl="0" indent="-342900" marL="342900">
+            <a:pPr lvl="0" indent="-457200" marL="457200">
               <a:buAutoNum type="arabicPeriod"/>
             </a:pPr>
             <a:r>
@@ -14237,7 +14882,7 @@
             </a:r>
           </a:p>
           <a:p>
-            <a:pPr lvl="0" indent="-342900" marL="342900">
+            <a:pPr lvl="0" indent="-457200" marL="457200">
               <a:buAutoNum type="arabicPeriod"/>
             </a:pPr>
             <a:r>
@@ -14326,7 +14971,7 @@
             </a:r>
           </a:p>
           <a:p>
-            <a:pPr lvl="0" indent="-342900" marL="342900">
+            <a:pPr lvl="0" indent="-457200" marL="457200">
               <a:buAutoNum type="arabicPeriod"/>
             </a:pPr>
             <a:r>
@@ -14335,7 +14980,7 @@
             </a:r>
           </a:p>
           <a:p>
-            <a:pPr lvl="0" indent="-342900" marL="342900">
+            <a:pPr lvl="0" indent="-457200" marL="457200">
               <a:buAutoNum type="arabicPeriod"/>
             </a:pPr>
             <a:r>
@@ -14344,7 +14989,7 @@
             </a:r>
           </a:p>
           <a:p>
-            <a:pPr lvl="0" indent="-342900" marL="342900">
+            <a:pPr lvl="0" indent="-457200" marL="457200">
               <a:buAutoNum type="arabicPeriod"/>
             </a:pPr>
             <a:r>
@@ -14416,8 +15061,8 @@
         </p:nvSpPr>
         <p:spPr>
           <a:xfrm>
-            <a:off x="722313" y="3305176"/>
-            <a:ext cx="7772400" cy="1021556"/>
+            <a:off x="722313" y="4406900"/>
+            <a:ext cx="7772400" cy="1362075"/>
           </a:xfrm>
         </p:spPr>
         <p:txBody>
@@ -14960,7 +15605,7 @@
           <a:bodyPr/>
           <a:lstStyle/>
           <a:p>
-            <a:pPr lvl="0" indent="-342900" marL="342900">
+            <a:pPr lvl="0" indent="-457200" marL="457200">
               <a:buAutoNum type="arabicPeriod"/>
             </a:pPr>
             <a:r>
@@ -14983,7 +15628,7 @@
             </a:r>
           </a:p>
           <a:p>
-            <a:pPr lvl="0" indent="-342900" marL="342900">
+            <a:pPr lvl="0" indent="-457200" marL="457200">
               <a:buAutoNum type="arabicPeriod"/>
             </a:pPr>
             <a:r>
@@ -14992,7 +15637,7 @@
             </a:r>
           </a:p>
           <a:p>
-            <a:pPr lvl="1" indent="-342900" marL="685800">
+            <a:pPr lvl="1" indent="-457200" marL="914400">
               <a:buAutoNum type="arabicPeriod"/>
             </a:pPr>
             <a:r>
@@ -15011,7 +15656,7 @@
             </a:r>
           </a:p>
           <a:p>
-            <a:pPr lvl="1" indent="-342900" marL="685800">
+            <a:pPr lvl="1" indent="-457200" marL="914400">
               <a:buAutoNum type="arabicPeriod"/>
             </a:pPr>
             <a:r>
@@ -15028,7 +15673,7 @@
             </a:r>
           </a:p>
           <a:p>
-            <a:pPr lvl="1" indent="-342900" marL="685800">
+            <a:pPr lvl="1" indent="-457200" marL="914400">
               <a:buAutoNum type="arabicPeriod"/>
             </a:pPr>
             <a:r>
@@ -15454,8 +16099,8 @@
           </p:nvPr>
         </p:nvGraphicFramePr>
         <p:xfrm>
-          <a:off x="457200" y="1193800"/>
-          <a:ext cx="8229600" cy="3390900"/>
+          <a:off x="457200" y="1600200"/>
+          <a:ext cx="8229600" cy="4521200"/>
         </p:xfrm>
         <a:graphic>
           <a:graphicData uri="http://schemas.openxmlformats.org/drawingml/2006/table">
@@ -15627,8 +16272,8 @@
           </p:nvPr>
         </p:nvGraphicFramePr>
         <p:xfrm>
-          <a:off x="457200" y="1193800"/>
-          <a:ext cx="8229600" cy="3390900"/>
+          <a:off x="457200" y="1600200"/>
+          <a:ext cx="8229600" cy="4521200"/>
         </p:xfrm>
         <a:graphic>
           <a:graphicData uri="http://schemas.openxmlformats.org/drawingml/2006/table">
@@ -16016,7 +16661,7 @@
             </a:r>
           </a:p>
           <a:p>
-            <a:pPr lvl="1" indent="-342900" marL="685800">
+            <a:pPr lvl="1" indent="-457200" marL="914400">
               <a:buAutoNum type="arabicPeriod"/>
             </a:pPr>
             <a:r>
@@ -16035,7 +16680,7 @@
             </a:r>
           </a:p>
           <a:p>
-            <a:pPr lvl="1" indent="-342900" marL="685800">
+            <a:pPr lvl="1" indent="-457200" marL="914400">
               <a:buAutoNum type="arabicPeriod"/>
             </a:pPr>
             <a:r>
@@ -16264,8 +16909,8 @@
         </p:nvSpPr>
         <p:spPr>
           <a:xfrm>
-            <a:off x="722313" y="3305176"/>
-            <a:ext cx="7772400" cy="1021556"/>
+            <a:off x="722313" y="4406900"/>
+            <a:ext cx="7772400" cy="1362075"/>
           </a:xfrm>
         </p:spPr>
         <p:txBody>

</xml_diff>

<commit_message>
Deploy site from d6769995bf981042ebc42832a644d8e9aec78416 d6769995bf981042ebc42832a644d8e9aec78416
</commit_message>
<xml_diff>
--- a/courses/research-in-finance/lectures/lecture-01-basics/slides.pptx
+++ b/courses/research-in-finance/lectures/lecture-01-basics/slides.pptx
@@ -7,7 +7,52 @@
   <p:notesMasterIdLst>
     <p:notesMasterId r:id="rId45"/>
   </p:notesMasterIdLst>
-  <p:sldSz cx="12191695" cy="6858000" type="screen4x3"/>
+  <p:sldIdLst>
+    <p:sldId id="256" r:id="rId2"/>
+    <p:sldId id="257" r:id="rId3"/>
+    <p:sldId id="258" r:id="rId4"/>
+    <p:sldId id="259" r:id="rId5"/>
+    <p:sldId id="260" r:id="rId6"/>
+    <p:sldId id="261" r:id="rId7"/>
+    <p:sldId id="262" r:id="rId8"/>
+    <p:sldId id="263" r:id="rId9"/>
+    <p:sldId id="264" r:id="rId10"/>
+    <p:sldId id="265" r:id="rId11"/>
+    <p:sldId id="266" r:id="rId12"/>
+    <p:sldId id="267" r:id="rId13"/>
+    <p:sldId id="268" r:id="rId14"/>
+    <p:sldId id="269" r:id="rId15"/>
+    <p:sldId id="270" r:id="rId16"/>
+    <p:sldId id="271" r:id="rId17"/>
+    <p:sldId id="272" r:id="rId18"/>
+    <p:sldId id="273" r:id="rId19"/>
+    <p:sldId id="274" r:id="rId20"/>
+    <p:sldId id="275" r:id="rId21"/>
+    <p:sldId id="276" r:id="rId22"/>
+    <p:sldId id="277" r:id="rId23"/>
+    <p:sldId id="278" r:id="rId24"/>
+    <p:sldId id="279" r:id="rId25"/>
+    <p:sldId id="280" r:id="rId26"/>
+    <p:sldId id="281" r:id="rId27"/>
+    <p:sldId id="282" r:id="rId28"/>
+    <p:sldId id="283" r:id="rId29"/>
+    <p:sldId id="284" r:id="rId30"/>
+    <p:sldId id="285" r:id="rId31"/>
+    <p:sldId id="286" r:id="rId32"/>
+    <p:sldId id="287" r:id="rId33"/>
+    <p:sldId id="288" r:id="rId34"/>
+    <p:sldId id="289" r:id="rId35"/>
+    <p:sldId id="290" r:id="rId36"/>
+    <p:sldId id="291" r:id="rId37"/>
+    <p:sldId id="292" r:id="rId38"/>
+    <p:sldId id="293" r:id="rId39"/>
+    <p:sldId id="294" r:id="rId40"/>
+    <p:sldId id="295" r:id="rId41"/>
+    <p:sldId id="296" r:id="rId42"/>
+    <p:sldId id="297" r:id="rId43"/>
+    <p:sldId id="298" r:id="rId44"/>
+  </p:sldIdLst>
+  <p:sldSz cx="9144000" cy="5143500" type="screen16x9"/>
   <p:notesSz cx="6858000" cy="9144000"/>
   <p:defaultTextStyle>
     <a:defPPr>
@@ -104,6 +149,22 @@
       </a:defRPr>
     </a:lvl9pPr>
   </p:defaultTextStyle>
+  <p:extLst>
+    <p:ext uri="{EFAFB233-063F-42B5-8137-9DF3F51BA10A}">
+      <p15:sldGuideLst xmlns:p15="http://schemas.microsoft.com/office/powerpoint/2012/main">
+        <p15:guide id="1" orient="horz" pos="1620" userDrawn="1">
+          <p15:clr>
+            <a:srgbClr val="A4A3A4"/>
+          </p15:clr>
+        </p15:guide>
+        <p15:guide id="2" pos="2880" userDrawn="1">
+          <p15:clr>
+            <a:srgbClr val="A4A3A4"/>
+          </p15:clr>
+        </p15:guide>
+      </p15:sldGuideLst>
+    </p:ext>
+  </p:extLst>
 </p:presentation>
 </file>
 
@@ -649,8 +710,8 @@
         </p:nvSpPr>
         <p:spPr>
           <a:xfrm>
-            <a:off x="685800" y="2130425"/>
-            <a:ext cx="7772400" cy="1470025"/>
+            <a:off x="685800" y="1597819"/>
+            <a:ext cx="7772400" cy="1102519"/>
           </a:xfrm>
         </p:spPr>
         <p:txBody>
@@ -658,14 +719,13 @@
           <a:lstStyle/>
           <a:p>
             <a:r>
-              <a:rPr lang="en-US" smtClean="0">
+              <a:rPr lang="en-US">
                 <a:solidFill>
                   <a:srgbClr val="111111"/>
                 </a:solidFill>
               </a:rPr>
               <a:t>Click to edit Master title style</a:t>
             </a:r>
-            <a:endParaRPr lang="en-US"/>
           </a:p>
         </p:txBody>
       </p:sp>
@@ -681,8 +741,8 @@
         </p:nvSpPr>
         <p:spPr>
           <a:xfrm>
-            <a:off x="1371600" y="3886200"/>
-            <a:ext cx="6400800" cy="1752600"/>
+            <a:off x="1371600" y="2914650"/>
+            <a:ext cx="6400800" cy="1314450"/>
           </a:xfrm>
         </p:spPr>
         <p:txBody>
@@ -696,7 +756,7 @@
                 </a:solidFill>
               </a:defRPr>
             </a:lvl1pPr>
-            <a:lvl2pPr marL="457200" indent="0" algn="ctr">
+            <a:lvl2pPr marL="342900" indent="0" algn="ctr">
               <a:buNone/>
               <a:defRPr>
                 <a:solidFill>
@@ -704,7 +764,7 @@
                 </a:solidFill>
               </a:defRPr>
             </a:lvl2pPr>
-            <a:lvl3pPr marL="914400" indent="0" algn="ctr">
+            <a:lvl3pPr marL="685800" indent="0" algn="ctr">
               <a:buNone/>
               <a:defRPr>
                 <a:solidFill>
@@ -712,7 +772,7 @@
                 </a:solidFill>
               </a:defRPr>
             </a:lvl3pPr>
-            <a:lvl4pPr marL="1371600" indent="0" algn="ctr">
+            <a:lvl4pPr marL="1028700" indent="0" algn="ctr">
               <a:buNone/>
               <a:defRPr>
                 <a:solidFill>
@@ -720,7 +780,7 @@
                 </a:solidFill>
               </a:defRPr>
             </a:lvl4pPr>
-            <a:lvl5pPr marL="1828800" indent="0" algn="ctr">
+            <a:lvl5pPr marL="1371600" indent="0" algn="ctr">
               <a:buNone/>
               <a:defRPr>
                 <a:solidFill>
@@ -728,7 +788,7 @@
                 </a:solidFill>
               </a:defRPr>
             </a:lvl5pPr>
-            <a:lvl6pPr marL="2286000" indent="0" algn="ctr">
+            <a:lvl6pPr marL="1714500" indent="0" algn="ctr">
               <a:buNone/>
               <a:defRPr>
                 <a:solidFill>
@@ -736,7 +796,7 @@
                 </a:solidFill>
               </a:defRPr>
             </a:lvl6pPr>
-            <a:lvl7pPr marL="2743200" indent="0" algn="ctr">
+            <a:lvl7pPr marL="2057400" indent="0" algn="ctr">
               <a:buNone/>
               <a:defRPr>
                 <a:solidFill>
@@ -744,7 +804,7 @@
                 </a:solidFill>
               </a:defRPr>
             </a:lvl7pPr>
-            <a:lvl8pPr marL="3200400" indent="0" algn="ctr">
+            <a:lvl8pPr marL="2400300" indent="0" algn="ctr">
               <a:buNone/>
               <a:defRPr>
                 <a:solidFill>
@@ -752,7 +812,7 @@
                 </a:solidFill>
               </a:defRPr>
             </a:lvl8pPr>
-            <a:lvl9pPr marL="3657600" indent="0" algn="ctr">
+            <a:lvl9pPr marL="2743200" indent="0" algn="ctr">
               <a:buNone/>
               <a:defRPr>
                 <a:solidFill>
@@ -763,14 +823,13 @@
           </a:lstStyle>
           <a:p>
             <a:r>
-              <a:rPr lang="en-US" smtClean="0">
+              <a:rPr lang="en-US">
                 <a:solidFill>
                   <a:srgbClr val="111111"/>
                 </a:solidFill>
               </a:rPr>
               <a:t>Click to edit Master subtitle style</a:t>
             </a:r>
-            <a:endParaRPr lang="en-US"/>
           </a:p>
         </p:txBody>
       </p:sp>
@@ -789,15 +848,19 @@
           <a:bodyPr/>
           <a:lstStyle/>
           <a:p>
-            <a:fld id="{5BCAD085-E8A6-8845-BD4E-CB4CCA059FC4}" type="datetimeFigureOut">
+            <a:fld id="{241EB5C9-1307-BA42-ABA2-0BC069CD8E7F}" type="datetimeFigureOut">
               <a:rPr lang="en-US" smtClean="0">
                 <a:solidFill>
                   <a:srgbClr val="111111"/>
                 </a:solidFill>
               </a:rPr>
-              <a:t>1/27/13</a:t>
+              <a:t>1/2/22</a:t>
             </a:fld>
-            <a:endParaRPr lang="en-US"/>
+            <a:endParaRPr lang="en-US">
+              <a:solidFill>
+                <a:srgbClr val="111111"/>
+              </a:solidFill>
+            </a:endParaRPr>
           </a:p>
         </p:txBody>
       </p:sp>
@@ -816,7 +879,11 @@
           <a:bodyPr/>
           <a:lstStyle/>
           <a:p>
-            <a:endParaRPr lang="en-US"/>
+            <a:endParaRPr lang="en-US">
+              <a:solidFill>
+                <a:srgbClr val="111111"/>
+              </a:solidFill>
+            </a:endParaRPr>
           </a:p>
         </p:txBody>
       </p:sp>
@@ -835,7 +902,7 @@
           <a:bodyPr/>
           <a:lstStyle/>
           <a:p>
-            <a:fld id="{C1FF6DA9-008F-8B48-92A6-B652298478BF}" type="slidenum">
+            <a:fld id="{C5EF2332-01BF-834F-8236-50238282D533}" type="slidenum">
               <a:rPr lang="en-US" smtClean="0">
                 <a:solidFill>
                   <a:srgbClr val="111111"/>
@@ -843,14 +910,18 @@
               </a:rPr>
               <a:t>‹#›</a:t>
             </a:fld>
-            <a:endParaRPr lang="en-US"/>
+            <a:endParaRPr lang="en-US">
+              <a:solidFill>
+                <a:srgbClr val="111111"/>
+              </a:solidFill>
+            </a:endParaRPr>
           </a:p>
         </p:txBody>
       </p:sp>
     </p:spTree>
     <p:extLst>
       <p:ext uri="{BB962C8B-B14F-4D97-AF65-F5344CB8AC3E}">
-        <p14:creationId xmlns:p14="http://schemas.microsoft.com/office/powerpoint/2010/main" val="3168075583"/>
+        <p14:creationId xmlns:p14="http://schemas.microsoft.com/office/powerpoint/2010/main" val="1444357513"/>
       </p:ext>
     </p:extLst>
   </p:cSld>
@@ -893,14 +964,13 @@
           <a:lstStyle/>
           <a:p>
             <a:r>
-              <a:rPr lang="en-US" smtClean="0">
+              <a:rPr lang="en-US">
                 <a:solidFill>
                   <a:srgbClr val="111111"/>
                 </a:solidFill>
               </a:rPr>
               <a:t>Click to edit Master title style</a:t>
             </a:r>
-            <a:endParaRPr lang="en-US"/>
           </a:p>
         </p:txBody>
       </p:sp>
@@ -921,7 +991,7 @@
           <a:p>
             <a:pPr lvl="0"/>
             <a:r>
-              <a:rPr lang="en-US" smtClean="0">
+              <a:rPr lang="en-US">
                 <a:solidFill>
                   <a:srgbClr val="111111"/>
                 </a:solidFill>
@@ -932,7 +1002,7 @@
           <a:p>
             <a:pPr lvl="1"/>
             <a:r>
-              <a:rPr lang="en-US" smtClean="0">
+              <a:rPr lang="en-US">
                 <a:solidFill>
                   <a:srgbClr val="111111"/>
                 </a:solidFill>
@@ -943,7 +1013,7 @@
           <a:p>
             <a:pPr lvl="2"/>
             <a:r>
-              <a:rPr lang="en-US" smtClean="0">
+              <a:rPr lang="en-US">
                 <a:solidFill>
                   <a:srgbClr val="111111"/>
                 </a:solidFill>
@@ -954,7 +1024,7 @@
           <a:p>
             <a:pPr lvl="3"/>
             <a:r>
-              <a:rPr lang="en-US" smtClean="0">
+              <a:rPr lang="en-US">
                 <a:solidFill>
                   <a:srgbClr val="111111"/>
                 </a:solidFill>
@@ -965,14 +1035,13 @@
           <a:p>
             <a:pPr lvl="4"/>
             <a:r>
-              <a:rPr lang="en-US" smtClean="0">
+              <a:rPr lang="en-US">
                 <a:solidFill>
                   <a:srgbClr val="111111"/>
                 </a:solidFill>
               </a:rPr>
               <a:t>Fifth level</a:t>
             </a:r>
-            <a:endParaRPr lang="en-US"/>
           </a:p>
         </p:txBody>
       </p:sp>
@@ -991,15 +1060,19 @@
           <a:bodyPr/>
           <a:lstStyle/>
           <a:p>
-            <a:fld id="{5BCAD085-E8A6-8845-BD4E-CB4CCA059FC4}" type="datetimeFigureOut">
+            <a:fld id="{241EB5C9-1307-BA42-ABA2-0BC069CD8E7F}" type="datetimeFigureOut">
               <a:rPr lang="en-US" smtClean="0">
                 <a:solidFill>
                   <a:srgbClr val="111111"/>
                 </a:solidFill>
               </a:rPr>
-              <a:t>1/27/13</a:t>
+              <a:t>1/2/22</a:t>
             </a:fld>
-            <a:endParaRPr lang="en-US"/>
+            <a:endParaRPr lang="en-US">
+              <a:solidFill>
+                <a:srgbClr val="111111"/>
+              </a:solidFill>
+            </a:endParaRPr>
           </a:p>
         </p:txBody>
       </p:sp>
@@ -1018,7 +1091,11 @@
           <a:bodyPr/>
           <a:lstStyle/>
           <a:p>
-            <a:endParaRPr lang="en-US"/>
+            <a:endParaRPr lang="en-US">
+              <a:solidFill>
+                <a:srgbClr val="111111"/>
+              </a:solidFill>
+            </a:endParaRPr>
           </a:p>
         </p:txBody>
       </p:sp>
@@ -1037,7 +1114,7 @@
           <a:bodyPr/>
           <a:lstStyle/>
           <a:p>
-            <a:fld id="{C1FF6DA9-008F-8B48-92A6-B652298478BF}" type="slidenum">
+            <a:fld id="{C5EF2332-01BF-834F-8236-50238282D533}" type="slidenum">
               <a:rPr lang="en-US" smtClean="0">
                 <a:solidFill>
                   <a:srgbClr val="111111"/>
@@ -1045,14 +1122,18 @@
               </a:rPr>
               <a:t>‹#›</a:t>
             </a:fld>
-            <a:endParaRPr lang="en-US"/>
+            <a:endParaRPr lang="en-US">
+              <a:solidFill>
+                <a:srgbClr val="111111"/>
+              </a:solidFill>
+            </a:endParaRPr>
           </a:p>
         </p:txBody>
       </p:sp>
     </p:spTree>
     <p:extLst>
       <p:ext uri="{BB962C8B-B14F-4D97-AF65-F5344CB8AC3E}">
-        <p14:creationId xmlns:p14="http://schemas.microsoft.com/office/powerpoint/2010/main" val="2910927964"/>
+        <p14:creationId xmlns:p14="http://schemas.microsoft.com/office/powerpoint/2010/main" val="313914798"/>
       </p:ext>
     </p:extLst>
   </p:cSld>
@@ -1091,8 +1172,8 @@
         </p:nvSpPr>
         <p:spPr>
           <a:xfrm>
-            <a:off x="6629400" y="274638"/>
-            <a:ext cx="2057400" cy="5851525"/>
+            <a:off x="6629400" y="205979"/>
+            <a:ext cx="2057400" cy="4388644"/>
           </a:xfrm>
         </p:spPr>
         <p:txBody>
@@ -1100,14 +1181,13 @@
           <a:lstStyle/>
           <a:p>
             <a:r>
-              <a:rPr lang="en-US" smtClean="0">
+              <a:rPr lang="en-US">
                 <a:solidFill>
                   <a:srgbClr val="111111"/>
                 </a:solidFill>
               </a:rPr>
               <a:t>Click to edit Master title style</a:t>
             </a:r>
-            <a:endParaRPr lang="en-US"/>
           </a:p>
         </p:txBody>
       </p:sp>
@@ -1123,8 +1203,8 @@
         </p:nvSpPr>
         <p:spPr>
           <a:xfrm>
-            <a:off x="457200" y="274638"/>
-            <a:ext cx="6019800" cy="5851525"/>
+            <a:off x="457200" y="205979"/>
+            <a:ext cx="6019800" cy="4388644"/>
           </a:xfrm>
         </p:spPr>
         <p:txBody>
@@ -1133,7 +1213,7 @@
           <a:p>
             <a:pPr lvl="0"/>
             <a:r>
-              <a:rPr lang="en-US" smtClean="0">
+              <a:rPr lang="en-US">
                 <a:solidFill>
                   <a:srgbClr val="111111"/>
                 </a:solidFill>
@@ -1144,7 +1224,7 @@
           <a:p>
             <a:pPr lvl="1"/>
             <a:r>
-              <a:rPr lang="en-US" smtClean="0">
+              <a:rPr lang="en-US">
                 <a:solidFill>
                   <a:srgbClr val="111111"/>
                 </a:solidFill>
@@ -1155,7 +1235,7 @@
           <a:p>
             <a:pPr lvl="2"/>
             <a:r>
-              <a:rPr lang="en-US" smtClean="0">
+              <a:rPr lang="en-US">
                 <a:solidFill>
                   <a:srgbClr val="111111"/>
                 </a:solidFill>
@@ -1166,7 +1246,7 @@
           <a:p>
             <a:pPr lvl="3"/>
             <a:r>
-              <a:rPr lang="en-US" smtClean="0">
+              <a:rPr lang="en-US">
                 <a:solidFill>
                   <a:srgbClr val="111111"/>
                 </a:solidFill>
@@ -1177,14 +1257,13 @@
           <a:p>
             <a:pPr lvl="4"/>
             <a:r>
-              <a:rPr lang="en-US" smtClean="0">
+              <a:rPr lang="en-US">
                 <a:solidFill>
                   <a:srgbClr val="111111"/>
                 </a:solidFill>
               </a:rPr>
               <a:t>Fifth level</a:t>
             </a:r>
-            <a:endParaRPr lang="en-US"/>
           </a:p>
         </p:txBody>
       </p:sp>
@@ -1203,15 +1282,19 @@
           <a:bodyPr/>
           <a:lstStyle/>
           <a:p>
-            <a:fld id="{5BCAD085-E8A6-8845-BD4E-CB4CCA059FC4}" type="datetimeFigureOut">
+            <a:fld id="{241EB5C9-1307-BA42-ABA2-0BC069CD8E7F}" type="datetimeFigureOut">
               <a:rPr lang="en-US" smtClean="0">
                 <a:solidFill>
                   <a:srgbClr val="111111"/>
                 </a:solidFill>
               </a:rPr>
-              <a:t>1/27/13</a:t>
+              <a:t>1/2/22</a:t>
             </a:fld>
-            <a:endParaRPr lang="en-US"/>
+            <a:endParaRPr lang="en-US">
+              <a:solidFill>
+                <a:srgbClr val="111111"/>
+              </a:solidFill>
+            </a:endParaRPr>
           </a:p>
         </p:txBody>
       </p:sp>
@@ -1230,7 +1313,11 @@
           <a:bodyPr/>
           <a:lstStyle/>
           <a:p>
-            <a:endParaRPr lang="en-US"/>
+            <a:endParaRPr lang="en-US">
+              <a:solidFill>
+                <a:srgbClr val="111111"/>
+              </a:solidFill>
+            </a:endParaRPr>
           </a:p>
         </p:txBody>
       </p:sp>
@@ -1249,7 +1336,7 @@
           <a:bodyPr/>
           <a:lstStyle/>
           <a:p>
-            <a:fld id="{C1FF6DA9-008F-8B48-92A6-B652298478BF}" type="slidenum">
+            <a:fld id="{C5EF2332-01BF-834F-8236-50238282D533}" type="slidenum">
               <a:rPr lang="en-US" smtClean="0">
                 <a:solidFill>
                   <a:srgbClr val="111111"/>
@@ -1257,14 +1344,18 @@
               </a:rPr>
               <a:t>‹#›</a:t>
             </a:fld>
-            <a:endParaRPr lang="en-US"/>
+            <a:endParaRPr lang="en-US">
+              <a:solidFill>
+                <a:srgbClr val="111111"/>
+              </a:solidFill>
+            </a:endParaRPr>
           </a:p>
         </p:txBody>
       </p:sp>
     </p:spTree>
     <p:extLst>
       <p:ext uri="{BB962C8B-B14F-4D97-AF65-F5344CB8AC3E}">
-        <p14:creationId xmlns:p14="http://schemas.microsoft.com/office/powerpoint/2010/main" val="3612223792"/>
+        <p14:creationId xmlns:p14="http://schemas.microsoft.com/office/powerpoint/2010/main" val="2581529045"/>
       </p:ext>
     </p:extLst>
   </p:cSld>
@@ -1307,14 +1398,13 @@
           <a:lstStyle/>
           <a:p>
             <a:r>
-              <a:rPr lang="en-US" smtClean="0">
+              <a:rPr lang="en-US">
                 <a:solidFill>
                   <a:srgbClr val="111111"/>
                 </a:solidFill>
               </a:rPr>
               <a:t>Click to edit Master title style</a:t>
             </a:r>
-            <a:endParaRPr lang="en-US"/>
           </a:p>
         </p:txBody>
       </p:sp>
@@ -1335,7 +1425,7 @@
           <a:p>
             <a:pPr lvl="0"/>
             <a:r>
-              <a:rPr lang="en-US" smtClean="0">
+              <a:rPr lang="en-US">
                 <a:solidFill>
                   <a:srgbClr val="111111"/>
                 </a:solidFill>
@@ -1346,7 +1436,7 @@
           <a:p>
             <a:pPr lvl="1"/>
             <a:r>
-              <a:rPr lang="en-US" smtClean="0">
+              <a:rPr lang="en-US">
                 <a:solidFill>
                   <a:srgbClr val="111111"/>
                 </a:solidFill>
@@ -1357,7 +1447,7 @@
           <a:p>
             <a:pPr lvl="2"/>
             <a:r>
-              <a:rPr lang="en-US" smtClean="0">
+              <a:rPr lang="en-US">
                 <a:solidFill>
                   <a:srgbClr val="111111"/>
                 </a:solidFill>
@@ -1368,7 +1458,7 @@
           <a:p>
             <a:pPr lvl="3"/>
             <a:r>
-              <a:rPr lang="en-US" smtClean="0">
+              <a:rPr lang="en-US">
                 <a:solidFill>
                   <a:srgbClr val="111111"/>
                 </a:solidFill>
@@ -1379,14 +1469,13 @@
           <a:p>
             <a:pPr lvl="4"/>
             <a:r>
-              <a:rPr lang="en-US" smtClean="0">
+              <a:rPr lang="en-US">
                 <a:solidFill>
                   <a:srgbClr val="111111"/>
                 </a:solidFill>
               </a:rPr>
               <a:t>Fifth level</a:t>
             </a:r>
-            <a:endParaRPr lang="en-US"/>
           </a:p>
         </p:txBody>
       </p:sp>
@@ -1405,15 +1494,19 @@
           <a:bodyPr/>
           <a:lstStyle/>
           <a:p>
-            <a:fld id="{5BCAD085-E8A6-8845-BD4E-CB4CCA059FC4}" type="datetimeFigureOut">
+            <a:fld id="{241EB5C9-1307-BA42-ABA2-0BC069CD8E7F}" type="datetimeFigureOut">
               <a:rPr lang="en-US" smtClean="0">
                 <a:solidFill>
                   <a:srgbClr val="111111"/>
                 </a:solidFill>
               </a:rPr>
-              <a:t>1/27/13</a:t>
+              <a:t>1/2/22</a:t>
             </a:fld>
-            <a:endParaRPr lang="en-US"/>
+            <a:endParaRPr lang="en-US">
+              <a:solidFill>
+                <a:srgbClr val="111111"/>
+              </a:solidFill>
+            </a:endParaRPr>
           </a:p>
         </p:txBody>
       </p:sp>
@@ -1432,7 +1525,11 @@
           <a:bodyPr/>
           <a:lstStyle/>
           <a:p>
-            <a:endParaRPr lang="en-US"/>
+            <a:endParaRPr lang="en-US">
+              <a:solidFill>
+                <a:srgbClr val="111111"/>
+              </a:solidFill>
+            </a:endParaRPr>
           </a:p>
         </p:txBody>
       </p:sp>
@@ -1451,7 +1548,7 @@
           <a:bodyPr/>
           <a:lstStyle/>
           <a:p>
-            <a:fld id="{C1FF6DA9-008F-8B48-92A6-B652298478BF}" type="slidenum">
+            <a:fld id="{C5EF2332-01BF-834F-8236-50238282D533}" type="slidenum">
               <a:rPr lang="en-US" smtClean="0">
                 <a:solidFill>
                   <a:srgbClr val="111111"/>
@@ -1459,14 +1556,18 @@
               </a:rPr>
               <a:t>‹#›</a:t>
             </a:fld>
-            <a:endParaRPr lang="en-US"/>
+            <a:endParaRPr lang="en-US">
+              <a:solidFill>
+                <a:srgbClr val="111111"/>
+              </a:solidFill>
+            </a:endParaRPr>
           </a:p>
         </p:txBody>
       </p:sp>
     </p:spTree>
     <p:extLst>
       <p:ext uri="{BB962C8B-B14F-4D97-AF65-F5344CB8AC3E}">
-        <p14:creationId xmlns:p14="http://schemas.microsoft.com/office/powerpoint/2010/main" val="2614314258"/>
+        <p14:creationId xmlns:p14="http://schemas.microsoft.com/office/powerpoint/2010/main" val="338346009"/>
       </p:ext>
     </p:extLst>
   </p:cSld>
@@ -1505,15 +1606,15 @@
         </p:nvSpPr>
         <p:spPr>
           <a:xfrm>
-            <a:off x="722313" y="4406900"/>
-            <a:ext cx="7772400" cy="1362075"/>
+            <a:off x="722313" y="3305176"/>
+            <a:ext cx="7772400" cy="1021556"/>
           </a:xfrm>
         </p:spPr>
         <p:txBody>
           <a:bodyPr anchor="t"/>
           <a:lstStyle>
             <a:lvl1pPr algn="l">
-              <a:defRPr sz="4000" b="1" cap="all">
+              <a:defRPr sz="3000" b="1" cap="all">
                 <a:solidFill>
                   <a:srgbClr val="111111"/>
                 </a:solidFill>
@@ -1522,14 +1623,13 @@
           </a:lstStyle>
           <a:p>
             <a:r>
-              <a:rPr lang="en-US" smtClean="0">
+              <a:rPr lang="en-US">
                 <a:solidFill>
                   <a:srgbClr val="111111"/>
                 </a:solidFill>
               </a:rPr>
               <a:t>Click to edit Master title style</a:t>
             </a:r>
-            <a:endParaRPr lang="en-US"/>
           </a:p>
         </p:txBody>
       </p:sp>
@@ -1545,8 +1645,8 @@
         </p:nvSpPr>
         <p:spPr>
           <a:xfrm>
-            <a:off x="722313" y="2906713"/>
-            <a:ext cx="7772400" cy="1500187"/>
+            <a:off x="722313" y="2180035"/>
+            <a:ext cx="7772400" cy="1125140"/>
           </a:xfrm>
         </p:spPr>
         <p:txBody>
@@ -1554,71 +1654,71 @@
           <a:lstStyle>
             <a:lvl1pPr marL="0" indent="0">
               <a:buNone/>
-              <a:defRPr sz="2000">
+              <a:defRPr sz="1500">
                 <a:solidFill>
                   <a:srgbClr val="111111"/>
                 </a:solidFill>
               </a:defRPr>
             </a:lvl1pPr>
-            <a:lvl2pPr marL="457200" indent="0">
+            <a:lvl2pPr marL="342900" indent="0">
               <a:buNone/>
-              <a:defRPr sz="1800">
+              <a:defRPr sz="1350">
                 <a:solidFill>
                   <a:srgbClr val="111111"/>
                 </a:solidFill>
               </a:defRPr>
             </a:lvl2pPr>
-            <a:lvl3pPr marL="914400" indent="0">
+            <a:lvl3pPr marL="685800" indent="0">
               <a:buNone/>
-              <a:defRPr sz="1600">
+              <a:defRPr sz="1200">
                 <a:solidFill>
                   <a:srgbClr val="111111"/>
                 </a:solidFill>
               </a:defRPr>
             </a:lvl3pPr>
-            <a:lvl4pPr marL="1371600" indent="0">
+            <a:lvl4pPr marL="1028700" indent="0">
               <a:buNone/>
-              <a:defRPr sz="1400">
+              <a:defRPr sz="1050">
                 <a:solidFill>
                   <a:srgbClr val="111111"/>
                 </a:solidFill>
               </a:defRPr>
             </a:lvl4pPr>
-            <a:lvl5pPr marL="1828800" indent="0">
+            <a:lvl5pPr marL="1371600" indent="0">
               <a:buNone/>
-              <a:defRPr sz="1400">
+              <a:defRPr sz="1050">
                 <a:solidFill>
                   <a:srgbClr val="111111"/>
                 </a:solidFill>
               </a:defRPr>
             </a:lvl5pPr>
-            <a:lvl6pPr marL="2286000" indent="0">
+            <a:lvl6pPr marL="1714500" indent="0">
               <a:buNone/>
-              <a:defRPr sz="1400">
+              <a:defRPr sz="1050">
                 <a:solidFill>
                   <a:srgbClr val="111111"/>
                 </a:solidFill>
               </a:defRPr>
             </a:lvl6pPr>
-            <a:lvl7pPr marL="2743200" indent="0">
+            <a:lvl7pPr marL="2057400" indent="0">
               <a:buNone/>
-              <a:defRPr sz="1400">
+              <a:defRPr sz="1050">
                 <a:solidFill>
                   <a:srgbClr val="111111"/>
                 </a:solidFill>
               </a:defRPr>
             </a:lvl7pPr>
-            <a:lvl8pPr marL="3200400" indent="0">
+            <a:lvl8pPr marL="2400300" indent="0">
               <a:buNone/>
-              <a:defRPr sz="1400">
+              <a:defRPr sz="1050">
                 <a:solidFill>
                   <a:srgbClr val="111111"/>
                 </a:solidFill>
               </a:defRPr>
             </a:lvl8pPr>
-            <a:lvl9pPr marL="3657600" indent="0">
+            <a:lvl9pPr marL="2743200" indent="0">
               <a:buNone/>
-              <a:defRPr sz="1400">
+              <a:defRPr sz="1050">
                 <a:solidFill>
                   <a:srgbClr val="111111"/>
                 </a:solidFill>
@@ -1628,7 +1728,7 @@
           <a:p>
             <a:pPr lvl="0"/>
             <a:r>
-              <a:rPr lang="en-US" smtClean="0">
+              <a:rPr lang="en-US">
                 <a:solidFill>
                   <a:srgbClr val="111111"/>
                 </a:solidFill>
@@ -1653,15 +1753,19 @@
           <a:bodyPr/>
           <a:lstStyle/>
           <a:p>
-            <a:fld id="{5BCAD085-E8A6-8845-BD4E-CB4CCA059FC4}" type="datetimeFigureOut">
+            <a:fld id="{241EB5C9-1307-BA42-ABA2-0BC069CD8E7F}" type="datetimeFigureOut">
               <a:rPr lang="en-US" smtClean="0">
                 <a:solidFill>
                   <a:srgbClr val="111111"/>
                 </a:solidFill>
               </a:rPr>
-              <a:t>1/27/13</a:t>
+              <a:t>1/2/22</a:t>
             </a:fld>
-            <a:endParaRPr lang="en-US"/>
+            <a:endParaRPr lang="en-US">
+              <a:solidFill>
+                <a:srgbClr val="111111"/>
+              </a:solidFill>
+            </a:endParaRPr>
           </a:p>
         </p:txBody>
       </p:sp>
@@ -1680,7 +1784,11 @@
           <a:bodyPr/>
           <a:lstStyle/>
           <a:p>
-            <a:endParaRPr lang="en-US"/>
+            <a:endParaRPr lang="en-US">
+              <a:solidFill>
+                <a:srgbClr val="111111"/>
+              </a:solidFill>
+            </a:endParaRPr>
           </a:p>
         </p:txBody>
       </p:sp>
@@ -1699,7 +1807,7 @@
           <a:bodyPr/>
           <a:lstStyle/>
           <a:p>
-            <a:fld id="{C1FF6DA9-008F-8B48-92A6-B652298478BF}" type="slidenum">
+            <a:fld id="{C5EF2332-01BF-834F-8236-50238282D533}" type="slidenum">
               <a:rPr lang="en-US" smtClean="0">
                 <a:solidFill>
                   <a:srgbClr val="111111"/>
@@ -1707,14 +1815,18 @@
               </a:rPr>
               <a:t>‹#›</a:t>
             </a:fld>
-            <a:endParaRPr lang="en-US"/>
+            <a:endParaRPr lang="en-US">
+              <a:solidFill>
+                <a:srgbClr val="111111"/>
+              </a:solidFill>
+            </a:endParaRPr>
           </a:p>
         </p:txBody>
       </p:sp>
     </p:spTree>
     <p:extLst>
       <p:ext uri="{BB962C8B-B14F-4D97-AF65-F5344CB8AC3E}">
-        <p14:creationId xmlns:p14="http://schemas.microsoft.com/office/powerpoint/2010/main" val="960648375"/>
+        <p14:creationId xmlns:p14="http://schemas.microsoft.com/office/powerpoint/2010/main" val="1073069076"/>
       </p:ext>
     </p:extLst>
   </p:cSld>
@@ -1757,14 +1869,13 @@
           <a:lstStyle/>
           <a:p>
             <a:r>
-              <a:rPr lang="en-US" smtClean="0">
+              <a:rPr lang="en-US">
                 <a:solidFill>
                   <a:srgbClr val="111111"/>
                 </a:solidFill>
               </a:rPr>
               <a:t>Click to edit Master title style</a:t>
             </a:r>
-            <a:endParaRPr lang="en-US"/>
           </a:p>
         </p:txBody>
       </p:sp>
@@ -1780,71 +1891,71 @@
         </p:nvSpPr>
         <p:spPr>
           <a:xfrm>
-            <a:off x="457200" y="1600200"/>
-            <a:ext cx="4038600" cy="4525963"/>
+            <a:off x="457200" y="1200151"/>
+            <a:ext cx="4038600" cy="3394472"/>
           </a:xfrm>
         </p:spPr>
         <p:txBody>
           <a:bodyPr/>
           <a:lstStyle>
             <a:lvl1pPr>
-              <a:defRPr sz="2800">
+              <a:defRPr sz="2100">
                 <a:solidFill>
                   <a:srgbClr val="111111"/>
                 </a:solidFill>
               </a:defRPr>
             </a:lvl1pPr>
             <a:lvl2pPr>
-              <a:defRPr sz="2400">
+              <a:defRPr sz="1800">
                 <a:solidFill>
                   <a:srgbClr val="111111"/>
                 </a:solidFill>
               </a:defRPr>
             </a:lvl2pPr>
             <a:lvl3pPr>
-              <a:defRPr sz="2000">
+              <a:defRPr sz="1500">
                 <a:solidFill>
                   <a:srgbClr val="111111"/>
                 </a:solidFill>
               </a:defRPr>
             </a:lvl3pPr>
             <a:lvl4pPr>
-              <a:defRPr sz="1800">
+              <a:defRPr sz="1350">
                 <a:solidFill>
                   <a:srgbClr val="111111"/>
                 </a:solidFill>
               </a:defRPr>
             </a:lvl4pPr>
             <a:lvl5pPr>
-              <a:defRPr sz="1800">
+              <a:defRPr sz="1350">
                 <a:solidFill>
                   <a:srgbClr val="111111"/>
                 </a:solidFill>
               </a:defRPr>
             </a:lvl5pPr>
             <a:lvl6pPr>
-              <a:defRPr sz="1800">
+              <a:defRPr sz="1350">
                 <a:solidFill>
                   <a:srgbClr val="111111"/>
                 </a:solidFill>
               </a:defRPr>
             </a:lvl6pPr>
             <a:lvl7pPr>
-              <a:defRPr sz="1800">
+              <a:defRPr sz="1350">
                 <a:solidFill>
                   <a:srgbClr val="111111"/>
                 </a:solidFill>
               </a:defRPr>
             </a:lvl7pPr>
             <a:lvl8pPr>
-              <a:defRPr sz="1800">
+              <a:defRPr sz="1350">
                 <a:solidFill>
                   <a:srgbClr val="111111"/>
                 </a:solidFill>
               </a:defRPr>
             </a:lvl8pPr>
             <a:lvl9pPr>
-              <a:defRPr sz="1800">
+              <a:defRPr sz="1350">
                 <a:solidFill>
                   <a:srgbClr val="111111"/>
                 </a:solidFill>
@@ -1854,7 +1965,7 @@
           <a:p>
             <a:pPr lvl="0"/>
             <a:r>
-              <a:rPr lang="en-US" smtClean="0">
+              <a:rPr lang="en-US">
                 <a:solidFill>
                   <a:srgbClr val="111111"/>
                 </a:solidFill>
@@ -1865,7 +1976,7 @@
           <a:p>
             <a:pPr lvl="1"/>
             <a:r>
-              <a:rPr lang="en-US" smtClean="0">
+              <a:rPr lang="en-US">
                 <a:solidFill>
                   <a:srgbClr val="111111"/>
                 </a:solidFill>
@@ -1876,7 +1987,7 @@
           <a:p>
             <a:pPr lvl="2"/>
             <a:r>
-              <a:rPr lang="en-US" smtClean="0">
+              <a:rPr lang="en-US">
                 <a:solidFill>
                   <a:srgbClr val="111111"/>
                 </a:solidFill>
@@ -1887,7 +1998,7 @@
           <a:p>
             <a:pPr lvl="3"/>
             <a:r>
-              <a:rPr lang="en-US" smtClean="0">
+              <a:rPr lang="en-US">
                 <a:solidFill>
                   <a:srgbClr val="111111"/>
                 </a:solidFill>
@@ -1898,14 +2009,13 @@
           <a:p>
             <a:pPr lvl="4"/>
             <a:r>
-              <a:rPr lang="en-US" smtClean="0">
+              <a:rPr lang="en-US">
                 <a:solidFill>
                   <a:srgbClr val="111111"/>
                 </a:solidFill>
               </a:rPr>
               <a:t>Fifth level</a:t>
             </a:r>
-            <a:endParaRPr lang="en-US"/>
           </a:p>
         </p:txBody>
       </p:sp>
@@ -1921,71 +2031,71 @@
         </p:nvSpPr>
         <p:spPr>
           <a:xfrm>
-            <a:off x="4648200" y="1600200"/>
-            <a:ext cx="4038600" cy="4525963"/>
+            <a:off x="4648200" y="1200151"/>
+            <a:ext cx="4038600" cy="3394472"/>
           </a:xfrm>
         </p:spPr>
         <p:txBody>
           <a:bodyPr/>
           <a:lstStyle>
             <a:lvl1pPr>
-              <a:defRPr sz="2800">
+              <a:defRPr sz="2100">
                 <a:solidFill>
                   <a:srgbClr val="111111"/>
                 </a:solidFill>
               </a:defRPr>
             </a:lvl1pPr>
             <a:lvl2pPr>
-              <a:defRPr sz="2400">
+              <a:defRPr sz="1800">
                 <a:solidFill>
                   <a:srgbClr val="111111"/>
                 </a:solidFill>
               </a:defRPr>
             </a:lvl2pPr>
             <a:lvl3pPr>
-              <a:defRPr sz="2000">
+              <a:defRPr sz="1500">
                 <a:solidFill>
                   <a:srgbClr val="111111"/>
                 </a:solidFill>
               </a:defRPr>
             </a:lvl3pPr>
             <a:lvl4pPr>
-              <a:defRPr sz="1800">
+              <a:defRPr sz="1350">
                 <a:solidFill>
                   <a:srgbClr val="111111"/>
                 </a:solidFill>
               </a:defRPr>
             </a:lvl4pPr>
             <a:lvl5pPr>
-              <a:defRPr sz="1800">
+              <a:defRPr sz="1350">
                 <a:solidFill>
                   <a:srgbClr val="111111"/>
                 </a:solidFill>
               </a:defRPr>
             </a:lvl5pPr>
             <a:lvl6pPr>
-              <a:defRPr sz="1800">
+              <a:defRPr sz="1350">
                 <a:solidFill>
                   <a:srgbClr val="111111"/>
                 </a:solidFill>
               </a:defRPr>
             </a:lvl6pPr>
             <a:lvl7pPr>
-              <a:defRPr sz="1800">
+              <a:defRPr sz="1350">
                 <a:solidFill>
                   <a:srgbClr val="111111"/>
                 </a:solidFill>
               </a:defRPr>
             </a:lvl7pPr>
             <a:lvl8pPr>
-              <a:defRPr sz="1800">
+              <a:defRPr sz="1350">
                 <a:solidFill>
                   <a:srgbClr val="111111"/>
                 </a:solidFill>
               </a:defRPr>
             </a:lvl8pPr>
             <a:lvl9pPr>
-              <a:defRPr sz="1800">
+              <a:defRPr sz="1350">
                 <a:solidFill>
                   <a:srgbClr val="111111"/>
                 </a:solidFill>
@@ -1995,7 +2105,7 @@
           <a:p>
             <a:pPr lvl="0"/>
             <a:r>
-              <a:rPr lang="en-US" smtClean="0">
+              <a:rPr lang="en-US">
                 <a:solidFill>
                   <a:srgbClr val="111111"/>
                 </a:solidFill>
@@ -2006,7 +2116,7 @@
           <a:p>
             <a:pPr lvl="1"/>
             <a:r>
-              <a:rPr lang="en-US" smtClean="0">
+              <a:rPr lang="en-US">
                 <a:solidFill>
                   <a:srgbClr val="111111"/>
                 </a:solidFill>
@@ -2017,7 +2127,7 @@
           <a:p>
             <a:pPr lvl="2"/>
             <a:r>
-              <a:rPr lang="en-US" smtClean="0">
+              <a:rPr lang="en-US">
                 <a:solidFill>
                   <a:srgbClr val="111111"/>
                 </a:solidFill>
@@ -2028,7 +2138,7 @@
           <a:p>
             <a:pPr lvl="3"/>
             <a:r>
-              <a:rPr lang="en-US" smtClean="0">
+              <a:rPr lang="en-US">
                 <a:solidFill>
                   <a:srgbClr val="111111"/>
                 </a:solidFill>
@@ -2039,14 +2149,13 @@
           <a:p>
             <a:pPr lvl="4"/>
             <a:r>
-              <a:rPr lang="en-US" smtClean="0">
+              <a:rPr lang="en-US">
                 <a:solidFill>
                   <a:srgbClr val="111111"/>
                 </a:solidFill>
               </a:rPr>
               <a:t>Fifth level</a:t>
             </a:r>
-            <a:endParaRPr lang="en-US"/>
           </a:p>
         </p:txBody>
       </p:sp>
@@ -2065,15 +2174,19 @@
           <a:bodyPr/>
           <a:lstStyle/>
           <a:p>
-            <a:fld id="{5BCAD085-E8A6-8845-BD4E-CB4CCA059FC4}" type="datetimeFigureOut">
+            <a:fld id="{241EB5C9-1307-BA42-ABA2-0BC069CD8E7F}" type="datetimeFigureOut">
               <a:rPr lang="en-US" smtClean="0">
                 <a:solidFill>
                   <a:srgbClr val="111111"/>
                 </a:solidFill>
               </a:rPr>
-              <a:t>1/27/13</a:t>
+              <a:t>1/2/22</a:t>
             </a:fld>
-            <a:endParaRPr lang="en-US"/>
+            <a:endParaRPr lang="en-US">
+              <a:solidFill>
+                <a:srgbClr val="111111"/>
+              </a:solidFill>
+            </a:endParaRPr>
           </a:p>
         </p:txBody>
       </p:sp>
@@ -2092,7 +2205,11 @@
           <a:bodyPr/>
           <a:lstStyle/>
           <a:p>
-            <a:endParaRPr lang="en-US"/>
+            <a:endParaRPr lang="en-US">
+              <a:solidFill>
+                <a:srgbClr val="111111"/>
+              </a:solidFill>
+            </a:endParaRPr>
           </a:p>
         </p:txBody>
       </p:sp>
@@ -2111,7 +2228,7 @@
           <a:bodyPr/>
           <a:lstStyle/>
           <a:p>
-            <a:fld id="{C1FF6DA9-008F-8B48-92A6-B652298478BF}" type="slidenum">
+            <a:fld id="{C5EF2332-01BF-834F-8236-50238282D533}" type="slidenum">
               <a:rPr lang="en-US" smtClean="0">
                 <a:solidFill>
                   <a:srgbClr val="111111"/>
@@ -2119,14 +2236,18 @@
               </a:rPr>
               <a:t>‹#›</a:t>
             </a:fld>
-            <a:endParaRPr lang="en-US"/>
+            <a:endParaRPr lang="en-US">
+              <a:solidFill>
+                <a:srgbClr val="111111"/>
+              </a:solidFill>
+            </a:endParaRPr>
           </a:p>
         </p:txBody>
       </p:sp>
     </p:spTree>
     <p:extLst>
       <p:ext uri="{BB962C8B-B14F-4D97-AF65-F5344CB8AC3E}">
-        <p14:creationId xmlns:p14="http://schemas.microsoft.com/office/powerpoint/2010/main" val="2782244947"/>
+        <p14:creationId xmlns:p14="http://schemas.microsoft.com/office/powerpoint/2010/main" val="2619886245"/>
       </p:ext>
     </p:extLst>
   </p:cSld>
@@ -2177,14 +2298,13 @@
           </a:lstStyle>
           <a:p>
             <a:r>
-              <a:rPr lang="en-US" smtClean="0">
+              <a:rPr lang="en-US">
                 <a:solidFill>
                   <a:srgbClr val="111111"/>
                 </a:solidFill>
               </a:rPr>
               <a:t>Click to edit Master title style</a:t>
             </a:r>
-            <a:endParaRPr lang="en-US"/>
           </a:p>
         </p:txBody>
       </p:sp>
@@ -2200,8 +2320,8 @@
         </p:nvSpPr>
         <p:spPr>
           <a:xfrm>
-            <a:off x="457200" y="1535113"/>
-            <a:ext cx="4040188" cy="639762"/>
+            <a:off x="457200" y="1151335"/>
+            <a:ext cx="4040188" cy="479822"/>
           </a:xfrm>
         </p:spPr>
         <p:txBody>
@@ -2209,71 +2329,71 @@
           <a:lstStyle>
             <a:lvl1pPr marL="0" indent="0">
               <a:buNone/>
-              <a:defRPr sz="2400" b="1">
+              <a:defRPr sz="1800" b="1">
                 <a:solidFill>
                   <a:srgbClr val="111111"/>
                 </a:solidFill>
               </a:defRPr>
             </a:lvl1pPr>
-            <a:lvl2pPr marL="457200" indent="0">
+            <a:lvl2pPr marL="342900" indent="0">
               <a:buNone/>
-              <a:defRPr sz="2000" b="1">
+              <a:defRPr sz="1500" b="1">
                 <a:solidFill>
                   <a:srgbClr val="111111"/>
                 </a:solidFill>
               </a:defRPr>
             </a:lvl2pPr>
-            <a:lvl3pPr marL="914400" indent="0">
+            <a:lvl3pPr marL="685800" indent="0">
               <a:buNone/>
-              <a:defRPr sz="1800" b="1">
+              <a:defRPr sz="1350" b="1">
                 <a:solidFill>
                   <a:srgbClr val="111111"/>
                 </a:solidFill>
               </a:defRPr>
             </a:lvl3pPr>
-            <a:lvl4pPr marL="1371600" indent="0">
+            <a:lvl4pPr marL="1028700" indent="0">
               <a:buNone/>
-              <a:defRPr sz="1600" b="1">
+              <a:defRPr sz="1200" b="1">
                 <a:solidFill>
                   <a:srgbClr val="111111"/>
                 </a:solidFill>
               </a:defRPr>
             </a:lvl4pPr>
-            <a:lvl5pPr marL="1828800" indent="0">
+            <a:lvl5pPr marL="1371600" indent="0">
               <a:buNone/>
-              <a:defRPr sz="1600" b="1">
+              <a:defRPr sz="1200" b="1">
                 <a:solidFill>
                   <a:srgbClr val="111111"/>
                 </a:solidFill>
               </a:defRPr>
             </a:lvl5pPr>
-            <a:lvl6pPr marL="2286000" indent="0">
+            <a:lvl6pPr marL="1714500" indent="0">
               <a:buNone/>
-              <a:defRPr sz="1600" b="1">
+              <a:defRPr sz="1200" b="1">
                 <a:solidFill>
                   <a:srgbClr val="111111"/>
                 </a:solidFill>
               </a:defRPr>
             </a:lvl6pPr>
-            <a:lvl7pPr marL="2743200" indent="0">
+            <a:lvl7pPr marL="2057400" indent="0">
               <a:buNone/>
-              <a:defRPr sz="1600" b="1">
+              <a:defRPr sz="1200" b="1">
                 <a:solidFill>
                   <a:srgbClr val="111111"/>
                 </a:solidFill>
               </a:defRPr>
             </a:lvl7pPr>
-            <a:lvl8pPr marL="3200400" indent="0">
+            <a:lvl8pPr marL="2400300" indent="0">
               <a:buNone/>
-              <a:defRPr sz="1600" b="1">
+              <a:defRPr sz="1200" b="1">
                 <a:solidFill>
                   <a:srgbClr val="111111"/>
                 </a:solidFill>
               </a:defRPr>
             </a:lvl8pPr>
-            <a:lvl9pPr marL="3657600" indent="0">
+            <a:lvl9pPr marL="2743200" indent="0">
               <a:buNone/>
-              <a:defRPr sz="1600" b="1">
+              <a:defRPr sz="1200" b="1">
                 <a:solidFill>
                   <a:srgbClr val="111111"/>
                 </a:solidFill>
@@ -2283,7 +2403,7 @@
           <a:p>
             <a:pPr lvl="0"/>
             <a:r>
-              <a:rPr lang="en-US" smtClean="0">
+              <a:rPr lang="en-US">
                 <a:solidFill>
                   <a:srgbClr val="111111"/>
                 </a:solidFill>
@@ -2305,71 +2425,71 @@
         </p:nvSpPr>
         <p:spPr>
           <a:xfrm>
-            <a:off x="457200" y="2174875"/>
-            <a:ext cx="4040188" cy="3951288"/>
+            <a:off x="457200" y="1631156"/>
+            <a:ext cx="4040188" cy="2963466"/>
           </a:xfrm>
         </p:spPr>
         <p:txBody>
           <a:bodyPr/>
           <a:lstStyle>
             <a:lvl1pPr>
-              <a:defRPr sz="2400">
+              <a:defRPr sz="1800">
                 <a:solidFill>
                   <a:srgbClr val="111111"/>
                 </a:solidFill>
               </a:defRPr>
             </a:lvl1pPr>
             <a:lvl2pPr>
-              <a:defRPr sz="2000">
+              <a:defRPr sz="1500">
                 <a:solidFill>
                   <a:srgbClr val="111111"/>
                 </a:solidFill>
               </a:defRPr>
             </a:lvl2pPr>
             <a:lvl3pPr>
-              <a:defRPr sz="1800">
+              <a:defRPr sz="1350">
                 <a:solidFill>
                   <a:srgbClr val="111111"/>
                 </a:solidFill>
               </a:defRPr>
             </a:lvl3pPr>
             <a:lvl4pPr>
-              <a:defRPr sz="1600">
+              <a:defRPr sz="1200">
                 <a:solidFill>
                   <a:srgbClr val="111111"/>
                 </a:solidFill>
               </a:defRPr>
             </a:lvl4pPr>
             <a:lvl5pPr>
-              <a:defRPr sz="1600">
+              <a:defRPr sz="1200">
                 <a:solidFill>
                   <a:srgbClr val="111111"/>
                 </a:solidFill>
               </a:defRPr>
             </a:lvl5pPr>
             <a:lvl6pPr>
-              <a:defRPr sz="1600">
+              <a:defRPr sz="1200">
                 <a:solidFill>
                   <a:srgbClr val="111111"/>
                 </a:solidFill>
               </a:defRPr>
             </a:lvl6pPr>
             <a:lvl7pPr>
-              <a:defRPr sz="1600">
+              <a:defRPr sz="1200">
                 <a:solidFill>
                   <a:srgbClr val="111111"/>
                 </a:solidFill>
               </a:defRPr>
             </a:lvl7pPr>
             <a:lvl8pPr>
-              <a:defRPr sz="1600">
+              <a:defRPr sz="1200">
                 <a:solidFill>
                   <a:srgbClr val="111111"/>
                 </a:solidFill>
               </a:defRPr>
             </a:lvl8pPr>
             <a:lvl9pPr>
-              <a:defRPr sz="1600">
+              <a:defRPr sz="1200">
                 <a:solidFill>
                   <a:srgbClr val="111111"/>
                 </a:solidFill>
@@ -2379,7 +2499,7 @@
           <a:p>
             <a:pPr lvl="0"/>
             <a:r>
-              <a:rPr lang="en-US" smtClean="0">
+              <a:rPr lang="en-US">
                 <a:solidFill>
                   <a:srgbClr val="111111"/>
                 </a:solidFill>
@@ -2390,7 +2510,7 @@
           <a:p>
             <a:pPr lvl="1"/>
             <a:r>
-              <a:rPr lang="en-US" smtClean="0">
+              <a:rPr lang="en-US">
                 <a:solidFill>
                   <a:srgbClr val="111111"/>
                 </a:solidFill>
@@ -2401,7 +2521,7 @@
           <a:p>
             <a:pPr lvl="2"/>
             <a:r>
-              <a:rPr lang="en-US" smtClean="0">
+              <a:rPr lang="en-US">
                 <a:solidFill>
                   <a:srgbClr val="111111"/>
                 </a:solidFill>
@@ -2412,7 +2532,7 @@
           <a:p>
             <a:pPr lvl="3"/>
             <a:r>
-              <a:rPr lang="en-US" smtClean="0">
+              <a:rPr lang="en-US">
                 <a:solidFill>
                   <a:srgbClr val="111111"/>
                 </a:solidFill>
@@ -2423,14 +2543,13 @@
           <a:p>
             <a:pPr lvl="4"/>
             <a:r>
-              <a:rPr lang="en-US" smtClean="0">
+              <a:rPr lang="en-US">
                 <a:solidFill>
                   <a:srgbClr val="111111"/>
                 </a:solidFill>
               </a:rPr>
               <a:t>Fifth level</a:t>
             </a:r>
-            <a:endParaRPr lang="en-US"/>
           </a:p>
         </p:txBody>
       </p:sp>
@@ -2446,8 +2565,8 @@
         </p:nvSpPr>
         <p:spPr>
           <a:xfrm>
-            <a:off x="4645025" y="1535113"/>
-            <a:ext cx="4041775" cy="639762"/>
+            <a:off x="4645026" y="1151335"/>
+            <a:ext cx="4041775" cy="479822"/>
           </a:xfrm>
         </p:spPr>
         <p:txBody>
@@ -2455,71 +2574,71 @@
           <a:lstStyle>
             <a:lvl1pPr marL="0" indent="0">
               <a:buNone/>
-              <a:defRPr sz="2400" b="1">
+              <a:defRPr sz="1800" b="1">
                 <a:solidFill>
                   <a:srgbClr val="111111"/>
                 </a:solidFill>
               </a:defRPr>
             </a:lvl1pPr>
-            <a:lvl2pPr marL="457200" indent="0">
+            <a:lvl2pPr marL="342900" indent="0">
               <a:buNone/>
-              <a:defRPr sz="2000" b="1">
+              <a:defRPr sz="1500" b="1">
                 <a:solidFill>
                   <a:srgbClr val="111111"/>
                 </a:solidFill>
               </a:defRPr>
             </a:lvl2pPr>
-            <a:lvl3pPr marL="914400" indent="0">
+            <a:lvl3pPr marL="685800" indent="0">
               <a:buNone/>
-              <a:defRPr sz="1800" b="1">
+              <a:defRPr sz="1350" b="1">
                 <a:solidFill>
                   <a:srgbClr val="111111"/>
                 </a:solidFill>
               </a:defRPr>
             </a:lvl3pPr>
-            <a:lvl4pPr marL="1371600" indent="0">
+            <a:lvl4pPr marL="1028700" indent="0">
               <a:buNone/>
-              <a:defRPr sz="1600" b="1">
+              <a:defRPr sz="1200" b="1">
                 <a:solidFill>
                   <a:srgbClr val="111111"/>
                 </a:solidFill>
               </a:defRPr>
             </a:lvl4pPr>
-            <a:lvl5pPr marL="1828800" indent="0">
+            <a:lvl5pPr marL="1371600" indent="0">
               <a:buNone/>
-              <a:defRPr sz="1600" b="1">
+              <a:defRPr sz="1200" b="1">
                 <a:solidFill>
                   <a:srgbClr val="111111"/>
                 </a:solidFill>
               </a:defRPr>
             </a:lvl5pPr>
-            <a:lvl6pPr marL="2286000" indent="0">
+            <a:lvl6pPr marL="1714500" indent="0">
               <a:buNone/>
-              <a:defRPr sz="1600" b="1">
+              <a:defRPr sz="1200" b="1">
                 <a:solidFill>
                   <a:srgbClr val="111111"/>
                 </a:solidFill>
               </a:defRPr>
             </a:lvl6pPr>
-            <a:lvl7pPr marL="2743200" indent="0">
+            <a:lvl7pPr marL="2057400" indent="0">
               <a:buNone/>
-              <a:defRPr sz="1600" b="1">
+              <a:defRPr sz="1200" b="1">
                 <a:solidFill>
                   <a:srgbClr val="111111"/>
                 </a:solidFill>
               </a:defRPr>
             </a:lvl7pPr>
-            <a:lvl8pPr marL="3200400" indent="0">
+            <a:lvl8pPr marL="2400300" indent="0">
               <a:buNone/>
-              <a:defRPr sz="1600" b="1">
+              <a:defRPr sz="1200" b="1">
                 <a:solidFill>
                   <a:srgbClr val="111111"/>
                 </a:solidFill>
               </a:defRPr>
             </a:lvl8pPr>
-            <a:lvl9pPr marL="3657600" indent="0">
+            <a:lvl9pPr marL="2743200" indent="0">
               <a:buNone/>
-              <a:defRPr sz="1600" b="1">
+              <a:defRPr sz="1200" b="1">
                 <a:solidFill>
                   <a:srgbClr val="111111"/>
                 </a:solidFill>
@@ -2529,7 +2648,7 @@
           <a:p>
             <a:pPr lvl="0"/>
             <a:r>
-              <a:rPr lang="en-US" smtClean="0">
+              <a:rPr lang="en-US">
                 <a:solidFill>
                   <a:srgbClr val="111111"/>
                 </a:solidFill>
@@ -2551,71 +2670,71 @@
         </p:nvSpPr>
         <p:spPr>
           <a:xfrm>
-            <a:off x="4645025" y="2174875"/>
-            <a:ext cx="4041775" cy="3951288"/>
+            <a:off x="4645026" y="1631156"/>
+            <a:ext cx="4041775" cy="2963466"/>
           </a:xfrm>
         </p:spPr>
         <p:txBody>
           <a:bodyPr/>
           <a:lstStyle>
             <a:lvl1pPr>
-              <a:defRPr sz="2400">
+              <a:defRPr sz="1800">
                 <a:solidFill>
                   <a:srgbClr val="111111"/>
                 </a:solidFill>
               </a:defRPr>
             </a:lvl1pPr>
             <a:lvl2pPr>
-              <a:defRPr sz="2000">
+              <a:defRPr sz="1500">
                 <a:solidFill>
                   <a:srgbClr val="111111"/>
                 </a:solidFill>
               </a:defRPr>
             </a:lvl2pPr>
             <a:lvl3pPr>
-              <a:defRPr sz="1800">
+              <a:defRPr sz="1350">
                 <a:solidFill>
                   <a:srgbClr val="111111"/>
                 </a:solidFill>
               </a:defRPr>
             </a:lvl3pPr>
             <a:lvl4pPr>
-              <a:defRPr sz="1600">
+              <a:defRPr sz="1200">
                 <a:solidFill>
                   <a:srgbClr val="111111"/>
                 </a:solidFill>
               </a:defRPr>
             </a:lvl4pPr>
             <a:lvl5pPr>
-              <a:defRPr sz="1600">
+              <a:defRPr sz="1200">
                 <a:solidFill>
                   <a:srgbClr val="111111"/>
                 </a:solidFill>
               </a:defRPr>
             </a:lvl5pPr>
             <a:lvl6pPr>
-              <a:defRPr sz="1600">
+              <a:defRPr sz="1200">
                 <a:solidFill>
                   <a:srgbClr val="111111"/>
                 </a:solidFill>
               </a:defRPr>
             </a:lvl6pPr>
             <a:lvl7pPr>
-              <a:defRPr sz="1600">
+              <a:defRPr sz="1200">
                 <a:solidFill>
                   <a:srgbClr val="111111"/>
                 </a:solidFill>
               </a:defRPr>
             </a:lvl7pPr>
             <a:lvl8pPr>
-              <a:defRPr sz="1600">
+              <a:defRPr sz="1200">
                 <a:solidFill>
                   <a:srgbClr val="111111"/>
                 </a:solidFill>
               </a:defRPr>
             </a:lvl8pPr>
             <a:lvl9pPr>
-              <a:defRPr sz="1600">
+              <a:defRPr sz="1200">
                 <a:solidFill>
                   <a:srgbClr val="111111"/>
                 </a:solidFill>
@@ -2625,7 +2744,7 @@
           <a:p>
             <a:pPr lvl="0"/>
             <a:r>
-              <a:rPr lang="en-US" smtClean="0">
+              <a:rPr lang="en-US">
                 <a:solidFill>
                   <a:srgbClr val="111111"/>
                 </a:solidFill>
@@ -2636,7 +2755,7 @@
           <a:p>
             <a:pPr lvl="1"/>
             <a:r>
-              <a:rPr lang="en-US" smtClean="0">
+              <a:rPr lang="en-US">
                 <a:solidFill>
                   <a:srgbClr val="111111"/>
                 </a:solidFill>
@@ -2647,7 +2766,7 @@
           <a:p>
             <a:pPr lvl="2"/>
             <a:r>
-              <a:rPr lang="en-US" smtClean="0">
+              <a:rPr lang="en-US">
                 <a:solidFill>
                   <a:srgbClr val="111111"/>
                 </a:solidFill>
@@ -2658,7 +2777,7 @@
           <a:p>
             <a:pPr lvl="3"/>
             <a:r>
-              <a:rPr lang="en-US" smtClean="0">
+              <a:rPr lang="en-US">
                 <a:solidFill>
                   <a:srgbClr val="111111"/>
                 </a:solidFill>
@@ -2669,14 +2788,13 @@
           <a:p>
             <a:pPr lvl="4"/>
             <a:r>
-              <a:rPr lang="en-US" smtClean="0">
+              <a:rPr lang="en-US">
                 <a:solidFill>
                   <a:srgbClr val="111111"/>
                 </a:solidFill>
               </a:rPr>
               <a:t>Fifth level</a:t>
             </a:r>
-            <a:endParaRPr lang="en-US"/>
           </a:p>
         </p:txBody>
       </p:sp>
@@ -2695,15 +2813,19 @@
           <a:bodyPr/>
           <a:lstStyle/>
           <a:p>
-            <a:fld id="{5BCAD085-E8A6-8845-BD4E-CB4CCA059FC4}" type="datetimeFigureOut">
+            <a:fld id="{241EB5C9-1307-BA42-ABA2-0BC069CD8E7F}" type="datetimeFigureOut">
               <a:rPr lang="en-US" smtClean="0">
                 <a:solidFill>
                   <a:srgbClr val="111111"/>
                 </a:solidFill>
               </a:rPr>
-              <a:t>1/27/13</a:t>
+              <a:t>1/2/22</a:t>
             </a:fld>
-            <a:endParaRPr lang="en-US"/>
+            <a:endParaRPr lang="en-US">
+              <a:solidFill>
+                <a:srgbClr val="111111"/>
+              </a:solidFill>
+            </a:endParaRPr>
           </a:p>
         </p:txBody>
       </p:sp>
@@ -2722,7 +2844,11 @@
           <a:bodyPr/>
           <a:lstStyle/>
           <a:p>
-            <a:endParaRPr lang="en-US"/>
+            <a:endParaRPr lang="en-US">
+              <a:solidFill>
+                <a:srgbClr val="111111"/>
+              </a:solidFill>
+            </a:endParaRPr>
           </a:p>
         </p:txBody>
       </p:sp>
@@ -2741,7 +2867,7 @@
           <a:bodyPr/>
           <a:lstStyle/>
           <a:p>
-            <a:fld id="{C1FF6DA9-008F-8B48-92A6-B652298478BF}" type="slidenum">
+            <a:fld id="{C5EF2332-01BF-834F-8236-50238282D533}" type="slidenum">
               <a:rPr lang="en-US" smtClean="0">
                 <a:solidFill>
                   <a:srgbClr val="111111"/>
@@ -2749,14 +2875,18 @@
               </a:rPr>
               <a:t>‹#›</a:t>
             </a:fld>
-            <a:endParaRPr lang="en-US"/>
+            <a:endParaRPr lang="en-US">
+              <a:solidFill>
+                <a:srgbClr val="111111"/>
+              </a:solidFill>
+            </a:endParaRPr>
           </a:p>
         </p:txBody>
       </p:sp>
     </p:spTree>
     <p:extLst>
       <p:ext uri="{BB962C8B-B14F-4D97-AF65-F5344CB8AC3E}">
-        <p14:creationId xmlns:p14="http://schemas.microsoft.com/office/powerpoint/2010/main" val="990158736"/>
+        <p14:creationId xmlns:p14="http://schemas.microsoft.com/office/powerpoint/2010/main" val="2535793967"/>
       </p:ext>
     </p:extLst>
   </p:cSld>
@@ -2799,14 +2929,13 @@
           <a:lstStyle/>
           <a:p>
             <a:r>
-              <a:rPr lang="en-US" smtClean="0">
+              <a:rPr lang="en-US">
                 <a:solidFill>
                   <a:srgbClr val="111111"/>
                 </a:solidFill>
               </a:rPr>
               <a:t>Click to edit Master title style</a:t>
             </a:r>
-            <a:endParaRPr lang="en-US"/>
           </a:p>
         </p:txBody>
       </p:sp>
@@ -2825,15 +2954,19 @@
           <a:bodyPr/>
           <a:lstStyle/>
           <a:p>
-            <a:fld id="{5BCAD085-E8A6-8845-BD4E-CB4CCA059FC4}" type="datetimeFigureOut">
+            <a:fld id="{241EB5C9-1307-BA42-ABA2-0BC069CD8E7F}" type="datetimeFigureOut">
               <a:rPr lang="en-US" smtClean="0">
                 <a:solidFill>
                   <a:srgbClr val="111111"/>
                 </a:solidFill>
               </a:rPr>
-              <a:t>1/27/13</a:t>
+              <a:t>1/2/22</a:t>
             </a:fld>
-            <a:endParaRPr lang="en-US"/>
+            <a:endParaRPr lang="en-US">
+              <a:solidFill>
+                <a:srgbClr val="111111"/>
+              </a:solidFill>
+            </a:endParaRPr>
           </a:p>
         </p:txBody>
       </p:sp>
@@ -2852,7 +2985,11 @@
           <a:bodyPr/>
           <a:lstStyle/>
           <a:p>
-            <a:endParaRPr lang="en-US"/>
+            <a:endParaRPr lang="en-US">
+              <a:solidFill>
+                <a:srgbClr val="111111"/>
+              </a:solidFill>
+            </a:endParaRPr>
           </a:p>
         </p:txBody>
       </p:sp>
@@ -2871,7 +3008,7 @@
           <a:bodyPr/>
           <a:lstStyle/>
           <a:p>
-            <a:fld id="{C1FF6DA9-008F-8B48-92A6-B652298478BF}" type="slidenum">
+            <a:fld id="{C5EF2332-01BF-834F-8236-50238282D533}" type="slidenum">
               <a:rPr lang="en-US" smtClean="0">
                 <a:solidFill>
                   <a:srgbClr val="111111"/>
@@ -2879,14 +3016,18 @@
               </a:rPr>
               <a:t>‹#›</a:t>
             </a:fld>
-            <a:endParaRPr lang="en-US"/>
+            <a:endParaRPr lang="en-US">
+              <a:solidFill>
+                <a:srgbClr val="111111"/>
+              </a:solidFill>
+            </a:endParaRPr>
           </a:p>
         </p:txBody>
       </p:sp>
     </p:spTree>
     <p:extLst>
       <p:ext uri="{BB962C8B-B14F-4D97-AF65-F5344CB8AC3E}">
-        <p14:creationId xmlns:p14="http://schemas.microsoft.com/office/powerpoint/2010/main" val="727027711"/>
+        <p14:creationId xmlns:p14="http://schemas.microsoft.com/office/powerpoint/2010/main" val="3472721253"/>
       </p:ext>
     </p:extLst>
   </p:cSld>
@@ -2928,15 +3069,19 @@
           <a:bodyPr/>
           <a:lstStyle/>
           <a:p>
-            <a:fld id="{5BCAD085-E8A6-8845-BD4E-CB4CCA059FC4}" type="datetimeFigureOut">
+            <a:fld id="{241EB5C9-1307-BA42-ABA2-0BC069CD8E7F}" type="datetimeFigureOut">
               <a:rPr lang="en-US" smtClean="0">
                 <a:solidFill>
                   <a:srgbClr val="111111"/>
                 </a:solidFill>
               </a:rPr>
-              <a:t>1/27/13</a:t>
+              <a:t>1/2/22</a:t>
             </a:fld>
-            <a:endParaRPr lang="en-US"/>
+            <a:endParaRPr lang="en-US">
+              <a:solidFill>
+                <a:srgbClr val="111111"/>
+              </a:solidFill>
+            </a:endParaRPr>
           </a:p>
         </p:txBody>
       </p:sp>
@@ -2955,7 +3100,11 @@
           <a:bodyPr/>
           <a:lstStyle/>
           <a:p>
-            <a:endParaRPr lang="en-US"/>
+            <a:endParaRPr lang="en-US">
+              <a:solidFill>
+                <a:srgbClr val="111111"/>
+              </a:solidFill>
+            </a:endParaRPr>
           </a:p>
         </p:txBody>
       </p:sp>
@@ -2974,7 +3123,7 @@
           <a:bodyPr/>
           <a:lstStyle/>
           <a:p>
-            <a:fld id="{C1FF6DA9-008F-8B48-92A6-B652298478BF}" type="slidenum">
+            <a:fld id="{C5EF2332-01BF-834F-8236-50238282D533}" type="slidenum">
               <a:rPr lang="en-US" smtClean="0">
                 <a:solidFill>
                   <a:srgbClr val="111111"/>
@@ -2982,14 +3131,18 @@
               </a:rPr>
               <a:t>‹#›</a:t>
             </a:fld>
-            <a:endParaRPr lang="en-US"/>
+            <a:endParaRPr lang="en-US">
+              <a:solidFill>
+                <a:srgbClr val="111111"/>
+              </a:solidFill>
+            </a:endParaRPr>
           </a:p>
         </p:txBody>
       </p:sp>
     </p:spTree>
     <p:extLst>
       <p:ext uri="{BB962C8B-B14F-4D97-AF65-F5344CB8AC3E}">
-        <p14:creationId xmlns:p14="http://schemas.microsoft.com/office/powerpoint/2010/main" val="1212999818"/>
+        <p14:creationId xmlns:p14="http://schemas.microsoft.com/office/powerpoint/2010/main" val="2130901097"/>
       </p:ext>
     </p:extLst>
   </p:cSld>
@@ -3028,15 +3181,15 @@
         </p:nvSpPr>
         <p:spPr>
           <a:xfrm>
-            <a:off x="457200" y="273050"/>
-            <a:ext cx="3008313" cy="1162050"/>
+            <a:off x="457201" y="204787"/>
+            <a:ext cx="3008313" cy="871538"/>
           </a:xfrm>
         </p:spPr>
         <p:txBody>
           <a:bodyPr anchor="b"/>
           <a:lstStyle>
             <a:lvl1pPr algn="l">
-              <a:defRPr sz="2000" b="1">
+              <a:defRPr sz="1500" b="1">
                 <a:solidFill>
                   <a:srgbClr val="111111"/>
                 </a:solidFill>
@@ -3045,14 +3198,13 @@
           </a:lstStyle>
           <a:p>
             <a:r>
-              <a:rPr lang="en-US" smtClean="0">
+              <a:rPr lang="en-US">
                 <a:solidFill>
                   <a:srgbClr val="111111"/>
                 </a:solidFill>
               </a:rPr>
               <a:t>Click to edit Master title style</a:t>
             </a:r>
-            <a:endParaRPr lang="en-US"/>
           </a:p>
         </p:txBody>
       </p:sp>
@@ -3068,71 +3220,71 @@
         </p:nvSpPr>
         <p:spPr>
           <a:xfrm>
-            <a:off x="3575050" y="273050"/>
-            <a:ext cx="5111750" cy="5853113"/>
+            <a:off x="3575050" y="204788"/>
+            <a:ext cx="5111750" cy="4389835"/>
           </a:xfrm>
         </p:spPr>
         <p:txBody>
           <a:bodyPr/>
           <a:lstStyle>
             <a:lvl1pPr>
-              <a:defRPr sz="3200">
+              <a:defRPr sz="2400">
                 <a:solidFill>
                   <a:srgbClr val="111111"/>
                 </a:solidFill>
               </a:defRPr>
             </a:lvl1pPr>
             <a:lvl2pPr>
-              <a:defRPr sz="2800">
+              <a:defRPr sz="2100">
                 <a:solidFill>
                   <a:srgbClr val="111111"/>
                 </a:solidFill>
               </a:defRPr>
             </a:lvl2pPr>
             <a:lvl3pPr>
-              <a:defRPr sz="2400">
+              <a:defRPr sz="1800">
                 <a:solidFill>
                   <a:srgbClr val="111111"/>
                 </a:solidFill>
               </a:defRPr>
             </a:lvl3pPr>
             <a:lvl4pPr>
-              <a:defRPr sz="2000">
+              <a:defRPr sz="1500">
                 <a:solidFill>
                   <a:srgbClr val="111111"/>
                 </a:solidFill>
               </a:defRPr>
             </a:lvl4pPr>
             <a:lvl5pPr>
-              <a:defRPr sz="2000">
+              <a:defRPr sz="1500">
                 <a:solidFill>
                   <a:srgbClr val="111111"/>
                 </a:solidFill>
               </a:defRPr>
             </a:lvl5pPr>
             <a:lvl6pPr>
-              <a:defRPr sz="2000">
+              <a:defRPr sz="1500">
                 <a:solidFill>
                   <a:srgbClr val="111111"/>
                 </a:solidFill>
               </a:defRPr>
             </a:lvl6pPr>
             <a:lvl7pPr>
-              <a:defRPr sz="2000">
+              <a:defRPr sz="1500">
                 <a:solidFill>
                   <a:srgbClr val="111111"/>
                 </a:solidFill>
               </a:defRPr>
             </a:lvl7pPr>
             <a:lvl8pPr>
-              <a:defRPr sz="2000">
+              <a:defRPr sz="1500">
                 <a:solidFill>
                   <a:srgbClr val="111111"/>
                 </a:solidFill>
               </a:defRPr>
             </a:lvl8pPr>
             <a:lvl9pPr>
-              <a:defRPr sz="2000">
+              <a:defRPr sz="1500">
                 <a:solidFill>
                   <a:srgbClr val="111111"/>
                 </a:solidFill>
@@ -3142,7 +3294,7 @@
           <a:p>
             <a:pPr lvl="0"/>
             <a:r>
-              <a:rPr lang="en-US" smtClean="0">
+              <a:rPr lang="en-US">
                 <a:solidFill>
                   <a:srgbClr val="111111"/>
                 </a:solidFill>
@@ -3153,7 +3305,7 @@
           <a:p>
             <a:pPr lvl="1"/>
             <a:r>
-              <a:rPr lang="en-US" smtClean="0">
+              <a:rPr lang="en-US">
                 <a:solidFill>
                   <a:srgbClr val="111111"/>
                 </a:solidFill>
@@ -3164,7 +3316,7 @@
           <a:p>
             <a:pPr lvl="2"/>
             <a:r>
-              <a:rPr lang="en-US" smtClean="0">
+              <a:rPr lang="en-US">
                 <a:solidFill>
                   <a:srgbClr val="111111"/>
                 </a:solidFill>
@@ -3175,7 +3327,7 @@
           <a:p>
             <a:pPr lvl="3"/>
             <a:r>
-              <a:rPr lang="en-US" smtClean="0">
+              <a:rPr lang="en-US">
                 <a:solidFill>
                   <a:srgbClr val="111111"/>
                 </a:solidFill>
@@ -3186,14 +3338,13 @@
           <a:p>
             <a:pPr lvl="4"/>
             <a:r>
-              <a:rPr lang="en-US" smtClean="0">
+              <a:rPr lang="en-US">
                 <a:solidFill>
                   <a:srgbClr val="111111"/>
                 </a:solidFill>
               </a:rPr>
               <a:t>Fifth level</a:t>
             </a:r>
-            <a:endParaRPr lang="en-US"/>
           </a:p>
         </p:txBody>
       </p:sp>
@@ -3209,8 +3360,8 @@
         </p:nvSpPr>
         <p:spPr>
           <a:xfrm>
-            <a:off x="457200" y="1435100"/>
-            <a:ext cx="3008313" cy="4691063"/>
+            <a:off x="457201" y="1076326"/>
+            <a:ext cx="3008313" cy="3518297"/>
           </a:xfrm>
         </p:spPr>
         <p:txBody>
@@ -3218,71 +3369,71 @@
           <a:lstStyle>
             <a:lvl1pPr marL="0" indent="0">
               <a:buNone/>
-              <a:defRPr sz="1400">
+              <a:defRPr sz="1050">
                 <a:solidFill>
                   <a:srgbClr val="111111"/>
                 </a:solidFill>
               </a:defRPr>
             </a:lvl1pPr>
-            <a:lvl2pPr marL="457200" indent="0">
+            <a:lvl2pPr marL="342900" indent="0">
               <a:buNone/>
-              <a:defRPr sz="1200">
+              <a:defRPr sz="900">
                 <a:solidFill>
                   <a:srgbClr val="111111"/>
                 </a:solidFill>
               </a:defRPr>
             </a:lvl2pPr>
-            <a:lvl3pPr marL="914400" indent="0">
+            <a:lvl3pPr marL="685800" indent="0">
               <a:buNone/>
-              <a:defRPr sz="1000">
+              <a:defRPr sz="750">
                 <a:solidFill>
                   <a:srgbClr val="111111"/>
                 </a:solidFill>
               </a:defRPr>
             </a:lvl3pPr>
-            <a:lvl4pPr marL="1371600" indent="0">
+            <a:lvl4pPr marL="1028700" indent="0">
               <a:buNone/>
-              <a:defRPr sz="900">
+              <a:defRPr sz="675">
                 <a:solidFill>
                   <a:srgbClr val="111111"/>
                 </a:solidFill>
               </a:defRPr>
             </a:lvl4pPr>
-            <a:lvl5pPr marL="1828800" indent="0">
+            <a:lvl5pPr marL="1371600" indent="0">
               <a:buNone/>
-              <a:defRPr sz="900">
+              <a:defRPr sz="675">
                 <a:solidFill>
                   <a:srgbClr val="111111"/>
                 </a:solidFill>
               </a:defRPr>
             </a:lvl5pPr>
-            <a:lvl6pPr marL="2286000" indent="0">
+            <a:lvl6pPr marL="1714500" indent="0">
               <a:buNone/>
-              <a:defRPr sz="900">
+              <a:defRPr sz="675">
                 <a:solidFill>
                   <a:srgbClr val="111111"/>
                 </a:solidFill>
               </a:defRPr>
             </a:lvl6pPr>
-            <a:lvl7pPr marL="2743200" indent="0">
+            <a:lvl7pPr marL="2057400" indent="0">
               <a:buNone/>
-              <a:defRPr sz="900">
+              <a:defRPr sz="675">
                 <a:solidFill>
                   <a:srgbClr val="111111"/>
                 </a:solidFill>
               </a:defRPr>
             </a:lvl7pPr>
-            <a:lvl8pPr marL="3200400" indent="0">
+            <a:lvl8pPr marL="2400300" indent="0">
               <a:buNone/>
-              <a:defRPr sz="900">
+              <a:defRPr sz="675">
                 <a:solidFill>
                   <a:srgbClr val="111111"/>
                 </a:solidFill>
               </a:defRPr>
             </a:lvl8pPr>
-            <a:lvl9pPr marL="3657600" indent="0">
+            <a:lvl9pPr marL="2743200" indent="0">
               <a:buNone/>
-              <a:defRPr sz="900">
+              <a:defRPr sz="675">
                 <a:solidFill>
                   <a:srgbClr val="111111"/>
                 </a:solidFill>
@@ -3292,7 +3443,7 @@
           <a:p>
             <a:pPr lvl="0"/>
             <a:r>
-              <a:rPr lang="en-US" smtClean="0">
+              <a:rPr lang="en-US">
                 <a:solidFill>
                   <a:srgbClr val="111111"/>
                 </a:solidFill>
@@ -3317,15 +3468,19 @@
           <a:bodyPr/>
           <a:lstStyle/>
           <a:p>
-            <a:fld id="{5BCAD085-E8A6-8845-BD4E-CB4CCA059FC4}" type="datetimeFigureOut">
+            <a:fld id="{241EB5C9-1307-BA42-ABA2-0BC069CD8E7F}" type="datetimeFigureOut">
               <a:rPr lang="en-US" smtClean="0">
                 <a:solidFill>
                   <a:srgbClr val="111111"/>
                 </a:solidFill>
               </a:rPr>
-              <a:t>1/27/13</a:t>
+              <a:t>1/2/22</a:t>
             </a:fld>
-            <a:endParaRPr lang="en-US"/>
+            <a:endParaRPr lang="en-US">
+              <a:solidFill>
+                <a:srgbClr val="111111"/>
+              </a:solidFill>
+            </a:endParaRPr>
           </a:p>
         </p:txBody>
       </p:sp>
@@ -3344,7 +3499,11 @@
           <a:bodyPr/>
           <a:lstStyle/>
           <a:p>
-            <a:endParaRPr lang="en-US"/>
+            <a:endParaRPr lang="en-US">
+              <a:solidFill>
+                <a:srgbClr val="111111"/>
+              </a:solidFill>
+            </a:endParaRPr>
           </a:p>
         </p:txBody>
       </p:sp>
@@ -3363,7 +3522,7 @@
           <a:bodyPr/>
           <a:lstStyle/>
           <a:p>
-            <a:fld id="{C1FF6DA9-008F-8B48-92A6-B652298478BF}" type="slidenum">
+            <a:fld id="{C5EF2332-01BF-834F-8236-50238282D533}" type="slidenum">
               <a:rPr lang="en-US" smtClean="0">
                 <a:solidFill>
                   <a:srgbClr val="111111"/>
@@ -3371,14 +3530,18 @@
               </a:rPr>
               <a:t>‹#›</a:t>
             </a:fld>
-            <a:endParaRPr lang="en-US"/>
+            <a:endParaRPr lang="en-US">
+              <a:solidFill>
+                <a:srgbClr val="111111"/>
+              </a:solidFill>
+            </a:endParaRPr>
           </a:p>
         </p:txBody>
       </p:sp>
     </p:spTree>
     <p:extLst>
       <p:ext uri="{BB962C8B-B14F-4D97-AF65-F5344CB8AC3E}">
-        <p14:creationId xmlns:p14="http://schemas.microsoft.com/office/powerpoint/2010/main" val="1840726560"/>
+        <p14:creationId xmlns:p14="http://schemas.microsoft.com/office/powerpoint/2010/main" val="3540895647"/>
       </p:ext>
     </p:extLst>
   </p:cSld>
@@ -3417,15 +3580,15 @@
         </p:nvSpPr>
         <p:spPr>
           <a:xfrm>
-            <a:off x="1792288" y="4800600"/>
-            <a:ext cx="5486400" cy="566738"/>
+            <a:off x="1792288" y="3600450"/>
+            <a:ext cx="5486400" cy="425054"/>
           </a:xfrm>
         </p:spPr>
         <p:txBody>
           <a:bodyPr anchor="b"/>
           <a:lstStyle>
             <a:lvl1pPr algn="l">
-              <a:defRPr sz="2000" b="1">
+              <a:defRPr sz="1500" b="1">
                 <a:solidFill>
                   <a:srgbClr val="111111"/>
                 </a:solidFill>
@@ -3434,14 +3597,13 @@
           </a:lstStyle>
           <a:p>
             <a:r>
-              <a:rPr lang="en-US" smtClean="0">
+              <a:rPr lang="en-US">
                 <a:solidFill>
                   <a:srgbClr val="111111"/>
                 </a:solidFill>
               </a:rPr>
               <a:t>Click to edit Master title style</a:t>
             </a:r>
-            <a:endParaRPr lang="en-US"/>
           </a:p>
         </p:txBody>
       </p:sp>
@@ -3457,8 +3619,8 @@
         </p:nvSpPr>
         <p:spPr>
           <a:xfrm>
-            <a:off x="1792288" y="612775"/>
-            <a:ext cx="5486400" cy="4114800"/>
+            <a:off x="1792288" y="459581"/>
+            <a:ext cx="5486400" cy="3086100"/>
           </a:xfrm>
         </p:spPr>
         <p:txBody>
@@ -3466,71 +3628,71 @@
           <a:lstStyle>
             <a:lvl1pPr marL="0" indent="0">
               <a:buNone/>
-              <a:defRPr sz="3200">
+              <a:defRPr sz="2400">
                 <a:solidFill>
                   <a:srgbClr val="111111"/>
                 </a:solidFill>
               </a:defRPr>
             </a:lvl1pPr>
-            <a:lvl2pPr marL="457200" indent="0">
+            <a:lvl2pPr marL="342900" indent="0">
               <a:buNone/>
-              <a:defRPr sz="2800">
+              <a:defRPr sz="2100">
                 <a:solidFill>
                   <a:srgbClr val="111111"/>
                 </a:solidFill>
               </a:defRPr>
             </a:lvl2pPr>
-            <a:lvl3pPr marL="914400" indent="0">
+            <a:lvl3pPr marL="685800" indent="0">
               <a:buNone/>
-              <a:defRPr sz="2400">
+              <a:defRPr sz="1800">
                 <a:solidFill>
                   <a:srgbClr val="111111"/>
                 </a:solidFill>
               </a:defRPr>
             </a:lvl3pPr>
-            <a:lvl4pPr marL="1371600" indent="0">
+            <a:lvl4pPr marL="1028700" indent="0">
               <a:buNone/>
-              <a:defRPr sz="2000">
+              <a:defRPr sz="1500">
                 <a:solidFill>
                   <a:srgbClr val="111111"/>
                 </a:solidFill>
               </a:defRPr>
             </a:lvl4pPr>
-            <a:lvl5pPr marL="1828800" indent="0">
+            <a:lvl5pPr marL="1371600" indent="0">
               <a:buNone/>
-              <a:defRPr sz="2000">
+              <a:defRPr sz="1500">
                 <a:solidFill>
                   <a:srgbClr val="111111"/>
                 </a:solidFill>
               </a:defRPr>
             </a:lvl5pPr>
-            <a:lvl6pPr marL="2286000" indent="0">
+            <a:lvl6pPr marL="1714500" indent="0">
               <a:buNone/>
-              <a:defRPr sz="2000">
+              <a:defRPr sz="1500">
                 <a:solidFill>
                   <a:srgbClr val="111111"/>
                 </a:solidFill>
               </a:defRPr>
             </a:lvl6pPr>
-            <a:lvl7pPr marL="2743200" indent="0">
+            <a:lvl7pPr marL="2057400" indent="0">
               <a:buNone/>
-              <a:defRPr sz="2000">
+              <a:defRPr sz="1500">
                 <a:solidFill>
                   <a:srgbClr val="111111"/>
                 </a:solidFill>
               </a:defRPr>
             </a:lvl7pPr>
-            <a:lvl8pPr marL="3200400" indent="0">
+            <a:lvl8pPr marL="2400300" indent="0">
               <a:buNone/>
-              <a:defRPr sz="2000">
+              <a:defRPr sz="1500">
                 <a:solidFill>
                   <a:srgbClr val="111111"/>
                 </a:solidFill>
               </a:defRPr>
             </a:lvl8pPr>
-            <a:lvl9pPr marL="3657600" indent="0">
+            <a:lvl9pPr marL="2743200" indent="0">
               <a:buNone/>
-              <a:defRPr sz="2000">
+              <a:defRPr sz="1500">
                 <a:solidFill>
                   <a:srgbClr val="111111"/>
                 </a:solidFill>
@@ -3538,7 +3700,11 @@
             </a:lvl9pPr>
           </a:lstStyle>
           <a:p>
-            <a:endParaRPr lang="en-US"/>
+            <a:endParaRPr lang="en-US">
+              <a:solidFill>
+                <a:srgbClr val="111111"/>
+              </a:solidFill>
+            </a:endParaRPr>
           </a:p>
         </p:txBody>
       </p:sp>
@@ -3554,8 +3720,8 @@
         </p:nvSpPr>
         <p:spPr>
           <a:xfrm>
-            <a:off x="1792288" y="5367338"/>
-            <a:ext cx="5486400" cy="804862"/>
+            <a:off x="1792288" y="4025503"/>
+            <a:ext cx="5486400" cy="603647"/>
           </a:xfrm>
         </p:spPr>
         <p:txBody>
@@ -3563,71 +3729,71 @@
           <a:lstStyle>
             <a:lvl1pPr marL="0" indent="0">
               <a:buNone/>
-              <a:defRPr sz="1400">
+              <a:defRPr sz="1050">
                 <a:solidFill>
                   <a:srgbClr val="111111"/>
                 </a:solidFill>
               </a:defRPr>
             </a:lvl1pPr>
-            <a:lvl2pPr marL="457200" indent="0">
+            <a:lvl2pPr marL="342900" indent="0">
               <a:buNone/>
-              <a:defRPr sz="1200">
+              <a:defRPr sz="900">
                 <a:solidFill>
                   <a:srgbClr val="111111"/>
                 </a:solidFill>
               </a:defRPr>
             </a:lvl2pPr>
-            <a:lvl3pPr marL="914400" indent="0">
+            <a:lvl3pPr marL="685800" indent="0">
               <a:buNone/>
-              <a:defRPr sz="1000">
+              <a:defRPr sz="750">
                 <a:solidFill>
                   <a:srgbClr val="111111"/>
                 </a:solidFill>
               </a:defRPr>
             </a:lvl3pPr>
-            <a:lvl4pPr marL="1371600" indent="0">
+            <a:lvl4pPr marL="1028700" indent="0">
               <a:buNone/>
-              <a:defRPr sz="900">
+              <a:defRPr sz="675">
                 <a:solidFill>
                   <a:srgbClr val="111111"/>
                 </a:solidFill>
               </a:defRPr>
             </a:lvl4pPr>
-            <a:lvl5pPr marL="1828800" indent="0">
+            <a:lvl5pPr marL="1371600" indent="0">
               <a:buNone/>
-              <a:defRPr sz="900">
+              <a:defRPr sz="675">
                 <a:solidFill>
                   <a:srgbClr val="111111"/>
                 </a:solidFill>
               </a:defRPr>
             </a:lvl5pPr>
-            <a:lvl6pPr marL="2286000" indent="0">
+            <a:lvl6pPr marL="1714500" indent="0">
               <a:buNone/>
-              <a:defRPr sz="900">
+              <a:defRPr sz="675">
                 <a:solidFill>
                   <a:srgbClr val="111111"/>
                 </a:solidFill>
               </a:defRPr>
             </a:lvl6pPr>
-            <a:lvl7pPr marL="2743200" indent="0">
+            <a:lvl7pPr marL="2057400" indent="0">
               <a:buNone/>
-              <a:defRPr sz="900">
+              <a:defRPr sz="675">
                 <a:solidFill>
                   <a:srgbClr val="111111"/>
                 </a:solidFill>
               </a:defRPr>
             </a:lvl7pPr>
-            <a:lvl8pPr marL="3200400" indent="0">
+            <a:lvl8pPr marL="2400300" indent="0">
               <a:buNone/>
-              <a:defRPr sz="900">
+              <a:defRPr sz="675">
                 <a:solidFill>
                   <a:srgbClr val="111111"/>
                 </a:solidFill>
               </a:defRPr>
             </a:lvl8pPr>
-            <a:lvl9pPr marL="3657600" indent="0">
+            <a:lvl9pPr marL="2743200" indent="0">
               <a:buNone/>
-              <a:defRPr sz="900">
+              <a:defRPr sz="675">
                 <a:solidFill>
                   <a:srgbClr val="111111"/>
                 </a:solidFill>
@@ -3637,7 +3803,7 @@
           <a:p>
             <a:pPr lvl="0"/>
             <a:r>
-              <a:rPr lang="en-US" smtClean="0">
+              <a:rPr lang="en-US">
                 <a:solidFill>
                   <a:srgbClr val="111111"/>
                 </a:solidFill>
@@ -3662,15 +3828,19 @@
           <a:bodyPr/>
           <a:lstStyle/>
           <a:p>
-            <a:fld id="{5BCAD085-E8A6-8845-BD4E-CB4CCA059FC4}" type="datetimeFigureOut">
+            <a:fld id="{241EB5C9-1307-BA42-ABA2-0BC069CD8E7F}" type="datetimeFigureOut">
               <a:rPr lang="en-US" smtClean="0">
                 <a:solidFill>
                   <a:srgbClr val="111111"/>
                 </a:solidFill>
               </a:rPr>
-              <a:t>1/27/13</a:t>
+              <a:t>1/2/22</a:t>
             </a:fld>
-            <a:endParaRPr lang="en-US"/>
+            <a:endParaRPr lang="en-US">
+              <a:solidFill>
+                <a:srgbClr val="111111"/>
+              </a:solidFill>
+            </a:endParaRPr>
           </a:p>
         </p:txBody>
       </p:sp>
@@ -3689,7 +3859,11 @@
           <a:bodyPr/>
           <a:lstStyle/>
           <a:p>
-            <a:endParaRPr lang="en-US"/>
+            <a:endParaRPr lang="en-US">
+              <a:solidFill>
+                <a:srgbClr val="111111"/>
+              </a:solidFill>
+            </a:endParaRPr>
           </a:p>
         </p:txBody>
       </p:sp>
@@ -3708,7 +3882,7 @@
           <a:bodyPr/>
           <a:lstStyle/>
           <a:p>
-            <a:fld id="{C1FF6DA9-008F-8B48-92A6-B652298478BF}" type="slidenum">
+            <a:fld id="{C5EF2332-01BF-834F-8236-50238282D533}" type="slidenum">
               <a:rPr lang="en-US" smtClean="0">
                 <a:solidFill>
                   <a:srgbClr val="111111"/>
@@ -3716,14 +3890,18 @@
               </a:rPr>
               <a:t>‹#›</a:t>
             </a:fld>
-            <a:endParaRPr lang="en-US"/>
+            <a:endParaRPr lang="en-US">
+              <a:solidFill>
+                <a:srgbClr val="111111"/>
+              </a:solidFill>
+            </a:endParaRPr>
           </a:p>
         </p:txBody>
       </p:sp>
     </p:spTree>
     <p:extLst>
       <p:ext uri="{BB962C8B-B14F-4D97-AF65-F5344CB8AC3E}">
-        <p14:creationId xmlns:p14="http://schemas.microsoft.com/office/powerpoint/2010/main" val="3889236939"/>
+        <p14:creationId xmlns:p14="http://schemas.microsoft.com/office/powerpoint/2010/main" val="3566899855"/>
       </p:ext>
     </p:extLst>
   </p:cSld>
@@ -3737,12 +3915,9 @@
 <p:sldMaster xmlns:a="http://schemas.openxmlformats.org/drawingml/2006/main" xmlns:p="http://schemas.openxmlformats.org/presentationml/2006/main" xmlns:r="http://schemas.openxmlformats.org/officeDocument/2006/relationships">
   <p:cSld>
     <p:bg>
-      <p:bgPr>
-        <a:solidFill>
-          <a:srgbClr val="FFFFFF"/>
-        </a:solidFill>
-        <a:effectLst/>
-      </p:bgPr>
+      <p:bgRef idx="1001">
+        <a:schemeClr val="bg1"/>
+      </p:bgRef>
     </p:bg>
     <p:spTree>
       <p:nvGrpSpPr>
@@ -3770,8 +3945,8 @@
         </p:nvSpPr>
         <p:spPr>
           <a:xfrm>
-            <a:off x="457200" y="274638"/>
-            <a:ext cx="8229600" cy="1143000"/>
+            <a:off x="457200" y="205979"/>
+            <a:ext cx="8229600" cy="857250"/>
           </a:xfrm>
           <a:prstGeom prst="rect">
             <a:avLst/>
@@ -3784,14 +3959,13 @@
           <a:lstStyle/>
           <a:p>
             <a:r>
-              <a:rPr lang="en-US" smtClean="0">
+              <a:rPr lang="en-US">
                 <a:solidFill>
                   <a:srgbClr val="111111"/>
                 </a:solidFill>
               </a:rPr>
               <a:t>Click to edit Master title style</a:t>
             </a:r>
-            <a:endParaRPr lang="en-US"/>
           </a:p>
         </p:txBody>
       </p:sp>
@@ -3807,8 +3981,8 @@
         </p:nvSpPr>
         <p:spPr>
           <a:xfrm>
-            <a:off x="457200" y="1600200"/>
-            <a:ext cx="8229600" cy="4525963"/>
+            <a:off x="457200" y="1200151"/>
+            <a:ext cx="8229600" cy="3394472"/>
           </a:xfrm>
           <a:prstGeom prst="rect">
             <a:avLst/>
@@ -3822,7 +3996,7 @@
           <a:p>
             <a:pPr lvl="0"/>
             <a:r>
-              <a:rPr lang="en-US" smtClean="0">
+              <a:rPr lang="en-US">
                 <a:solidFill>
                   <a:srgbClr val="111111"/>
                 </a:solidFill>
@@ -3833,7 +4007,7 @@
           <a:p>
             <a:pPr lvl="1"/>
             <a:r>
-              <a:rPr lang="en-US" smtClean="0">
+              <a:rPr lang="en-US">
                 <a:solidFill>
                   <a:srgbClr val="111111"/>
                 </a:solidFill>
@@ -3844,7 +4018,7 @@
           <a:p>
             <a:pPr lvl="2"/>
             <a:r>
-              <a:rPr lang="en-US" smtClean="0">
+              <a:rPr lang="en-US">
                 <a:solidFill>
                   <a:srgbClr val="111111"/>
                 </a:solidFill>
@@ -3855,7 +4029,7 @@
           <a:p>
             <a:pPr lvl="3"/>
             <a:r>
-              <a:rPr lang="en-US" smtClean="0">
+              <a:rPr lang="en-US">
                 <a:solidFill>
                   <a:srgbClr val="111111"/>
                 </a:solidFill>
@@ -3866,14 +4040,13 @@
           <a:p>
             <a:pPr lvl="4"/>
             <a:r>
-              <a:rPr lang="en-US" smtClean="0">
+              <a:rPr lang="en-US">
                 <a:solidFill>
                   <a:srgbClr val="111111"/>
                 </a:solidFill>
               </a:rPr>
               <a:t>Fifth level</a:t>
             </a:r>
-            <a:endParaRPr lang="en-US"/>
           </a:p>
         </p:txBody>
       </p:sp>
@@ -3889,8 +4062,8 @@
         </p:nvSpPr>
         <p:spPr>
           <a:xfrm>
-            <a:off x="457200" y="6356350"/>
-            <a:ext cx="2133600" cy="365125"/>
+            <a:off x="457200" y="4767263"/>
+            <a:ext cx="2133600" cy="273844"/>
           </a:xfrm>
           <a:prstGeom prst="rect">
             <a:avLst/>
@@ -3900,7 +4073,7 @@
           <a:bodyPr anchor="ctr" bIns="45720" lIns="91440" rIns="91440" rtlCol="0" tIns="45720" vert="horz"/>
           <a:lstStyle>
             <a:lvl1pPr algn="l">
-              <a:defRPr sz="1200">
+              <a:defRPr sz="900">
                 <a:solidFill>
                   <a:srgbClr val="111111"/>
                 </a:solidFill>
@@ -3908,15 +4081,19 @@
             </a:lvl1pPr>
           </a:lstStyle>
           <a:p>
-            <a:fld id="{5BCAD085-E8A6-8845-BD4E-CB4CCA059FC4}" type="datetimeFigureOut">
+            <a:fld id="{241EB5C9-1307-BA42-ABA2-0BC069CD8E7F}" type="datetimeFigureOut">
               <a:rPr lang="en-US" smtClean="0">
                 <a:solidFill>
                   <a:srgbClr val="111111"/>
                 </a:solidFill>
               </a:rPr>
-              <a:t>1/27/13</a:t>
+              <a:t>1/2/22</a:t>
             </a:fld>
-            <a:endParaRPr lang="en-US"/>
+            <a:endParaRPr lang="en-US">
+              <a:solidFill>
+                <a:srgbClr val="111111"/>
+              </a:solidFill>
+            </a:endParaRPr>
           </a:p>
         </p:txBody>
       </p:sp>
@@ -3932,8 +4109,8 @@
         </p:nvSpPr>
         <p:spPr>
           <a:xfrm>
-            <a:off x="3124200" y="6356350"/>
-            <a:ext cx="2895600" cy="365125"/>
+            <a:off x="3124200" y="4767263"/>
+            <a:ext cx="2895600" cy="273844"/>
           </a:xfrm>
           <a:prstGeom prst="rect">
             <a:avLst/>
@@ -3943,7 +4120,7 @@
           <a:bodyPr anchor="ctr" bIns="45720" lIns="91440" rIns="91440" rtlCol="0" tIns="45720" vert="horz"/>
           <a:lstStyle>
             <a:lvl1pPr algn="ctr">
-              <a:defRPr sz="1200">
+              <a:defRPr sz="900">
                 <a:solidFill>
                   <a:srgbClr val="111111"/>
                 </a:solidFill>
@@ -3951,7 +4128,11 @@
             </a:lvl1pPr>
           </a:lstStyle>
           <a:p>
-            <a:endParaRPr lang="en-US"/>
+            <a:endParaRPr lang="en-US">
+              <a:solidFill>
+                <a:srgbClr val="111111"/>
+              </a:solidFill>
+            </a:endParaRPr>
           </a:p>
         </p:txBody>
       </p:sp>
@@ -3967,8 +4148,8 @@
         </p:nvSpPr>
         <p:spPr>
           <a:xfrm>
-            <a:off x="6553200" y="6356350"/>
-            <a:ext cx="2133600" cy="365125"/>
+            <a:off x="6553200" y="4767263"/>
+            <a:ext cx="2133600" cy="273844"/>
           </a:xfrm>
           <a:prstGeom prst="rect">
             <a:avLst/>
@@ -3978,7 +4159,7 @@
           <a:bodyPr anchor="ctr" bIns="45720" lIns="91440" rIns="91440" rtlCol="0" tIns="45720" vert="horz"/>
           <a:lstStyle>
             <a:lvl1pPr algn="r">
-              <a:defRPr sz="1200">
+              <a:defRPr sz="900">
                 <a:solidFill>
                   <a:srgbClr val="111111"/>
                 </a:solidFill>
@@ -3986,7 +4167,7 @@
             </a:lvl1pPr>
           </a:lstStyle>
           <a:p>
-            <a:fld id="{C1FF6DA9-008F-8B48-92A6-B652298478BF}" type="slidenum">
+            <a:fld id="{C5EF2332-01BF-834F-8236-50238282D533}" type="slidenum">
               <a:rPr lang="en-US" smtClean="0">
                 <a:solidFill>
                   <a:srgbClr val="111111"/>
@@ -3994,14 +4175,18 @@
               </a:rPr>
               <a:t>‹#›</a:t>
             </a:fld>
-            <a:endParaRPr lang="en-US"/>
+            <a:endParaRPr lang="en-US">
+              <a:solidFill>
+                <a:srgbClr val="111111"/>
+              </a:solidFill>
+            </a:endParaRPr>
           </a:p>
         </p:txBody>
       </p:sp>
     </p:spTree>
     <p:extLst>
       <p:ext uri="{BB962C8B-B14F-4D97-AF65-F5344CB8AC3E}">
-        <p14:creationId xmlns:p14="http://schemas.microsoft.com/office/powerpoint/2010/main" val="2209977519"/>
+        <p14:creationId xmlns:p14="http://schemas.microsoft.com/office/powerpoint/2010/main" val="3676200875"/>
       </p:ext>
     </p:extLst>
   </p:cSld>
@@ -4021,12 +4206,12 @@
   </p:sldLayoutIdLst>
   <p:txStyles>
     <p:titleStyle>
-      <a:lvl1pPr algn="ctr" defTabSz="457200" eaLnBrk="1" hangingPunct="1" latinLnBrk="0" rtl="0">
+      <a:lvl1pPr algn="ctr" defTabSz="342900" eaLnBrk="1" hangingPunct="1" latinLnBrk="0" rtl="0">
         <a:spcBef>
           <a:spcPct val="0"/>
         </a:spcBef>
         <a:buNone/>
-        <a:defRPr kern="1200" sz="4400">
+        <a:defRPr kern="1200" sz="3300">
           <a:latin typeface="Cambria"/>
           <a:ea typeface="+mj-ea"/>
           <a:cs typeface="+mj-cs"/>
@@ -4037,37 +4222,7 @@
       </a:lvl1pPr>
     </p:titleStyle>
     <p:bodyStyle>
-      <a:lvl1pPr algn="l" defTabSz="457200" eaLnBrk="1" hangingPunct="1" indent="-342900" latinLnBrk="0" marL="342900" rtl="0">
-        <a:spcBef>
-          <a:spcPct val="20000"/>
-        </a:spcBef>
-        <a:buFont typeface="Arial"/>
-        <a:buChar char="•"/>
-        <a:defRPr kern="1200" sz="3200">
-          <a:latin typeface="Cambria"/>
-          <a:ea typeface="+mn-ea"/>
-          <a:cs typeface="+mn-cs"/>
-          <a:solidFill>
-            <a:srgbClr val="111111"/>
-          </a:solidFill>
-        </a:defRPr>
-      </a:lvl1pPr>
-      <a:lvl2pPr algn="l" defTabSz="457200" eaLnBrk="1" hangingPunct="1" indent="-285750" latinLnBrk="0" marL="742950" rtl="0">
-        <a:spcBef>
-          <a:spcPct val="20000"/>
-        </a:spcBef>
-        <a:buFont typeface="Arial"/>
-        <a:buChar char="–"/>
-        <a:defRPr kern="1200" sz="2800">
-          <a:latin typeface="Cambria"/>
-          <a:ea typeface="+mn-ea"/>
-          <a:cs typeface="+mn-cs"/>
-          <a:solidFill>
-            <a:srgbClr val="111111"/>
-          </a:solidFill>
-        </a:defRPr>
-      </a:lvl2pPr>
-      <a:lvl3pPr algn="l" defTabSz="457200" eaLnBrk="1" hangingPunct="1" indent="-228600" latinLnBrk="0" marL="1143000" rtl="0">
+      <a:lvl1pPr algn="l" defTabSz="342900" eaLnBrk="1" hangingPunct="1" indent="-342900" latinLnBrk="0" marL="342900" rtl="0">
         <a:spcBef>
           <a:spcPct val="20000"/>
         </a:spcBef>
@@ -4081,14 +4236,44 @@
             <a:srgbClr val="111111"/>
           </a:solidFill>
         </a:defRPr>
-      </a:lvl3pPr>
-      <a:lvl4pPr algn="l" defTabSz="457200" eaLnBrk="1" hangingPunct="1" indent="-228600" latinLnBrk="0" marL="1600200" rtl="0">
+      </a:lvl1pPr>
+      <a:lvl2pPr algn="l" defTabSz="342900" eaLnBrk="1" hangingPunct="1" indent="-342900" latinLnBrk="0" marL="685800" rtl="0">
         <a:spcBef>
           <a:spcPct val="20000"/>
         </a:spcBef>
         <a:buFont typeface="Arial"/>
         <a:buChar char="–"/>
-        <a:defRPr kern="1200" sz="2000">
+        <a:defRPr kern="1200" sz="2100">
+          <a:latin typeface="Cambria"/>
+          <a:ea typeface="+mn-ea"/>
+          <a:cs typeface="+mn-cs"/>
+          <a:solidFill>
+            <a:srgbClr val="111111"/>
+          </a:solidFill>
+        </a:defRPr>
+      </a:lvl2pPr>
+      <a:lvl3pPr algn="l" defTabSz="342900" eaLnBrk="1" hangingPunct="1" indent="-342900" latinLnBrk="0" marL="1028700" rtl="0">
+        <a:spcBef>
+          <a:spcPct val="20000"/>
+        </a:spcBef>
+        <a:buFont typeface="Arial"/>
+        <a:buChar char="•"/>
+        <a:defRPr kern="1200" sz="1800">
+          <a:latin typeface="Cambria"/>
+          <a:ea typeface="+mn-ea"/>
+          <a:cs typeface="+mn-cs"/>
+          <a:solidFill>
+            <a:srgbClr val="111111"/>
+          </a:solidFill>
+        </a:defRPr>
+      </a:lvl3pPr>
+      <a:lvl4pPr algn="l" defTabSz="342900" eaLnBrk="1" hangingPunct="1" indent="-342900" latinLnBrk="0" marL="1371600" rtl="0">
+        <a:spcBef>
+          <a:spcPct val="20000"/>
+        </a:spcBef>
+        <a:buFont typeface="Arial"/>
+        <a:buChar char="–"/>
+        <a:defRPr kern="1200" sz="1500">
           <a:latin typeface="Cambria"/>
           <a:ea typeface="+mn-ea"/>
           <a:cs typeface="+mn-cs"/>
@@ -4097,13 +4282,13 @@
           </a:solidFill>
         </a:defRPr>
       </a:lvl4pPr>
-      <a:lvl5pPr algn="l" defTabSz="457200" eaLnBrk="1" hangingPunct="1" indent="-228600" latinLnBrk="0" marL="2057400" rtl="0">
+      <a:lvl5pPr algn="l" defTabSz="342900" eaLnBrk="1" hangingPunct="1" indent="-342900" latinLnBrk="0" marL="1714500" rtl="0">
         <a:spcBef>
           <a:spcPct val="20000"/>
         </a:spcBef>
         <a:buFont typeface="Arial"/>
         <a:buChar char="»"/>
-        <a:defRPr kern="1200" sz="2000">
+        <a:defRPr kern="1200" sz="1500">
           <a:latin typeface="Cambria"/>
           <a:ea typeface="+mn-ea"/>
           <a:cs typeface="+mn-cs"/>
@@ -4112,13 +4297,13 @@
           </a:solidFill>
         </a:defRPr>
       </a:lvl5pPr>
-      <a:lvl6pPr algn="l" defTabSz="457200" eaLnBrk="1" hangingPunct="1" indent="-228600" latinLnBrk="0" marL="2514600" rtl="0">
+      <a:lvl6pPr algn="l" defTabSz="342900" eaLnBrk="1" hangingPunct="1" indent="-342900" latinLnBrk="0" marL="2057400" rtl="0">
         <a:spcBef>
           <a:spcPct val="20000"/>
         </a:spcBef>
         <a:buFont typeface="Arial"/>
         <a:buChar char="•"/>
-        <a:defRPr kern="1200" sz="2000">
+        <a:defRPr kern="1200" sz="1500">
           <a:latin typeface="Cambria"/>
           <a:ea typeface="+mn-ea"/>
           <a:cs typeface="+mn-cs"/>
@@ -4127,13 +4312,13 @@
           </a:solidFill>
         </a:defRPr>
       </a:lvl6pPr>
-      <a:lvl7pPr algn="l" defTabSz="457200" eaLnBrk="1" hangingPunct="1" indent="-228600" latinLnBrk="0" marL="2971800" rtl="0">
+      <a:lvl7pPr algn="l" defTabSz="342900" eaLnBrk="1" hangingPunct="1" indent="-342900" latinLnBrk="0" marL="2400300" rtl="0">
         <a:spcBef>
           <a:spcPct val="20000"/>
         </a:spcBef>
         <a:buFont typeface="Arial"/>
         <a:buChar char="•"/>
-        <a:defRPr kern="1200" sz="2000">
+        <a:defRPr kern="1200" sz="1500">
           <a:latin typeface="Cambria"/>
           <a:ea typeface="+mn-ea"/>
           <a:cs typeface="+mn-cs"/>
@@ -4142,13 +4327,13 @@
           </a:solidFill>
         </a:defRPr>
       </a:lvl7pPr>
-      <a:lvl8pPr algn="l" defTabSz="457200" eaLnBrk="1" hangingPunct="1" indent="-228600" latinLnBrk="0" marL="3429000" rtl="0">
+      <a:lvl8pPr algn="l" defTabSz="342900" eaLnBrk="1" hangingPunct="1" indent="-342900" latinLnBrk="0" marL="2743200" rtl="0">
         <a:spcBef>
           <a:spcPct val="20000"/>
         </a:spcBef>
         <a:buFont typeface="Arial"/>
         <a:buChar char="•"/>
-        <a:defRPr kern="1200" sz="2000">
+        <a:defRPr kern="1200" sz="1500">
           <a:latin typeface="Cambria"/>
           <a:ea typeface="+mn-ea"/>
           <a:cs typeface="+mn-cs"/>
@@ -4157,13 +4342,13 @@
           </a:solidFill>
         </a:defRPr>
       </a:lvl8pPr>
-      <a:lvl9pPr algn="l" defTabSz="457200" eaLnBrk="1" hangingPunct="1" indent="-228600" latinLnBrk="0" marL="3886200" rtl="0">
+      <a:lvl9pPr algn="l" defTabSz="342900" eaLnBrk="1" hangingPunct="1" indent="-342900" latinLnBrk="0" marL="3086100" rtl="0">
         <a:spcBef>
           <a:spcPct val="20000"/>
         </a:spcBef>
         <a:buFont typeface="Arial"/>
         <a:buChar char="•"/>
-        <a:defRPr kern="1200" sz="2000">
+        <a:defRPr kern="1200" sz="1500">
           <a:latin typeface="Cambria"/>
           <a:ea typeface="+mn-ea"/>
           <a:cs typeface="+mn-cs"/>
@@ -4181,8 +4366,8 @@
           </a:solidFill>
         </a:defRPr>
       </a:defPPr>
-      <a:lvl1pPr algn="l" defTabSz="457200" eaLnBrk="1" hangingPunct="1" latinLnBrk="0" marL="0" rtl="0">
-        <a:defRPr kern="1200" sz="1800">
+      <a:lvl1pPr algn="l" defTabSz="342900" eaLnBrk="1" hangingPunct="1" latinLnBrk="0" marL="0" rtl="0">
+        <a:defRPr kern="1200" sz="1350">
           <a:latin typeface="Cambria"/>
           <a:ea typeface="+mn-ea"/>
           <a:cs typeface="+mn-cs"/>
@@ -4191,8 +4376,8 @@
           </a:solidFill>
         </a:defRPr>
       </a:lvl1pPr>
-      <a:lvl2pPr algn="l" defTabSz="457200" eaLnBrk="1" hangingPunct="1" latinLnBrk="0" marL="457200" rtl="0">
-        <a:defRPr kern="1200" sz="1800">
+      <a:lvl2pPr algn="l" defTabSz="342900" eaLnBrk="1" hangingPunct="1" latinLnBrk="0" marL="342900" rtl="0">
+        <a:defRPr kern="1200" sz="1350">
           <a:latin typeface="Cambria"/>
           <a:ea typeface="+mn-ea"/>
           <a:cs typeface="+mn-cs"/>
@@ -4201,8 +4386,8 @@
           </a:solidFill>
         </a:defRPr>
       </a:lvl2pPr>
-      <a:lvl3pPr algn="l" defTabSz="457200" eaLnBrk="1" hangingPunct="1" latinLnBrk="0" marL="914400" rtl="0">
-        <a:defRPr kern="1200" sz="1800">
+      <a:lvl3pPr algn="l" defTabSz="342900" eaLnBrk="1" hangingPunct="1" latinLnBrk="0" marL="685800" rtl="0">
+        <a:defRPr kern="1200" sz="1350">
           <a:latin typeface="Cambria"/>
           <a:ea typeface="+mn-ea"/>
           <a:cs typeface="+mn-cs"/>
@@ -4211,8 +4396,8 @@
           </a:solidFill>
         </a:defRPr>
       </a:lvl3pPr>
-      <a:lvl4pPr algn="l" defTabSz="457200" eaLnBrk="1" hangingPunct="1" latinLnBrk="0" marL="1371600" rtl="0">
-        <a:defRPr kern="1200" sz="1800">
+      <a:lvl4pPr algn="l" defTabSz="342900" eaLnBrk="1" hangingPunct="1" latinLnBrk="0" marL="1028700" rtl="0">
+        <a:defRPr kern="1200" sz="1350">
           <a:latin typeface="Cambria"/>
           <a:ea typeface="+mn-ea"/>
           <a:cs typeface="+mn-cs"/>
@@ -4221,8 +4406,8 @@
           </a:solidFill>
         </a:defRPr>
       </a:lvl4pPr>
-      <a:lvl5pPr algn="l" defTabSz="457200" eaLnBrk="1" hangingPunct="1" latinLnBrk="0" marL="1828800" rtl="0">
-        <a:defRPr kern="1200" sz="1800">
+      <a:lvl5pPr algn="l" defTabSz="342900" eaLnBrk="1" hangingPunct="1" latinLnBrk="0" marL="1371600" rtl="0">
+        <a:defRPr kern="1200" sz="1350">
           <a:latin typeface="Cambria"/>
           <a:ea typeface="+mn-ea"/>
           <a:cs typeface="+mn-cs"/>
@@ -4231,8 +4416,8 @@
           </a:solidFill>
         </a:defRPr>
       </a:lvl5pPr>
-      <a:lvl6pPr algn="l" defTabSz="457200" eaLnBrk="1" hangingPunct="1" latinLnBrk="0" marL="2286000" rtl="0">
-        <a:defRPr kern="1200" sz="1800">
+      <a:lvl6pPr algn="l" defTabSz="342900" eaLnBrk="1" hangingPunct="1" latinLnBrk="0" marL="1714500" rtl="0">
+        <a:defRPr kern="1200" sz="1350">
           <a:latin typeface="Cambria"/>
           <a:ea typeface="+mn-ea"/>
           <a:cs typeface="+mn-cs"/>
@@ -4241,8 +4426,8 @@
           </a:solidFill>
         </a:defRPr>
       </a:lvl6pPr>
-      <a:lvl7pPr algn="l" defTabSz="457200" eaLnBrk="1" hangingPunct="1" latinLnBrk="0" marL="2743200" rtl="0">
-        <a:defRPr kern="1200" sz="1800">
+      <a:lvl7pPr algn="l" defTabSz="342900" eaLnBrk="1" hangingPunct="1" latinLnBrk="0" marL="2057400" rtl="0">
+        <a:defRPr kern="1200" sz="1350">
           <a:latin typeface="Cambria"/>
           <a:ea typeface="+mn-ea"/>
           <a:cs typeface="+mn-cs"/>
@@ -4251,8 +4436,8 @@
           </a:solidFill>
         </a:defRPr>
       </a:lvl7pPr>
-      <a:lvl8pPr algn="l" defTabSz="457200" eaLnBrk="1" hangingPunct="1" latinLnBrk="0" marL="3200400" rtl="0">
-        <a:defRPr kern="1200" sz="1800">
+      <a:lvl8pPr algn="l" defTabSz="342900" eaLnBrk="1" hangingPunct="1" latinLnBrk="0" marL="2400300" rtl="0">
+        <a:defRPr kern="1200" sz="1350">
           <a:latin typeface="Cambria"/>
           <a:ea typeface="+mn-ea"/>
           <a:cs typeface="+mn-cs"/>
@@ -4261,8 +4446,8 @@
           </a:solidFill>
         </a:defRPr>
       </a:lvl8pPr>
-      <a:lvl9pPr algn="l" defTabSz="457200" eaLnBrk="1" hangingPunct="1" latinLnBrk="0" marL="3657600" rtl="0">
-        <a:defRPr kern="1200" sz="1800">
+      <a:lvl9pPr algn="l" defTabSz="342900" eaLnBrk="1" hangingPunct="1" latinLnBrk="0" marL="2743200" rtl="0">
+        <a:defRPr kern="1200" sz="1350">
           <a:latin typeface="Cambria"/>
           <a:ea typeface="+mn-ea"/>
           <a:cs typeface="+mn-cs"/>
@@ -4305,8 +4490,8 @@
         </p:nvSpPr>
         <p:spPr>
           <a:xfrm>
-            <a:off x="685800" y="2130425"/>
-            <a:ext cx="7772400" cy="1470025"/>
+            <a:off x="685800" y="1597819"/>
+            <a:ext cx="7772400" cy="1102519"/>
           </a:xfrm>
         </p:spPr>
         <p:txBody>
@@ -4335,8 +4520,8 @@
         </p:nvSpPr>
         <p:spPr>
           <a:xfrm>
-            <a:off x="1371600" y="3886200"/>
-            <a:ext cx="6400800" cy="1752600"/>
+            <a:off x="1371600" y="2914650"/>
+            <a:ext cx="6400800" cy="1314450"/>
           </a:xfrm>
         </p:spPr>
         <p:txBody>
@@ -4765,7 +4950,7 @@
           <a:bodyPr/>
           <a:lstStyle/>
           <a:p>
-            <a:pPr lvl="0" indent="-457200" marL="457200">
+            <a:pPr lvl="0" indent="-342900" marL="342900">
               <a:buAutoNum type="arabicPeriod"/>
             </a:pPr>
             <a:r>
@@ -4792,7 +4977,7 @@
             </a:r>
           </a:p>
           <a:p>
-            <a:pPr lvl="0" indent="-457200" marL="457200">
+            <a:pPr lvl="0" indent="-342900" marL="342900">
               <a:buAutoNum type="arabicPeriod"/>
             </a:pPr>
             <a:r>
@@ -4809,7 +4994,7 @@
             </a:r>
           </a:p>
           <a:p>
-            <a:pPr lvl="0" indent="-457200" marL="457200">
+            <a:pPr lvl="0" indent="-342900" marL="342900">
               <a:buAutoNum type="arabicPeriod"/>
             </a:pPr>
             <a:r>
@@ -4836,7 +5021,7 @@
             </a:r>
           </a:p>
           <a:p>
-            <a:pPr lvl="0" indent="-457200" marL="457200">
+            <a:pPr lvl="0" indent="-342900" marL="342900">
               <a:buAutoNum type="arabicPeriod"/>
             </a:pPr>
             <a:r>
@@ -4863,7 +5048,7 @@
             </a:r>
           </a:p>
           <a:p>
-            <a:pPr lvl="0" indent="-457200" marL="457200">
+            <a:pPr lvl="0" indent="-342900" marL="342900">
               <a:buAutoNum type="arabicPeriod"/>
             </a:pPr>
             <a:r>
@@ -5222,7 +5407,7 @@
             </a:r>
           </a:p>
           <a:p>
-            <a:pPr lvl="0" indent="-457200" marL="457200">
+            <a:pPr lvl="0" indent="-342900" marL="342900">
               <a:buAutoNum type="arabicPeriod"/>
             </a:pPr>
             <a:r>
@@ -5235,7 +5420,7 @@
             </a:r>
           </a:p>
           <a:p>
-            <a:pPr lvl="0" indent="-457200" marL="457200">
+            <a:pPr lvl="0" indent="-342900" marL="342900">
               <a:buAutoNum type="arabicPeriod"/>
             </a:pPr>
             <a:r>
@@ -5248,7 +5433,7 @@
             </a:r>
           </a:p>
           <a:p>
-            <a:pPr lvl="0" indent="-457200" marL="457200">
+            <a:pPr lvl="0" indent="-342900" marL="342900">
               <a:buAutoNum type="arabicPeriod"/>
             </a:pPr>
             <a:r>
@@ -5788,7 +5973,7 @@
             </a:r>
           </a:p>
           <a:p>
-            <a:pPr lvl="0" indent="-457200" marL="457200">
+            <a:pPr lvl="0" indent="-342900" marL="342900">
               <a:buAutoNum type="arabicPeriod"/>
             </a:pPr>
             <a:r>
@@ -5801,7 +5986,7 @@
             </a:r>
           </a:p>
           <a:p>
-            <a:pPr lvl="0" indent="-457200" marL="457200">
+            <a:pPr lvl="0" indent="-342900" marL="342900">
               <a:buAutoNum type="arabicPeriod"/>
             </a:pPr>
             <a:r>
@@ -5818,7 +6003,7 @@
             </a:r>
           </a:p>
           <a:p>
-            <a:pPr lvl="0" indent="-457200" marL="457200">
+            <a:pPr lvl="0" indent="-342900" marL="342900">
               <a:buAutoNum type="arabicPeriod"/>
             </a:pPr>
             <a:r>
@@ -5831,7 +6016,7 @@
             </a:r>
           </a:p>
           <a:p>
-            <a:pPr lvl="0" indent="-457200" marL="457200">
+            <a:pPr lvl="0" indent="-342900" marL="342900">
               <a:buAutoNum type="arabicPeriod"/>
             </a:pPr>
             <a:r>
@@ -6099,7 +6284,7 @@
             </a:r>
           </a:p>
           <a:p>
-            <a:pPr lvl="0" indent="-457200" marL="457200">
+            <a:pPr lvl="0" indent="-342900" marL="342900">
               <a:buAutoNum type="arabicPeriod"/>
             </a:pPr>
             <a:r>
@@ -6112,7 +6297,7 @@
             </a:r>
           </a:p>
           <a:p>
-            <a:pPr lvl="0" indent="-457200" marL="457200">
+            <a:pPr lvl="0" indent="-342900" marL="342900">
               <a:buAutoNum type="arabicPeriod"/>
             </a:pPr>
             <a:r>
@@ -6125,7 +6310,7 @@
             </a:r>
           </a:p>
           <a:p>
-            <a:pPr lvl="0" indent="-457200" marL="457200">
+            <a:pPr lvl="0" indent="-342900" marL="342900">
               <a:buAutoNum type="arabicPeriod"/>
             </a:pPr>
             <a:r>
@@ -6138,7 +6323,7 @@
             </a:r>
           </a:p>
           <a:p>
-            <a:pPr lvl="0" indent="-457200" marL="457200">
+            <a:pPr lvl="0" indent="-342900" marL="342900">
               <a:buAutoNum type="arabicPeriod"/>
             </a:pPr>
             <a:r>
@@ -6587,8 +6772,8 @@
         </p:nvSpPr>
         <p:spPr>
           <a:xfrm>
-            <a:off x="722313" y="4406900"/>
-            <a:ext cx="7772400" cy="1362075"/>
+            <a:off x="722313" y="3305176"/>
+            <a:ext cx="7772400" cy="1021556"/>
           </a:xfrm>
         </p:spPr>
         <p:txBody>
@@ -7034,7 +7219,7 @@
           <a:bodyPr/>
           <a:lstStyle/>
           <a:p>
-            <a:pPr lvl="0" indent="-457200" marL="457200">
+            <a:pPr lvl="0" indent="-342900" marL="342900">
               <a:buAutoNum type="arabicPeriod"/>
             </a:pPr>
             <a:r>
@@ -7068,7 +7253,7 @@
             </a:r>
           </a:p>
           <a:p>
-            <a:pPr lvl="0" indent="-457200" marL="457200">
+            <a:pPr lvl="0" indent="-342900" marL="342900">
               <a:buAutoNum type="arabicPeriod"/>
             </a:pPr>
             <a:r>
@@ -7091,7 +7276,7 @@
             </a:r>
           </a:p>
           <a:p>
-            <a:pPr lvl="0" indent="-457200" marL="457200">
+            <a:pPr lvl="0" indent="-342900" marL="342900">
               <a:buAutoNum type="arabicPeriod"/>
             </a:pPr>
             <a:r>
@@ -7112,7 +7297,7 @@
             </a:r>
           </a:p>
           <a:p>
-            <a:pPr lvl="0" indent="-457200" marL="457200">
+            <a:pPr lvl="0" indent="-342900" marL="342900">
               <a:buAutoNum type="arabicPeriod"/>
             </a:pPr>
             <a:r>
@@ -7655,7 +7840,7 @@
           <a:bodyPr/>
           <a:lstStyle/>
           <a:p>
-            <a:pPr lvl="0" indent="-457200" marL="457200">
+            <a:pPr lvl="0" indent="-342900" marL="342900">
               <a:buAutoNum type="arabicPeriod"/>
             </a:pPr>
             <a:r>
@@ -7668,7 +7853,7 @@
             </a:r>
           </a:p>
           <a:p>
-            <a:pPr lvl="0" indent="-457200" marL="457200">
+            <a:pPr lvl="0" indent="-342900" marL="342900">
               <a:buAutoNum type="arabicPeriod"/>
             </a:pPr>
             <a:r>
@@ -7681,7 +7866,7 @@
             </a:r>
           </a:p>
           <a:p>
-            <a:pPr lvl="0" indent="-457200" marL="457200">
+            <a:pPr lvl="0" indent="-342900" marL="342900">
               <a:buAutoNum type="arabicPeriod"/>
             </a:pPr>
             <a:r>
@@ -7694,7 +7879,7 @@
             </a:r>
           </a:p>
           <a:p>
-            <a:pPr lvl="0" indent="-457200" marL="457200">
+            <a:pPr lvl="0" indent="-342900" marL="342900">
               <a:buAutoNum type="arabicPeriod"/>
             </a:pPr>
             <a:r>
@@ -7715,7 +7900,7 @@
             </a:r>
           </a:p>
           <a:p>
-            <a:pPr lvl="0" indent="-457200" marL="457200">
+            <a:pPr lvl="0" indent="-342900" marL="342900">
               <a:buAutoNum type="arabicPeriod"/>
             </a:pPr>
             <a:r>
@@ -10766,8 +10951,8 @@
         </p:nvSpPr>
         <p:spPr>
           <a:xfrm>
-            <a:off x="722313" y="4406900"/>
-            <a:ext cx="7772400" cy="1362075"/>
+            <a:off x="722313" y="3305176"/>
+            <a:ext cx="7772400" cy="1021556"/>
           </a:xfrm>
         </p:spPr>
         <p:txBody>
@@ -14832,7 +15017,7 @@
           <a:bodyPr/>
           <a:lstStyle/>
           <a:p>
-            <a:pPr lvl="0" indent="-457200" marL="457200">
+            <a:pPr lvl="0" indent="-342900" marL="342900">
               <a:buAutoNum type="arabicPeriod"/>
             </a:pPr>
             <a:r>
@@ -14861,7 +15046,7 @@
             </a:r>
           </a:p>
           <a:p>
-            <a:pPr lvl="0" indent="-457200" marL="457200">
+            <a:pPr lvl="0" indent="-342900" marL="342900">
               <a:buAutoNum type="arabicPeriod"/>
             </a:pPr>
             <a:r>
@@ -14882,7 +15067,7 @@
             </a:r>
           </a:p>
           <a:p>
-            <a:pPr lvl="0" indent="-457200" marL="457200">
+            <a:pPr lvl="0" indent="-342900" marL="342900">
               <a:buAutoNum type="arabicPeriod"/>
             </a:pPr>
             <a:r>
@@ -14971,7 +15156,7 @@
             </a:r>
           </a:p>
           <a:p>
-            <a:pPr lvl="0" indent="-457200" marL="457200">
+            <a:pPr lvl="0" indent="-342900" marL="342900">
               <a:buAutoNum type="arabicPeriod"/>
             </a:pPr>
             <a:r>
@@ -14980,7 +15165,7 @@
             </a:r>
           </a:p>
           <a:p>
-            <a:pPr lvl="0" indent="-457200" marL="457200">
+            <a:pPr lvl="0" indent="-342900" marL="342900">
               <a:buAutoNum type="arabicPeriod"/>
             </a:pPr>
             <a:r>
@@ -14989,7 +15174,7 @@
             </a:r>
           </a:p>
           <a:p>
-            <a:pPr lvl="0" indent="-457200" marL="457200">
+            <a:pPr lvl="0" indent="-342900" marL="342900">
               <a:buAutoNum type="arabicPeriod"/>
             </a:pPr>
             <a:r>
@@ -15061,8 +15246,8 @@
         </p:nvSpPr>
         <p:spPr>
           <a:xfrm>
-            <a:off x="722313" y="4406900"/>
-            <a:ext cx="7772400" cy="1362075"/>
+            <a:off x="722313" y="3305176"/>
+            <a:ext cx="7772400" cy="1021556"/>
           </a:xfrm>
         </p:spPr>
         <p:txBody>
@@ -15605,7 +15790,7 @@
           <a:bodyPr/>
           <a:lstStyle/>
           <a:p>
-            <a:pPr lvl="0" indent="-457200" marL="457200">
+            <a:pPr lvl="0" indent="-342900" marL="342900">
               <a:buAutoNum type="arabicPeriod"/>
             </a:pPr>
             <a:r>
@@ -15628,7 +15813,7 @@
             </a:r>
           </a:p>
           <a:p>
-            <a:pPr lvl="0" indent="-457200" marL="457200">
+            <a:pPr lvl="0" indent="-342900" marL="342900">
               <a:buAutoNum type="arabicPeriod"/>
             </a:pPr>
             <a:r>
@@ -15637,7 +15822,7 @@
             </a:r>
           </a:p>
           <a:p>
-            <a:pPr lvl="1" indent="-457200" marL="914400">
+            <a:pPr lvl="1" indent="-342900" marL="685800">
               <a:buAutoNum type="arabicPeriod"/>
             </a:pPr>
             <a:r>
@@ -15656,7 +15841,7 @@
             </a:r>
           </a:p>
           <a:p>
-            <a:pPr lvl="1" indent="-457200" marL="914400">
+            <a:pPr lvl="1" indent="-342900" marL="685800">
               <a:buAutoNum type="arabicPeriod"/>
             </a:pPr>
             <a:r>
@@ -15673,7 +15858,7 @@
             </a:r>
           </a:p>
           <a:p>
-            <a:pPr lvl="1" indent="-457200" marL="914400">
+            <a:pPr lvl="1" indent="-342900" marL="685800">
               <a:buAutoNum type="arabicPeriod"/>
             </a:pPr>
             <a:r>
@@ -16099,8 +16284,8 @@
           </p:nvPr>
         </p:nvGraphicFramePr>
         <p:xfrm>
-          <a:off x="457200" y="1600200"/>
-          <a:ext cx="8229600" cy="4521200"/>
+          <a:off x="457200" y="1193800"/>
+          <a:ext cx="8229600" cy="3390900"/>
         </p:xfrm>
         <a:graphic>
           <a:graphicData uri="http://schemas.openxmlformats.org/drawingml/2006/table">
@@ -16272,8 +16457,8 @@
           </p:nvPr>
         </p:nvGraphicFramePr>
         <p:xfrm>
-          <a:off x="457200" y="1600200"/>
-          <a:ext cx="8229600" cy="4521200"/>
+          <a:off x="457200" y="1193800"/>
+          <a:ext cx="8229600" cy="3390900"/>
         </p:xfrm>
         <a:graphic>
           <a:graphicData uri="http://schemas.openxmlformats.org/drawingml/2006/table">
@@ -16661,7 +16846,7 @@
             </a:r>
           </a:p>
           <a:p>
-            <a:pPr lvl="1" indent="-457200" marL="914400">
+            <a:pPr lvl="1" indent="-342900" marL="685800">
               <a:buAutoNum type="arabicPeriod"/>
             </a:pPr>
             <a:r>
@@ -16680,7 +16865,7 @@
             </a:r>
           </a:p>
           <a:p>
-            <a:pPr lvl="1" indent="-457200" marL="914400">
+            <a:pPr lvl="1" indent="-342900" marL="685800">
               <a:buAutoNum type="arabicPeriod"/>
             </a:pPr>
             <a:r>
@@ -16909,8 +17094,8 @@
         </p:nvSpPr>
         <p:spPr>
           <a:xfrm>
-            <a:off x="722313" y="4406900"/>
-            <a:ext cx="7772400" cy="1362075"/>
+            <a:off x="722313" y="3305176"/>
+            <a:ext cx="7772400" cy="1021556"/>
           </a:xfrm>
         </p:spPr>
         <p:txBody>

</xml_diff>